<commit_message>
presentation: rebuild slide 7 as a light three-step evidence walkthrough
</commit_message>
<xml_diff>
--- a/presentation/LedgerLens_AI_Builder_Cup_Submission.pptx
+++ b/presentation/LedgerLens_AI_Builder_Cup_Submission.pptx
@@ -17229,18 +17229,272 @@
       </p:sp>
       <p:sp>
         <p:nvSpPr>
-          <p:cNvPr id="104" name="Rounded Rectangle 103"/>
+          <p:cNvPr id="104" name="TextBox 103"/>
+          <p:cNvSpPr txBox="1"/>
+          <p:nvPr/>
+        </p:nvSpPr>
+        <p:spPr>
+          <a:xfrm>
+            <a:off x="274320" y="1078992"/>
+            <a:ext cx="8595360" cy="274320"/>
+          </a:xfrm>
+          <a:prstGeom prst="rect">
+            <a:avLst/>
+          </a:prstGeom>
+          <a:noFill/>
+        </p:spPr>
+        <p:txBody>
+          <a:bodyPr wrap="square" anchor="t" lIns="45720" rIns="45720" tIns="27432" bIns="27432">
+            <a:spAutoFit/>
+          </a:bodyPr>
+          <a:lstStyle/>
+          <a:p>
+            <a:pPr algn="l"/>
+            <a:r>
+              <a:rPr sz="900" b="1" i="0">
+                <a:solidFill>
+                  <a:srgbClr val="2A7F8E"/>
+                </a:solidFill>
+                <a:latin typeface="Arial"/>
+              </a:rPr>
+              <a:t>THE PRODUCT IN ONE INTERACTION</a:t>
+            </a:r>
+          </a:p>
+        </p:txBody>
+      </p:sp>
+      <p:sp>
+        <p:nvSpPr>
+          <p:cNvPr id="105" name="TextBox 104"/>
+          <p:cNvSpPr txBox="1"/>
+          <p:nvPr/>
+        </p:nvSpPr>
+        <p:spPr>
+          <a:xfrm>
+            <a:off x="274320" y="1280160"/>
+            <a:ext cx="8595360" cy="457200"/>
+          </a:xfrm>
+          <a:prstGeom prst="rect">
+            <a:avLst/>
+          </a:prstGeom>
+          <a:noFill/>
+        </p:spPr>
+        <p:txBody>
+          <a:bodyPr wrap="square" anchor="t" lIns="0" rIns="0" tIns="27432" bIns="27432">
+            <a:spAutoFit/>
+          </a:bodyPr>
+          <a:lstStyle/>
+          <a:p>
+            <a:pPr algn="l"/>
+            <a:r>
+              <a:rPr sz="2600" b="1" i="0">
+                <a:solidFill>
+                  <a:srgbClr val="0F3D4C"/>
+                </a:solidFill>
+                <a:latin typeface="Arial"/>
+              </a:rPr>
+              <a:t>Click the number. See the line.</a:t>
+            </a:r>
+          </a:p>
+        </p:txBody>
+      </p:sp>
+      <p:pic>
+        <p:nvPicPr>
+          <p:cNvPr id="106" name="Picture 105" descr="v2_evidence_c.jpg"/>
+          <p:cNvPicPr>
+            <a:picLocks noChangeAspect="1"/>
+          </p:cNvPicPr>
+          <p:nvPr/>
+        </p:nvPicPr>
+        <p:blipFill>
+          <a:blip r:embed="rId5"/>
+          <a:stretch>
+            <a:fillRect/>
+          </a:stretch>
+        </p:blipFill>
+        <p:spPr>
+          <a:xfrm>
+            <a:off x="274320" y="1783080"/>
+            <a:ext cx="4271441" cy="3108960"/>
+          </a:xfrm>
+          <a:prstGeom prst="rect">
+            <a:avLst/>
+          </a:prstGeom>
+          <a:ln w="9525">
+            <a:solidFill>
+              <a:srgbClr val="D5DBDE"/>
+            </a:solidFill>
+          </a:ln>
+        </p:spPr>
+      </p:pic>
+      <p:sp>
+        <p:nvSpPr>
+          <p:cNvPr id="107" name="Rounded Rectangle 106"/>
           <p:cNvSpPr/>
           <p:nvPr/>
         </p:nvSpPr>
         <p:spPr>
           <a:xfrm>
-            <a:off x="274320" y="1143000"/>
-            <a:ext cx="8595360" cy="3840480"/>
+            <a:off x="1137434" y="2132539"/>
+            <a:ext cx="274320" cy="274320"/>
           </a:xfrm>
           <a:prstGeom prst="roundRect">
             <a:avLst>
-              <a:gd name="adj" fmla="val 4000"/>
+              <a:gd name="adj" fmla="val 50000"/>
+            </a:avLst>
+          </a:prstGeom>
+          <a:solidFill>
+            <a:srgbClr val="E0A100"/>
+          </a:solidFill>
+          <a:ln>
+            <a:noFill/>
+          </a:ln>
+          <a:effectLst/>
+        </p:spPr>
+        <p:txBody>
+          <a:bodyPr rtlCol="0" anchor="ctr" lIns="36576" rIns="36576" tIns="0" bIns="0"/>
+          <a:lstStyle/>
+          <a:p>
+            <a:pPr algn="ctr"/>
+            <a:r>
+              <a:rPr sz="1000" b="1">
+                <a:solidFill>
+                  <a:srgbClr val="0F3D4C"/>
+                </a:solidFill>
+                <a:latin typeface="Arial"/>
+              </a:rPr>
+              <a:t>1</a:t>
+            </a:r>
+          </a:p>
+        </p:txBody>
+      </p:sp>
+      <p:sp>
+        <p:nvSpPr>
+          <p:cNvPr id="108" name="Rounded Rectangle 107"/>
+          <p:cNvSpPr/>
+          <p:nvPr/>
+        </p:nvSpPr>
+        <p:spPr>
+          <a:xfrm>
+            <a:off x="2286397" y="2240677"/>
+            <a:ext cx="274320" cy="274320"/>
+          </a:xfrm>
+          <a:prstGeom prst="roundRect">
+            <a:avLst>
+              <a:gd name="adj" fmla="val 50000"/>
+            </a:avLst>
+          </a:prstGeom>
+          <a:solidFill>
+            <a:srgbClr val="E0A100"/>
+          </a:solidFill>
+          <a:ln>
+            <a:noFill/>
+          </a:ln>
+          <a:effectLst/>
+        </p:spPr>
+        <p:txBody>
+          <a:bodyPr rtlCol="0" anchor="ctr" lIns="36576" rIns="36576" tIns="0" bIns="0"/>
+          <a:lstStyle/>
+          <a:p>
+            <a:pPr algn="ctr"/>
+            <a:r>
+              <a:rPr sz="1000" b="1">
+                <a:solidFill>
+                  <a:srgbClr val="0F3D4C"/>
+                </a:solidFill>
+                <a:latin typeface="Arial"/>
+              </a:rPr>
+              <a:t>2</a:t>
+            </a:r>
+          </a:p>
+        </p:txBody>
+      </p:sp>
+      <p:sp>
+        <p:nvSpPr>
+          <p:cNvPr id="109" name="Rounded Rectangle 108"/>
+          <p:cNvSpPr/>
+          <p:nvPr/>
+        </p:nvSpPr>
+        <p:spPr>
+          <a:xfrm>
+            <a:off x="4138256" y="2443435"/>
+            <a:ext cx="274320" cy="274320"/>
+          </a:xfrm>
+          <a:prstGeom prst="roundRect">
+            <a:avLst>
+              <a:gd name="adj" fmla="val 50000"/>
+            </a:avLst>
+          </a:prstGeom>
+          <a:solidFill>
+            <a:srgbClr val="E0A100"/>
+          </a:solidFill>
+          <a:ln>
+            <a:noFill/>
+          </a:ln>
+          <a:effectLst/>
+        </p:spPr>
+        <p:txBody>
+          <a:bodyPr rtlCol="0" anchor="ctr" lIns="36576" rIns="36576" tIns="0" bIns="0"/>
+          <a:lstStyle/>
+          <a:p>
+            <a:pPr algn="ctr"/>
+            <a:r>
+              <a:rPr sz="1000" b="1">
+                <a:solidFill>
+                  <a:srgbClr val="0F3D4C"/>
+                </a:solidFill>
+                <a:latin typeface="Arial"/>
+              </a:rPr>
+              <a:t>3</a:t>
+            </a:r>
+          </a:p>
+        </p:txBody>
+      </p:sp>
+      <p:sp>
+        <p:nvSpPr>
+          <p:cNvPr id="110" name="Rounded Rectangle 109"/>
+          <p:cNvSpPr/>
+          <p:nvPr/>
+        </p:nvSpPr>
+        <p:spPr>
+          <a:xfrm>
+            <a:off x="4754880" y="1783080"/>
+            <a:ext cx="4114800" cy="960120"/>
+          </a:xfrm>
+          <a:prstGeom prst="roundRect">
+            <a:avLst>
+              <a:gd name="adj" fmla="val 6000"/>
+            </a:avLst>
+          </a:prstGeom>
+          <a:solidFill>
+            <a:srgbClr val="FFFFFF"/>
+          </a:solidFill>
+          <a:ln w="12700">
+            <a:solidFill>
+              <a:srgbClr val="D5DBDE"/>
+            </a:solidFill>
+          </a:ln>
+          <a:effectLst/>
+        </p:spPr>
+        <p:txBody>
+          <a:bodyPr rtlCol="0" anchor="ctr"/>
+          <a:lstStyle/>
+          <a:p/>
+        </p:txBody>
+      </p:sp>
+      <p:sp>
+        <p:nvSpPr>
+          <p:cNvPr id="111" name="Rounded Rectangle 110"/>
+          <p:cNvSpPr/>
+          <p:nvPr/>
+        </p:nvSpPr>
+        <p:spPr>
+          <a:xfrm>
+            <a:off x="4882896" y="1911095"/>
+            <a:ext cx="310896" cy="310896"/>
+          </a:xfrm>
+          <a:prstGeom prst="roundRect">
+            <a:avLst>
+              <a:gd name="adj" fmla="val 50000"/>
             </a:avLst>
           </a:prstGeom>
           <a:solidFill>
@@ -17252,120 +17506,102 @@
           <a:effectLst/>
         </p:spPr>
         <p:txBody>
-          <a:bodyPr rtlCol="0" anchor="ctr"/>
-          <a:lstStyle/>
-          <a:p/>
-        </p:txBody>
-      </p:sp>
-      <p:sp>
-        <p:nvSpPr>
-          <p:cNvPr id="105" name="TextBox 104"/>
-          <p:cNvSpPr txBox="1"/>
-          <p:nvPr/>
-        </p:nvSpPr>
-        <p:spPr>
-          <a:xfrm>
-            <a:off x="457200" y="1216152"/>
-            <a:ext cx="5486400" cy="274320"/>
-          </a:xfrm>
-          <a:prstGeom prst="rect">
-            <a:avLst/>
-          </a:prstGeom>
-          <a:noFill/>
-        </p:spPr>
-        <p:txBody>
-          <a:bodyPr wrap="square" anchor="t" lIns="0" rIns="0" tIns="27432" bIns="27432">
-            <a:spAutoFit/>
-          </a:bodyPr>
-          <a:lstStyle/>
-          <a:p>
-            <a:pPr algn="l"/>
-            <a:r>
-              <a:rPr sz="900" b="1" i="0">
-                <a:solidFill>
-                  <a:srgbClr val="E0A100"/>
-                </a:solidFill>
-                <a:latin typeface="Arial"/>
-              </a:rPr>
-              <a:t>THE PRODUCT IN ONE INTERACTION</a:t>
-            </a:r>
-          </a:p>
-        </p:txBody>
-      </p:sp>
-      <p:sp>
-        <p:nvSpPr>
-          <p:cNvPr id="106" name="TextBox 105"/>
-          <p:cNvSpPr txBox="1"/>
-          <p:nvPr/>
-        </p:nvSpPr>
-        <p:spPr>
-          <a:xfrm>
-            <a:off x="457200" y="1463040"/>
-            <a:ext cx="5669280" cy="548640"/>
-          </a:xfrm>
-          <a:prstGeom prst="rect">
-            <a:avLst/>
-          </a:prstGeom>
-          <a:noFill/>
-        </p:spPr>
-        <p:txBody>
-          <a:bodyPr wrap="square" anchor="t" lIns="0" rIns="0" tIns="27432" bIns="27432">
-            <a:spAutoFit/>
-          </a:bodyPr>
-          <a:lstStyle/>
-          <a:p>
-            <a:pPr algn="l"/>
-            <a:r>
-              <a:rPr sz="2600" b="1" i="0">
+          <a:bodyPr rtlCol="0" anchor="ctr" lIns="36576" rIns="36576" tIns="0" bIns="0"/>
+          <a:lstStyle/>
+          <a:p>
+            <a:pPr algn="ctr"/>
+            <a:r>
+              <a:rPr sz="1100" b="1">
                 <a:solidFill>
                   <a:srgbClr val="FFFFFF"/>
                 </a:solidFill>
                 <a:latin typeface="Arial"/>
               </a:rPr>
-              <a:t>Click the number. See the line.</a:t>
-            </a:r>
-          </a:p>
-        </p:txBody>
-      </p:sp>
-      <p:pic>
-        <p:nvPicPr>
-          <p:cNvPr id="107" name="Picture 106" descr="v2_evidence_c.jpg"/>
-          <p:cNvPicPr>
-            <a:picLocks noChangeAspect="1"/>
-          </p:cNvPicPr>
-          <p:nvPr/>
-        </p:nvPicPr>
-        <p:blipFill>
-          <a:blip r:embed="rId5"/>
-          <a:stretch>
-            <a:fillRect/>
-          </a:stretch>
-        </p:blipFill>
-        <p:spPr>
-          <a:xfrm>
-            <a:off x="457200" y="2103120"/>
-            <a:ext cx="3580472" cy="2606040"/>
-          </a:xfrm>
-          <a:prstGeom prst="rect">
-            <a:avLst/>
-          </a:prstGeom>
-          <a:ln w="9525">
-            <a:solidFill>
-              <a:srgbClr val="2E5F6E"/>
-            </a:solidFill>
-          </a:ln>
-        </p:spPr>
-      </p:pic>
-      <p:sp>
-        <p:nvSpPr>
-          <p:cNvPr id="108" name="Rounded Rectangle 107"/>
+              <a:t>1</a:t>
+            </a:r>
+          </a:p>
+        </p:txBody>
+      </p:sp>
+      <p:sp>
+        <p:nvSpPr>
+          <p:cNvPr id="112" name="TextBox 111"/>
+          <p:cNvSpPr txBox="1"/>
+          <p:nvPr/>
+        </p:nvSpPr>
+        <p:spPr>
+          <a:xfrm>
+            <a:off x="5303520" y="1874519"/>
+            <a:ext cx="3474720" cy="365760"/>
+          </a:xfrm>
+          <a:prstGeom prst="rect">
+            <a:avLst/>
+          </a:prstGeom>
+          <a:noFill/>
+        </p:spPr>
+        <p:txBody>
+          <a:bodyPr wrap="square" anchor="ctr" lIns="0" rIns="0" tIns="27432" bIns="27432">
+            <a:spAutoFit/>
+          </a:bodyPr>
+          <a:lstStyle/>
+          <a:p>
+            <a:pPr algn="l"/>
+            <a:r>
+              <a:rPr sz="1350" b="1" i="0">
+                <a:solidFill>
+                  <a:srgbClr val="0F3D4C"/>
+                </a:solidFill>
+                <a:latin typeface="Arial"/>
+              </a:rPr>
+              <a:t>The memo cites a figure</a:t>
+            </a:r>
+          </a:p>
+        </p:txBody>
+      </p:sp>
+      <p:sp>
+        <p:nvSpPr>
+          <p:cNvPr id="113" name="TextBox 112"/>
+          <p:cNvSpPr txBox="1"/>
+          <p:nvPr/>
+        </p:nvSpPr>
+        <p:spPr>
+          <a:xfrm>
+            <a:off x="4882896" y="2240280"/>
+            <a:ext cx="3886200" cy="502920"/>
+          </a:xfrm>
+          <a:prstGeom prst="rect">
+            <a:avLst/>
+          </a:prstGeom>
+          <a:noFill/>
+        </p:spPr>
+        <p:txBody>
+          <a:bodyPr wrap="square" anchor="t" lIns="0" rIns="0" tIns="27432" bIns="27432">
+            <a:spAutoFit/>
+          </a:bodyPr>
+          <a:lstStyle/>
+          <a:p>
+            <a:pPr algn="l"/>
+            <a:r>
+              <a:rPr sz="950" b="0" i="0">
+                <a:solidFill>
+                  <a:srgbClr val="202124"/>
+                </a:solidFill>
+                <a:latin typeface="Arial"/>
+              </a:rPr>
+              <a:t>Every underlined value is a catalog figure with a source. Here: VND 82,500,000, credits from the applicant's own accounts.</a:t>
+            </a:r>
+          </a:p>
+        </p:txBody>
+      </p:sp>
+      <p:sp>
+        <p:nvSpPr>
+          <p:cNvPr id="114" name="Rounded Rectangle 113"/>
           <p:cNvSpPr/>
           <p:nvPr/>
         </p:nvSpPr>
         <p:spPr>
           <a:xfrm>
-            <a:off x="4266272" y="2103120"/>
-            <a:ext cx="4420528" cy="804672"/>
+            <a:off x="4754880" y="2834639"/>
+            <a:ext cx="4114800" cy="960120"/>
           </a:xfrm>
           <a:prstGeom prst="roundRect">
             <a:avLst>
@@ -17373,7 +17609,39 @@
             </a:avLst>
           </a:prstGeom>
           <a:solidFill>
-            <a:srgbClr val="15505F"/>
+            <a:srgbClr val="FFFFFF"/>
+          </a:solidFill>
+          <a:ln w="12700">
+            <a:solidFill>
+              <a:srgbClr val="D5DBDE"/>
+            </a:solidFill>
+          </a:ln>
+          <a:effectLst/>
+        </p:spPr>
+        <p:txBody>
+          <a:bodyPr rtlCol="0" anchor="ctr"/>
+          <a:lstStyle/>
+          <a:p/>
+        </p:txBody>
+      </p:sp>
+      <p:sp>
+        <p:nvSpPr>
+          <p:cNvPr id="115" name="Rounded Rectangle 114"/>
+          <p:cNvSpPr/>
+          <p:nvPr/>
+        </p:nvSpPr>
+        <p:spPr>
+          <a:xfrm>
+            <a:off x="4882896" y="2962656"/>
+            <a:ext cx="310896" cy="310896"/>
+          </a:xfrm>
+          <a:prstGeom prst="roundRect">
+            <a:avLst>
+              <a:gd name="adj" fmla="val 50000"/>
+            </a:avLst>
+          </a:prstGeom>
+          <a:solidFill>
+            <a:srgbClr val="0F3D4C"/>
           </a:solidFill>
           <a:ln>
             <a:noFill/>
@@ -17381,56 +17649,32 @@
           <a:effectLst/>
         </p:spPr>
         <p:txBody>
-          <a:bodyPr rtlCol="0" anchor="ctr"/>
-          <a:lstStyle/>
-          <a:p/>
-        </p:txBody>
-      </p:sp>
-      <p:sp>
-        <p:nvSpPr>
-          <p:cNvPr id="109" name="TextBox 108"/>
-          <p:cNvSpPr txBox="1"/>
-          <p:nvPr/>
-        </p:nvSpPr>
-        <p:spPr>
-          <a:xfrm>
-            <a:off x="4394287" y="2167127"/>
-            <a:ext cx="4164496" cy="320040"/>
-          </a:xfrm>
-          <a:prstGeom prst="rect">
-            <a:avLst/>
-          </a:prstGeom>
-          <a:noFill/>
-        </p:spPr>
-        <p:txBody>
-          <a:bodyPr wrap="square" anchor="t" lIns="0" rIns="0" tIns="27432" bIns="27432">
-            <a:spAutoFit/>
-          </a:bodyPr>
-          <a:lstStyle/>
-          <a:p>
-            <a:pPr algn="l"/>
-            <a:r>
-              <a:rPr sz="1300" b="1" i="0">
+          <a:bodyPr rtlCol="0" anchor="ctr" lIns="36576" rIns="36576" tIns="0" bIns="0"/>
+          <a:lstStyle/>
+          <a:p>
+            <a:pPr algn="ctr"/>
+            <a:r>
+              <a:rPr sz="1100" b="1">
                 <a:solidFill>
-                  <a:srgbClr val="E0A100"/>
+                  <a:srgbClr val="FFFFFF"/>
                 </a:solidFill>
                 <a:latin typeface="Arial"/>
               </a:rPr>
-              <a:t>VND 82,500,000</a:t>
-            </a:r>
-          </a:p>
-        </p:txBody>
-      </p:sp>
-      <p:sp>
-        <p:nvSpPr>
-          <p:cNvPr id="110" name="TextBox 109"/>
+              <a:t>2</a:t>
+            </a:r>
+          </a:p>
+        </p:txBody>
+      </p:sp>
+      <p:sp>
+        <p:nvSpPr>
+          <p:cNvPr id="116" name="TextBox 115"/>
           <p:cNvSpPr txBox="1"/>
           <p:nvPr/>
         </p:nvSpPr>
         <p:spPr>
           <a:xfrm>
-            <a:off x="4394287" y="2487168"/>
-            <a:ext cx="4164496" cy="457200"/>
+            <a:off x="5303520" y="2926079"/>
+            <a:ext cx="3474720" cy="365760"/>
           </a:xfrm>
           <a:prstGeom prst="rect">
             <a:avLst/>
@@ -17438,34 +17682,69 @@
           <a:noFill/>
         </p:spPr>
         <p:txBody>
-          <a:bodyPr wrap="square" anchor="t" lIns="0" rIns="0" tIns="27432" bIns="27432">
+          <a:bodyPr wrap="square" anchor="ctr" lIns="0" rIns="0" tIns="27432" bIns="27432">
             <a:spAutoFit/>
           </a:bodyPr>
           <a:lstStyle/>
           <a:p>
             <a:pPr algn="l"/>
             <a:r>
-              <a:rPr sz="900" b="0" i="0">
+              <a:rPr sz="1350" b="1" i="0">
                 <a:solidFill>
-                  <a:srgbClr val="BFD8D5"/>
+                  <a:srgbClr val="0F3D4C"/>
                 </a:solidFill>
                 <a:latin typeface="Arial"/>
               </a:rPr>
-              <a:t>Credits from the applicant's own accounts. Sum of 3 credits whose sender matches the account holder.</a:t>
-            </a:r>
-          </a:p>
-        </p:txBody>
-      </p:sp>
-      <p:sp>
-        <p:nvSpPr>
-          <p:cNvPr id="111" name="Rounded Rectangle 110"/>
+              <a:t>One click opens the evidence</a:t>
+            </a:r>
+          </a:p>
+        </p:txBody>
+      </p:sp>
+      <p:sp>
+        <p:nvSpPr>
+          <p:cNvPr id="117" name="TextBox 116"/>
+          <p:cNvSpPr txBox="1"/>
+          <p:nvPr/>
+        </p:nvSpPr>
+        <p:spPr>
+          <a:xfrm>
+            <a:off x="4882896" y="3291839"/>
+            <a:ext cx="3886200" cy="502920"/>
+          </a:xfrm>
+          <a:prstGeom prst="rect">
+            <a:avLst/>
+          </a:prstGeom>
+          <a:noFill/>
+        </p:spPr>
+        <p:txBody>
+          <a:bodyPr wrap="square" anchor="t" lIns="0" rIns="0" tIns="27432" bIns="27432">
+            <a:spAutoFit/>
+          </a:bodyPr>
+          <a:lstStyle/>
+          <a:p>
+            <a:pPr algn="l"/>
+            <a:r>
+              <a:rPr sz="950" b="0" i="0">
+                <a:solidFill>
+                  <a:srgbClr val="202124"/>
+                </a:solidFill>
+                <a:latin typeface="Arial"/>
+              </a:rPr>
+              <a:t>The computation (sum of 3 credits whose sender matches the account holder) and all 3 source references: pages 2, 4 and 5.</a:t>
+            </a:r>
+          </a:p>
+        </p:txBody>
+      </p:sp>
+      <p:sp>
+        <p:nvSpPr>
+          <p:cNvPr id="118" name="Rounded Rectangle 117"/>
           <p:cNvSpPr/>
           <p:nvPr/>
         </p:nvSpPr>
         <p:spPr>
           <a:xfrm>
-            <a:off x="4266272" y="3003803"/>
-            <a:ext cx="4420528" cy="804672"/>
+            <a:off x="4754880" y="3886200"/>
+            <a:ext cx="4114800" cy="960120"/>
           </a:xfrm>
           <a:prstGeom prst="roundRect">
             <a:avLst>
@@ -17473,10 +17752,12 @@
             </a:avLst>
           </a:prstGeom>
           <a:solidFill>
-            <a:srgbClr val="15505F"/>
+            <a:srgbClr val="FFF3CC"/>
           </a:solidFill>
-          <a:ln>
-            <a:noFill/>
+          <a:ln w="19050">
+            <a:solidFill>
+              <a:srgbClr val="E0A100"/>
+            </a:solidFill>
           </a:ln>
           <a:effectLst/>
         </p:spPr>
@@ -17488,88 +17769,18 @@
       </p:sp>
       <p:sp>
         <p:nvSpPr>
-          <p:cNvPr id="112" name="TextBox 111"/>
-          <p:cNvSpPr txBox="1"/>
-          <p:nvPr/>
-        </p:nvSpPr>
-        <p:spPr>
-          <a:xfrm>
-            <a:off x="4394287" y="3067811"/>
-            <a:ext cx="4164496" cy="320040"/>
-          </a:xfrm>
-          <a:prstGeom prst="rect">
-            <a:avLst/>
-          </a:prstGeom>
-          <a:noFill/>
-        </p:spPr>
-        <p:txBody>
-          <a:bodyPr wrap="square" anchor="t" lIns="0" rIns="0" tIns="27432" bIns="27432">
-            <a:spAutoFit/>
-          </a:bodyPr>
-          <a:lstStyle/>
-          <a:p>
-            <a:pPr algn="l"/>
-            <a:r>
-              <a:rPr sz="1300" b="1" i="0">
-                <a:solidFill>
-                  <a:srgbClr val="E0A100"/>
-                </a:solidFill>
-                <a:latin typeface="Arial"/>
-              </a:rPr>
-              <a:t>3 sources, 1 click</a:t>
-            </a:r>
-          </a:p>
-        </p:txBody>
-      </p:sp>
-      <p:sp>
-        <p:nvSpPr>
-          <p:cNvPr id="113" name="TextBox 112"/>
-          <p:cNvSpPr txBox="1"/>
-          <p:nvPr/>
-        </p:nvSpPr>
-        <p:spPr>
-          <a:xfrm>
-            <a:off x="4394287" y="3387851"/>
-            <a:ext cx="4164496" cy="457200"/>
-          </a:xfrm>
-          <a:prstGeom prst="rect">
-            <a:avLst/>
-          </a:prstGeom>
-          <a:noFill/>
-        </p:spPr>
-        <p:txBody>
-          <a:bodyPr wrap="square" anchor="t" lIns="0" rIns="0" tIns="27432" bIns="27432">
-            <a:spAutoFit/>
-          </a:bodyPr>
-          <a:lstStyle/>
-          <a:p>
-            <a:pPr algn="l"/>
-            <a:r>
-              <a:rPr sz="900" b="0" i="0">
-                <a:solidFill>
-                  <a:srgbClr val="BFD8D5"/>
-                </a:solidFill>
-                <a:latin typeface="Arial"/>
-              </a:rPr>
-              <a:t>bank_statement p.2, p.4, p.5. The viewer opens the page and highlights the row.</a:t>
-            </a:r>
-          </a:p>
-        </p:txBody>
-      </p:sp>
-      <p:sp>
-        <p:nvSpPr>
-          <p:cNvPr id="114" name="Rounded Rectangle 113"/>
+          <p:cNvPr id="119" name="Rounded Rectangle 118"/>
           <p:cNvSpPr/>
           <p:nvPr/>
         </p:nvSpPr>
         <p:spPr>
           <a:xfrm>
-            <a:off x="4266272" y="3904487"/>
-            <a:ext cx="4420528" cy="804672"/>
+            <a:off x="4882896" y="4014215"/>
+            <a:ext cx="310896" cy="310896"/>
           </a:xfrm>
           <a:prstGeom prst="roundRect">
             <a:avLst>
-              <a:gd name="adj" fmla="val 6000"/>
+              <a:gd name="adj" fmla="val 50000"/>
             </a:avLst>
           </a:prstGeom>
           <a:solidFill>
@@ -17581,56 +17792,32 @@
           <a:effectLst/>
         </p:spPr>
         <p:txBody>
-          <a:bodyPr rtlCol="0" anchor="ctr"/>
-          <a:lstStyle/>
-          <a:p/>
-        </p:txBody>
-      </p:sp>
-      <p:sp>
-        <p:nvSpPr>
-          <p:cNvPr id="115" name="TextBox 114"/>
-          <p:cNvSpPr txBox="1"/>
-          <p:nvPr/>
-        </p:nvSpPr>
-        <p:spPr>
-          <a:xfrm>
-            <a:off x="4394287" y="3968496"/>
-            <a:ext cx="4164496" cy="320040"/>
-          </a:xfrm>
-          <a:prstGeom prst="rect">
-            <a:avLst/>
-          </a:prstGeom>
-          <a:noFill/>
-        </p:spPr>
-        <p:txBody>
-          <a:bodyPr wrap="square" anchor="t" lIns="0" rIns="0" tIns="27432" bIns="27432">
-            <a:spAutoFit/>
-          </a:bodyPr>
-          <a:lstStyle/>
-          <a:p>
-            <a:pPr algn="l"/>
-            <a:r>
-              <a:rPr sz="1250" b="1" i="0">
+          <a:bodyPr rtlCol="0" anchor="ctr" lIns="36576" rIns="36576" tIns="0" bIns="0"/>
+          <a:lstStyle/>
+          <a:p>
+            <a:pPr algn="ctr"/>
+            <a:r>
+              <a:rPr sz="1100" b="1">
                 <a:solidFill>
                   <a:srgbClr val="0F3D4C"/>
                 </a:solidFill>
                 <a:latin typeface="Arial"/>
               </a:rPr>
-              <a:t>Unsourced numbers: 0</a:t>
-            </a:r>
-          </a:p>
-        </p:txBody>
-      </p:sp>
-      <p:sp>
-        <p:nvSpPr>
-          <p:cNvPr id="116" name="TextBox 115"/>
+              <a:t>3</a:t>
+            </a:r>
+          </a:p>
+        </p:txBody>
+      </p:sp>
+      <p:sp>
+        <p:nvSpPr>
+          <p:cNvPr id="120" name="TextBox 119"/>
           <p:cNvSpPr txBox="1"/>
           <p:nvPr/>
         </p:nvSpPr>
         <p:spPr>
           <a:xfrm>
-            <a:off x="4394287" y="4288536"/>
-            <a:ext cx="4164496" cy="457200"/>
+            <a:off x="5303520" y="3977639"/>
+            <a:ext cx="3474720" cy="365760"/>
           </a:xfrm>
           <a:prstGeom prst="rect">
             <a:avLst/>
@@ -17638,34 +17825,34 @@
           <a:noFill/>
         </p:spPr>
         <p:txBody>
-          <a:bodyPr wrap="square" anchor="t" lIns="0" rIns="0" tIns="27432" bIns="27432">
+          <a:bodyPr wrap="square" anchor="ctr" lIns="0" rIns="0" tIns="27432" bIns="27432">
             <a:spAutoFit/>
           </a:bodyPr>
           <a:lstStyle/>
           <a:p>
             <a:pPr algn="l"/>
             <a:r>
-              <a:rPr sz="900" b="0" i="0">
+              <a:rPr sz="1350" b="1" i="0">
                 <a:solidFill>
                   <a:srgbClr val="0F3D4C"/>
                 </a:solidFill>
                 <a:latin typeface="Arial"/>
               </a:rPr>
-              <a:t>Enforced by the output schema. A miss becomes a Challenger objection.</a:t>
-            </a:r>
-          </a:p>
-        </p:txBody>
-      </p:sp>
-      <p:sp>
-        <p:nvSpPr>
-          <p:cNvPr id="117" name="TextBox 116"/>
+              <a:t>The source line lights up</a:t>
+            </a:r>
+          </a:p>
+        </p:txBody>
+      </p:sp>
+      <p:sp>
+        <p:nvSpPr>
+          <p:cNvPr id="121" name="TextBox 120"/>
           <p:cNvSpPr txBox="1"/>
           <p:nvPr/>
         </p:nvSpPr>
         <p:spPr>
           <a:xfrm>
-            <a:off x="457200" y="4754880"/>
-            <a:ext cx="5943600" cy="201168"/>
+            <a:off x="4882896" y="4343400"/>
+            <a:ext cx="3886200" cy="502920"/>
           </a:xfrm>
           <a:prstGeom prst="rect">
             <a:avLst/>
@@ -17680,13 +17867,13 @@
           <a:p>
             <a:pPr algn="l"/>
             <a:r>
-              <a:rPr sz="800" b="0" i="1">
+              <a:rPr sz="950" b="0" i="0">
                 <a:solidFill>
-                  <a:srgbClr val="8FB8B3"/>
+                  <a:srgbClr val="202124"/>
                 </a:solidFill>
                 <a:latin typeface="Arial"/>
               </a:rPr>
-              <a:t>Live prototype, case B (Linh Fashion Online): 14 documents, 130 figures, 0 unsourced, 12 objections.</a:t>
+              <a:t>The statement page opens with the extractor's bounding box drawn on the exact row. Unsourced numbers: 0, enforced by the output schema.</a:t>
             </a:r>
           </a:p>
         </p:txBody>

</xml_diff>

<commit_message>
presentation: team Hey Merlion!, members Changhyeon Nam and Hyunho Yang
</commit_message>
<xml_diff>
--- a/presentation/LedgerLens_AI_Builder_Cup_Submission.pptx
+++ b/presentation/LedgerLens_AI_Builder_Cup_Submission.pptx
@@ -7165,7 +7165,7 @@
                 <a:cs typeface="Google Sans Flex"/>
                 <a:sym typeface="Google Sans Flex"/>
               </a:rPr>
-              <a:t>Team name: LedgerLens</a:t>
+              <a:t>Team name: Hey Merlion!</a:t>
             </a:r>
             <a:endParaRPr sz="1800">
               <a:latin typeface="Google Sans Flex"/>
@@ -7193,7 +7193,7 @@
                 <a:cs typeface="Google Sans Flex"/>
                 <a:sym typeface="Google Sans Flex"/>
               </a:rPr>
-              <a:t>Team leader name: Changhyeon (SK Telecom, AI CIC)</a:t>
+              <a:t>Team leader name: Changhyeon Nam (team: Changhyeon Nam, Hyunho Yang)</a:t>
             </a:r>
             <a:endParaRPr sz="1800">
               <a:latin typeface="Google Sans Flex"/>
@@ -9209,7 +9209,7 @@
                           </a:solidFill>
                           <a:latin typeface="Arial"/>
                         </a:rPr>
-                        <a:t>4 engineers, 4 days, free tier and trial credits</a:t>
+                        <a:t>2 engineers, 4 days, free tier and trial credits</a:t>
                       </a:r>
                     </a:p>
                   </a:txBody>

</xml_diff>

<commit_message>
Deck and README: replace mock-era numbers with the live Gemini run
Slides 4, 10, 11 and 13 and the roadmap caption now use the 2026-10-15 live run:
16/20 traps vs 1/20 for a single prompt, 0 vs 45 unsourced numbers, 481/481 rows,
about 2 minutes and USD 0.26-0.31 per cold case. README cost section updated to match.
</commit_message>
<xml_diff>
--- a/presentation/LedgerLens_AI_Builder_Cup_Submission.pptx
+++ b/presentation/LedgerLens_AI_Builder_Cup_Submission.pptx
@@ -367,10 +367,10 @@
                   <c:v>Manual review (45 min at USD 15/h)</c:v>
                 </c:pt>
                 <c:pt idx="1">
-                  <c:v>LedgerLens, Gemini 3.1 Pro upgrade</c:v>
+                  <c:v>Single prompt (catches 1 of 20 traps)</c:v>
                 </c:pt>
                 <c:pt idx="2">
-                  <c:v>LedgerLens, Gemini 3.8 Flash default</c:v>
+                  <c:v>LedgerLens, Gemini 3.8 Flash, measured</c:v>
                 </c:pt>
                 <c:pt idx="3">
                   <c:v>LedgerLens, cached re-run</c:v>
@@ -388,10 +388,10 @@
                   <c:v>11.25</c:v>
                 </c:pt>
                 <c:pt idx="1">
-                  <c:v>0.4</c:v>
+                  <c:v>0.015</c:v>
                 </c:pt>
                 <c:pt idx="2">
-                  <c:v>0.1</c:v>
+                  <c:v>0.31</c:v>
                 </c:pt>
                 <c:pt idx="3">
                   <c:v>0.0</c:v>
@@ -401,7 +401,7 @@
           </c:val>
         </c:ser>
         <c:dLbls>
-          <c:numFmt formatCode="0.00" sourceLinked="0"/>
+          <c:numFmt formatCode="0.00#" sourceLinked="0"/>
           <c:txPr>
             <a:bodyPr/>
             <a:lstStyle/>
@@ -7649,7 +7649,7 @@
                 </a:solidFill>
                 <a:latin typeface="Arial"/>
               </a:rPr>
-              <a:t>Default for every agent. Free tier available; about USD 0.10 per case paid.</a:t>
+              <a:t>Default for every agent. Measured USD 0.26-0.31 per cold case; free tier available.</a:t>
             </a:r>
           </a:p>
         </p:txBody>
@@ -8853,7 +8853,7 @@
                 </a:solidFill>
                 <a:latin typeface="Arial"/>
               </a:rPr>
-              <a:t>Cheap enough for small loans: about USD 0.10 per case on Flash, zero on a re-run</a:t>
+              <a:t>Cheap enough for small loans: USD 0.26-0.31 per case measured on Flash, zero on a cached re-run</a:t>
             </a:r>
           </a:p>
         </p:txBody>
@@ -9049,7 +9049,7 @@
                           </a:solidFill>
                           <a:latin typeface="Arial"/>
                         </a:rPr>
-                        <a:t>Tokens per 20-document case</a:t>
+                        <a:t>Tokens per case (measured)</a:t>
                       </a:r>
                     </a:p>
                   </a:txBody>
@@ -9071,7 +9071,7 @@
                           </a:solidFill>
                           <a:latin typeface="Arial"/>
                         </a:rPr>
-                        <a:t>60-90k input, 15-25k output</a:t>
+                        <a:t>77-103k for 11-18 documents</a:t>
                       </a:r>
                     </a:p>
                   </a:txBody>
@@ -10328,7 +10328,7 @@
                 </a:solidFill>
                 <a:latin typeface="Arial"/>
               </a:rPr>
-              <a:t>19 of 20 planted traps caught, zero unsourced numbers. A single prompt on the same documents caught none.</a:t>
+              <a:t>16 of 20 planted traps caught, zero unsourced numbers. A single prompt on the same documents caught 1 and left 45 numbers unsourced.</a:t>
             </a:r>
           </a:p>
         </p:txBody>
@@ -10430,7 +10430,7 @@
                 </a:solidFill>
                 <a:latin typeface="Arial"/>
               </a:rPr>
-              <a:t>19</a:t>
+              <a:t>16</a:t>
             </a:r>
           </a:p>
         </p:txBody>
@@ -10535,7 +10535,7 @@
                 </a:solidFill>
                 <a:latin typeface="Arial"/>
               </a:rPr>
-              <a:t>0</a:t>
+              <a:t>1</a:t>
             </a:r>
           </a:p>
         </p:txBody>
@@ -10672,7 +10672,7 @@
                 </a:solidFill>
                 <a:latin typeface="Arial"/>
               </a:rPr>
-              <a:t>unsourced numbers (baseline: 6)</a:t>
+              <a:t>unsourced numbers (baseline: 45)</a:t>
             </a:r>
           </a:p>
         </p:txBody>
@@ -10739,7 +10739,7 @@
                 </a:solidFill>
                 <a:latin typeface="Arial"/>
               </a:rPr>
-              <a:t>4.5 s</a:t>
+              <a:t>~2 min</a:t>
             </a:r>
           </a:p>
         </p:txBody>
@@ -10774,7 +10774,7 @@
                 </a:solidFill>
                 <a:latin typeface="Arial"/>
               </a:rPr>
-              <a:t>per case, USD 0.00 on cached run</a:t>
+              <a:t>per cold case, USD 0.26-0.31; cached re-run free</a:t>
             </a:r>
           </a:p>
         </p:txBody>
@@ -10927,7 +10927,7 @@
                           </a:solidFill>
                           <a:latin typeface="Arial"/>
                         </a:rPr>
-                        <a:t>19 / 20</a:t>
+                        <a:t>16 / 20</a:t>
                       </a:r>
                     </a:p>
                   </a:txBody>
@@ -11063,7 +11063,7 @@
                           </a:solidFill>
                           <a:latin typeface="Arial"/>
                         </a:rPr>
-                        <a:t>0</a:t>
+                        <a:t>1 (4.5%)</a:t>
                       </a:r>
                     </a:p>
                   </a:txBody>
@@ -11131,7 +11131,7 @@
                           </a:solidFill>
                           <a:latin typeface="Arial"/>
                         </a:rPr>
-                        <a:t>100%</a:t>
+                        <a:t>100% (481/481)</a:t>
                       </a:r>
                     </a:p>
                   </a:txBody>
@@ -11267,7 +11267,7 @@
                           </a:solidFill>
                           <a:latin typeface="Arial"/>
                         </a:rPr>
-                        <a:t>4.5 s</a:t>
+                        <a:t>~130 s</a:t>
                       </a:r>
                     </a:p>
                   </a:txBody>
@@ -11353,7 +11353,7 @@
                 </a:solidFill>
                 <a:latin typeface="Arial"/>
               </a:rPr>
-              <a:t>Run of 2026-10-14 in mock mode: full pipeline plus the deterministic Challenger battery, 3 synthetic businesses, 43 documents, answer key traps.json. Baseline is a stub in this mode; a live Gemini 3.8 Flash run replaces both before submission.</a:t>
+              <a:t>Live Gemini 3.8 Flash run, 2026-10-15. 3 synthetic businesses, 43 born-digital documents, 20 traps. Strict scoring: amount or document under an expected question (95% CI 0.58-0.92). Missed T02, T03, T18, T19. Scanned documents will extract below 100%.</a:t>
             </a:r>
           </a:p>
         </p:txBody>
@@ -14940,7 +14940,7 @@
                 </a:solidFill>
                 <a:latin typeface="Arial"/>
               </a:rPr>
-              <a:t>Same documents. Read in 3 minutes. Every number defensible.</a:t>
+              <a:t>Same documents. Read in about 2 minutes. Every number defensible.</a:t>
             </a:r>
           </a:p>
         </p:txBody>
@@ -15007,7 +15007,7 @@
                 </a:solidFill>
                 <a:latin typeface="Arial"/>
               </a:rPr>
-              <a:t>45 → 3</a:t>
+              <a:t>45 → 2</a:t>
             </a:r>
           </a:p>
         </p:txBody>
@@ -15042,7 +15042,7 @@
                 </a:solidFill>
                 <a:latin typeface="Arial"/>
               </a:rPr>
-              <a:t>minutes of reading per file</a:t>
+              <a:t>minutes per file, manual estimate vs measured run</a:t>
             </a:r>
           </a:p>
         </p:txBody>
@@ -15109,7 +15109,7 @@
                 </a:solidFill>
                 <a:latin typeface="Arial"/>
               </a:rPr>
-              <a:t>11 → 0.10</a:t>
+              <a:t>11 → 0.31</a:t>
             </a:r>
           </a:p>
         </p:txBody>
@@ -15144,7 +15144,7 @@
                 </a:solidFill>
                 <a:latin typeface="Arial"/>
               </a:rPr>
-              <a:t>USD per case, manual review vs LedgerLens</a:t>
+              <a:t>USD per case, manual estimate vs measured run</a:t>
             </a:r>
           </a:p>
         </p:txBody>

</xml_diff>

<commit_message>
Deck and README: live Gemini benchmark numbers, measured cost, link placeholders
</commit_message>
<xml_diff>
--- a/presentation/LedgerLens_AI_Builder_Cup_Submission.pptx
+++ b/presentation/LedgerLens_AI_Builder_Cup_Submission.pptx
@@ -310,7 +310,7 @@
                 </a:solidFill>
                 <a:latin typeface="Arial"/>
               </a:rPr>
-              <a:t>Cost per case, USD</a:t>
+              <a:t>Cost per case, USD (gemini-3.8-flash, live run 2026-10-15)</a:t>
             </a:r>
           </a:p>
         </c:rich>
@@ -346,7 +346,15 @@
             <c:idx val="0"/>
             <c:spPr>
               <a:solidFill>
-                <a:srgbClr val="B0B8BE"/>
+                <a:srgbClr val="E0A100"/>
+              </a:solidFill>
+            </c:spPr>
+          </c:dPt>
+          <c:dPt>
+            <c:idx val="1"/>
+            <c:spPr>
+              <a:solidFill>
+                <a:srgbClr val="E0A100"/>
               </a:solidFill>
             </c:spPr>
           </c:dPt>
@@ -354,7 +362,7 @@
             <c:idx val="2"/>
             <c:spPr>
               <a:solidFill>
-                <a:srgbClr val="E0A100"/>
+                <a:srgbClr val="B0B8BE"/>
               </a:solidFill>
             </c:spPr>
           </c:dPt>
@@ -364,16 +372,16 @@
               <c:strCache>
                 <c:ptCount val="4"/>
                 <c:pt idx="0">
-                  <c:v>Manual review (45 min at USD 15/h)</c:v>
+                  <c:v>LedgerLens cold run, case B (14 docs)</c:v>
                 </c:pt>
                 <c:pt idx="1">
-                  <c:v>LedgerLens, Gemini 3.1 Pro upgrade</c:v>
+                  <c:v>LedgerLens cold run, case C (11 docs)</c:v>
                 </c:pt>
                 <c:pt idx="2">
-                  <c:v>LedgerLens, Gemini 3.8 Flash default</c:v>
+                  <c:v>Single-prompt baseline (no checks)</c:v>
                 </c:pt>
                 <c:pt idx="3">
-                  <c:v>LedgerLens, cached re-run</c:v>
+                  <c:v>LedgerLens cached re-run</c:v>
                 </c:pt>
               </c:strCache>
             </c:strRef>
@@ -385,13 +393,13 @@
                 <c:formatCode>General</c:formatCode>
                 <c:ptCount val="4"/>
                 <c:pt idx="0">
-                  <c:v>11.25</c:v>
+                  <c:v>0.306</c:v>
                 </c:pt>
                 <c:pt idx="1">
-                  <c:v>0.4</c:v>
+                  <c:v>0.257</c:v>
                 </c:pt>
                 <c:pt idx="2">
-                  <c:v>0.1</c:v>
+                  <c:v>0.015</c:v>
                 </c:pt>
                 <c:pt idx="3">
                   <c:v>0.0</c:v>
@@ -401,7 +409,7 @@
           </c:val>
         </c:ser>
         <c:dLbls>
-          <c:numFmt formatCode="0.00" sourceLinked="0"/>
+          <c:numFmt formatCode="0.000" sourceLinked="0"/>
           <c:txPr>
             <a:bodyPr/>
             <a:lstStyle/>
@@ -470,7 +478,8 @@
       <c:valAx>
         <c:axId val="-2113994440"/>
         <c:scaling>
-          <c:max val="13.5"/>
+          <c:max val="0.38"/>
+          <c:min val="0.0"/>
         </c:scaling>
         <c:delete/>
         <c:axPos val="b"/>
@@ -7649,7 +7658,7 @@
                 </a:solidFill>
                 <a:latin typeface="Arial"/>
               </a:rPr>
-              <a:t>Default for every agent. Free tier available; about USD 0.10 per case paid.</a:t>
+              <a:t>Default for every agent. Measured USD 0.26-0.31 per cold case; USD 0 cached.</a:t>
             </a:r>
           </a:p>
         </p:txBody>
@@ -8853,7 +8862,7 @@
                 </a:solidFill>
                 <a:latin typeface="Arial"/>
               </a:rPr>
-              <a:t>Cheap enough for small loans: about USD 0.10 per case on Flash, zero on a re-run</a:t>
+              <a:t>Measured: USD 0.26-0.31 per case on a cold Flash run, USD 0 on a cached re-run</a:t>
             </a:r>
           </a:p>
         </p:txBody>
@@ -8886,7 +8895,7 @@
         </p:nvGraphicFramePr>
         <p:xfrm>
           <a:off x="5760720" y="1645920"/>
-          <a:ext cx="3108959" cy="3108959"/>
+          <a:ext cx="3108959" cy="3108960"/>
         </p:xfrm>
         <a:graphic>
           <a:graphicData uri="http://schemas.openxmlformats.org/drawingml/2006/table">
@@ -8898,7 +8907,7 @@
                 <a:gridCol w="1234440"/>
                 <a:gridCol w="1874519"/>
               </a:tblGrid>
-              <a:tr h="444137">
+              <a:tr h="388620">
                 <a:tc>
                   <a:txBody>
                     <a:bodyPr wrap="square"/>
@@ -8944,7 +8953,7 @@
                   </a:tcPr>
                 </a:tc>
               </a:tr>
-              <a:tr h="444137">
+              <a:tr h="388620">
                 <a:tc>
                   <a:txBody>
                     <a:bodyPr wrap="square"/>
@@ -8990,7 +8999,7 @@
                   </a:tcPr>
                 </a:tc>
               </a:tr>
-              <a:tr h="444137">
+              <a:tr h="388620">
                 <a:tc>
                   <a:txBody>
                     <a:bodyPr wrap="square"/>
@@ -9003,7 +9012,7 @@
                           </a:solidFill>
                           <a:latin typeface="Arial"/>
                         </a:rPr>
-                        <a:t>Gemini 3.1 Pro list price</a:t>
+                        <a:t>Measured cold run</a:t>
                       </a:r>
                     </a:p>
                   </a:txBody>
@@ -9025,7 +9034,7 @@
                           </a:solidFill>
                           <a:latin typeface="Arial"/>
                         </a:rPr>
-                        <a:t>USD 2.00 / 12.00 per 1M tokens</a:t>
+                        <a:t>~2 min and USD 0.26-0.31 per case</a:t>
                       </a:r>
                     </a:p>
                   </a:txBody>
@@ -9036,7 +9045,7 @@
                   </a:tcPr>
                 </a:tc>
               </a:tr>
-              <a:tr h="444137">
+              <a:tr h="388620">
                 <a:tc>
                   <a:txBody>
                     <a:bodyPr wrap="square"/>
@@ -9049,7 +9058,7 @@
                           </a:solidFill>
                           <a:latin typeface="Arial"/>
                         </a:rPr>
-                        <a:t>Tokens per 20-document case</a:t>
+                        <a:t>Cached re-run</a:t>
                       </a:r>
                     </a:p>
                   </a:txBody>
@@ -9071,7 +9080,7 @@
                           </a:solidFill>
                           <a:latin typeface="Arial"/>
                         </a:rPr>
-                        <a:t>60-90k input, 15-25k output</a:t>
+                        <a:t>USD 0 (content-hash LLM cache)</a:t>
                       </a:r>
                     </a:p>
                   </a:txBody>
@@ -9082,7 +9091,7 @@
                   </a:tcPr>
                 </a:tc>
               </a:tr>
-              <a:tr h="444137">
+              <a:tr h="388620">
                 <a:tc>
                   <a:txBody>
                     <a:bodyPr wrap="square"/>
@@ -9095,7 +9104,7 @@
                           </a:solidFill>
                           <a:latin typeface="Arial"/>
                         </a:rPr>
-                        <a:t>Hosting</a:t>
+                        <a:t>Public demo</a:t>
                       </a:r>
                     </a:p>
                   </a:txBody>
@@ -9117,7 +9126,7 @@
                           </a:solidFill>
                           <a:latin typeface="Arial"/>
                         </a:rPr>
-                        <a:t>Cloud Run scales to zero; Firestore and Storage in free tier</a:t>
+                        <a:t>cache_only replay, USD 0; only the customer letter calls Gemini (~USD 0.0015)</a:t>
                       </a:r>
                     </a:p>
                   </a:txBody>
@@ -9128,7 +9137,7 @@
                   </a:tcPr>
                 </a:tc>
               </a:tr>
-              <a:tr h="444137">
+              <a:tr h="388620">
                 <a:tc>
                   <a:txBody>
                     <a:bodyPr wrap="square"/>
@@ -9141,7 +9150,7 @@
                           </a:solidFill>
                           <a:latin typeface="Arial"/>
                         </a:rPr>
-                        <a:t>Guardrail</a:t>
+                        <a:t>Hosting</a:t>
                       </a:r>
                     </a:p>
                   </a:txBody>
@@ -9163,7 +9172,7 @@
                           </a:solidFill>
                           <a:latin typeface="Arial"/>
                         </a:rPr>
-                        <a:t>Budget-cap env var stops Gemini calls once spent</a:t>
+                        <a:t>Cloud Run scales to zero; Firestore and Storage in free tier</a:t>
                       </a:r>
                     </a:p>
                   </a:txBody>
@@ -9174,7 +9183,7 @@
                   </a:tcPr>
                 </a:tc>
               </a:tr>
-              <a:tr h="444137">
+              <a:tr h="388620">
                 <a:tc>
                   <a:txBody>
                     <a:bodyPr wrap="square"/>
@@ -9187,7 +9196,7 @@
                           </a:solidFill>
                           <a:latin typeface="Arial"/>
                         </a:rPr>
-                        <a:t>Build</a:t>
+                        <a:t>Guardrail</a:t>
                       </a:r>
                     </a:p>
                   </a:txBody>
@@ -9209,13 +9218,59 @@
                           </a:solidFill>
                           <a:latin typeface="Arial"/>
                         </a:rPr>
+                        <a:t>Budget-cap env var stops Gemini calls once spent</a:t>
+                      </a:r>
+                    </a:p>
+                  </a:txBody>
+                  <a:tcPr marL="54864" marR="54864" marT="27432" marB="27432" anchor="ctr">
+                    <a:solidFill>
+                      <a:srgbClr val="F7F9FA"/>
+                    </a:solidFill>
+                  </a:tcPr>
+                </a:tc>
+              </a:tr>
+              <a:tr h="388620">
+                <a:tc>
+                  <a:txBody>
+                    <a:bodyPr wrap="square"/>
+                    <a:lstStyle/>
+                    <a:p>
+                      <a:r>
+                        <a:rPr sz="850" b="1">
+                          <a:solidFill>
+                            <a:srgbClr val="202124"/>
+                          </a:solidFill>
+                          <a:latin typeface="Arial"/>
+                        </a:rPr>
+                        <a:t>Build</a:t>
+                      </a:r>
+                    </a:p>
+                  </a:txBody>
+                  <a:tcPr marL="54864" marR="54864" marT="27432" marB="27432" anchor="ctr">
+                    <a:solidFill>
+                      <a:srgbClr val="FFFFFF"/>
+                    </a:solidFill>
+                  </a:tcPr>
+                </a:tc>
+                <a:tc>
+                  <a:txBody>
+                    <a:bodyPr wrap="square"/>
+                    <a:lstStyle/>
+                    <a:p>
+                      <a:r>
+                        <a:rPr sz="850" b="0">
+                          <a:solidFill>
+                            <a:srgbClr val="202124"/>
+                          </a:solidFill>
+                          <a:latin typeface="Arial"/>
+                        </a:rPr>
                         <a:t>2 engineers, 4 days, free tier and trial credits</a:t>
                       </a:r>
                     </a:p>
                   </a:txBody>
                   <a:tcPr marL="54864" marR="54864" marT="27432" marB="27432" anchor="ctr">
                     <a:solidFill>
-                      <a:srgbClr val="F7F9FA"/>
+                      <a:srgbClr val="FFFFFF"/>
                     </a:solidFill>
                   </a:tcPr>
                 </a:tc>
@@ -10328,7 +10383,7 @@
                 </a:solidFill>
                 <a:latin typeface="Arial"/>
               </a:rPr>
-              <a:t>19 of 20 planted traps caught, zero unsourced numbers. A single prompt on the same documents caught none.</a:t>
+              <a:t>16 of 20 planted traps caught on live Gemini; a single prompt on the same documents caught 1.</a:t>
             </a:r>
           </a:p>
         </p:txBody>
@@ -10430,7 +10485,7 @@
                 </a:solidFill>
                 <a:latin typeface="Arial"/>
               </a:rPr>
-              <a:t>19</a:t>
+              <a:t>16</a:t>
             </a:r>
           </a:p>
         </p:txBody>
@@ -10443,8 +10498,8 @@
         </p:nvSpPr>
         <p:spPr>
           <a:xfrm>
-            <a:off x="411480" y="3154680"/>
-            <a:ext cx="2011680" cy="365760"/>
+            <a:off x="411480" y="3108960"/>
+            <a:ext cx="2011680" cy="457200"/>
           </a:xfrm>
           <a:prstGeom prst="rect">
             <a:avLst/>
@@ -10468,6 +10523,18 @@
               <a:t>of 20 traps caught</a:t>
             </a:r>
           </a:p>
+          <a:p>
+            <a:pPr algn="l"/>
+            <a:r>
+              <a:rPr sz="850" b="0" i="0">
+                <a:solidFill>
+                  <a:srgbClr val="5F6368"/>
+                </a:solidFill>
+                <a:latin typeface="Arial"/>
+              </a:rPr>
+              <a:t>95% Wilson CI 0.58-0.92</a:t>
+            </a:r>
+          </a:p>
         </p:txBody>
       </p:sp>
       <p:sp>
@@ -10535,7 +10602,7 @@
                 </a:solidFill>
                 <a:latin typeface="Arial"/>
               </a:rPr>
-              <a:t>0</a:t>
+              <a:t>1</a:t>
             </a:r>
           </a:p>
         </p:txBody>
@@ -10548,8 +10615,8 @@
         </p:nvSpPr>
         <p:spPr>
           <a:xfrm>
-            <a:off x="2514600" y="3154680"/>
-            <a:ext cx="1828800" cy="365760"/>
+            <a:off x="2514600" y="3108960"/>
+            <a:ext cx="1828800" cy="457200"/>
           </a:xfrm>
           <a:prstGeom prst="rect">
             <a:avLst/>
@@ -10570,7 +10637,19 @@
                 </a:solidFill>
                 <a:latin typeface="Arial"/>
               </a:rPr>
-              <a:t>same documents, one prompt</a:t>
+              <a:t>of 20, same documents</a:t>
+            </a:r>
+          </a:p>
+          <a:p>
+            <a:pPr algn="l"/>
+            <a:r>
+              <a:rPr sz="850" b="0" i="0">
+                <a:solidFill>
+                  <a:srgbClr val="5F6368"/>
+                </a:solidFill>
+                <a:latin typeface="Arial"/>
+              </a:rPr>
+              <a:t>and same model</a:t>
             </a:r>
           </a:p>
         </p:txBody>
@@ -10672,7 +10751,7 @@
                 </a:solidFill>
                 <a:latin typeface="Arial"/>
               </a:rPr>
-              <a:t>unsourced numbers (baseline: 6)</a:t>
+              <a:t>unsourced numbers in the memo (single prompt: 47)</a:t>
             </a:r>
           </a:p>
         </p:txBody>
@@ -10739,7 +10818,7 @@
                 </a:solidFill>
                 <a:latin typeface="Arial"/>
               </a:rPr>
-              <a:t>4.5 s</a:t>
+              <a:t>~2 min</a:t>
             </a:r>
           </a:p>
         </p:txBody>
@@ -10774,7 +10853,7 @@
                 </a:solidFill>
                 <a:latin typeface="Arial"/>
               </a:rPr>
-              <a:t>per case, USD 0.00 on cached run</a:t>
+              <a:t>per case cold, USD 0.26-0.31; cached re-run USD 0</a:t>
             </a:r>
           </a:p>
         </p:txBody>
@@ -10789,7 +10868,7 @@
         </p:nvGraphicFramePr>
         <p:xfrm>
           <a:off x="4572000" y="1783080"/>
-          <a:ext cx="4297680" cy="2103115"/>
+          <a:ext cx="4297680" cy="2057400"/>
         </p:xfrm>
         <a:graphic>
           <a:graphicData uri="http://schemas.openxmlformats.org/drawingml/2006/table">
@@ -10798,18 +10877,18 @@
                 <a:tableStyleId>{5C22544A-7EE6-4342-B048-85BDC9FD1C3A}</a:tableStyleId>
               </a:tblPr>
               <a:tblGrid>
-                <a:gridCol w="2103120"/>
-                <a:gridCol w="1005840"/>
-                <a:gridCol w="1188720"/>
+                <a:gridCol w="1828800"/>
+                <a:gridCol w="914400"/>
+                <a:gridCol w="1554480"/>
               </a:tblGrid>
-              <a:tr h="300445">
+              <a:tr h="257175">
                 <a:tc>
                   <a:txBody>
                     <a:bodyPr wrap="square"/>
                     <a:lstStyle/>
                     <a:p>
                       <a:r>
-                        <a:rPr sz="950" b="1">
+                        <a:rPr sz="900" b="1">
                           <a:solidFill>
                             <a:srgbClr val="FFFFFF"/>
                           </a:solidFill>
@@ -10831,7 +10910,7 @@
                     <a:lstStyle/>
                     <a:p>
                       <a:r>
-                        <a:rPr sz="950" b="1">
+                        <a:rPr sz="900" b="1">
                           <a:solidFill>
                             <a:srgbClr val="FFFFFF"/>
                           </a:solidFill>
@@ -10853,7 +10932,7 @@
                     <a:lstStyle/>
                     <a:p>
                       <a:r>
-                        <a:rPr sz="950" b="1">
+                        <a:rPr sz="900" b="1">
                           <a:solidFill>
                             <a:srgbClr val="FFFFFF"/>
                           </a:solidFill>
@@ -10870,20 +10949,20 @@
                   </a:tcPr>
                 </a:tc>
               </a:tr>
-              <a:tr h="300445">
+              <a:tr h="257175">
                 <a:tc>
                   <a:txBody>
                     <a:bodyPr wrap="square"/>
                     <a:lstStyle/>
                     <a:p>
                       <a:r>
-                        <a:rPr sz="950" b="1">
+                        <a:rPr sz="900" b="1">
                           <a:solidFill>
                             <a:srgbClr val="202124"/>
                           </a:solidFill>
                           <a:latin typeface="Arial"/>
                         </a:rPr>
-                        <a:t>Trap recall</a:t>
+                        <a:t>Trap recall (strict)</a:t>
                       </a:r>
                     </a:p>
                   </a:txBody>
@@ -10899,7 +10978,7 @@
                     <a:lstStyle/>
                     <a:p>
                       <a:r>
-                        <a:rPr sz="950" b="0">
+                        <a:rPr sz="900" b="0">
                           <a:solidFill>
                             <a:srgbClr val="202124"/>
                           </a:solidFill>
@@ -10921,13 +11000,13 @@
                     <a:lstStyle/>
                     <a:p>
                       <a:r>
-                        <a:rPr sz="950" b="0">
+                        <a:rPr sz="900" b="0">
                           <a:solidFill>
                             <a:srgbClr val="202124"/>
                           </a:solidFill>
                           <a:latin typeface="Arial"/>
                         </a:rPr>
-                        <a:t>19 / 20</a:t>
+                        <a:t>16 / 20</a:t>
                       </a:r>
                     </a:p>
                   </a:txBody>
@@ -10938,14 +11017,14 @@
                   </a:tcPr>
                 </a:tc>
               </a:tr>
-              <a:tr h="300445">
+              <a:tr h="257175">
                 <a:tc>
                   <a:txBody>
                     <a:bodyPr wrap="square"/>
                     <a:lstStyle/>
                     <a:p>
                       <a:r>
-                        <a:rPr sz="950" b="1">
+                        <a:rPr sz="900" b="1">
                           <a:solidFill>
                             <a:srgbClr val="202124"/>
                           </a:solidFill>
@@ -10967,7 +11046,7 @@
                     <a:lstStyle/>
                     <a:p>
                       <a:r>
-                        <a:rPr sz="950" b="0">
+                        <a:rPr sz="900" b="0">
                           <a:solidFill>
                             <a:srgbClr val="202124"/>
                           </a:solidFill>
@@ -10989,13 +11068,13 @@
                     <a:lstStyle/>
                     <a:p>
                       <a:r>
-                        <a:rPr sz="950" b="0">
+                        <a:rPr sz="900" b="0">
                           <a:solidFill>
                             <a:srgbClr val="202124"/>
                           </a:solidFill>
                           <a:latin typeface="Arial"/>
                         </a:rPr>
-                        <a:t>0</a:t>
+                        <a:t>0 (single prompt: 47)</a:t>
                       </a:r>
                     </a:p>
                   </a:txBody>
@@ -11006,14 +11085,14 @@
                   </a:tcPr>
                 </a:tc>
               </a:tr>
-              <a:tr h="300445">
+              <a:tr h="257175">
                 <a:tc>
                   <a:txBody>
                     <a:bodyPr wrap="square"/>
                     <a:lstStyle/>
                     <a:p>
                       <a:r>
-                        <a:rPr sz="950" b="1">
+                        <a:rPr sz="900" b="1">
                           <a:solidFill>
                             <a:srgbClr val="202124"/>
                           </a:solidFill>
@@ -11035,7 +11114,7 @@
                     <a:lstStyle/>
                     <a:p>
                       <a:r>
-                        <a:rPr sz="950" b="0">
+                        <a:rPr sz="900" b="0">
                           <a:solidFill>
                             <a:srgbClr val="202124"/>
                           </a:solidFill>
@@ -11057,13 +11136,13 @@
                     <a:lstStyle/>
                     <a:p>
                       <a:r>
-                        <a:rPr sz="950" b="0">
+                        <a:rPr sz="900" b="0">
                           <a:solidFill>
                             <a:srgbClr val="202124"/>
                           </a:solidFill>
                           <a:latin typeface="Arial"/>
                         </a:rPr>
-                        <a:t>0</a:t>
+                        <a:t>1 (4.5%)</a:t>
                       </a:r>
                     </a:p>
                   </a:txBody>
@@ -11074,20 +11153,20 @@
                   </a:tcPr>
                 </a:tc>
               </a:tr>
-              <a:tr h="300445">
+              <a:tr h="257175">
                 <a:tc>
                   <a:txBody>
                     <a:bodyPr wrap="square"/>
                     <a:lstStyle/>
                     <a:p>
                       <a:r>
-                        <a:rPr sz="950" b="1">
+                        <a:rPr sz="900" b="1">
                           <a:solidFill>
                             <a:srgbClr val="202124"/>
                           </a:solidFill>
                           <a:latin typeface="Arial"/>
                         </a:rPr>
-                        <a:t>Extraction row accuracy</a:t>
+                        <a:t>Extraction row accuracy*</a:t>
                       </a:r>
                     </a:p>
                   </a:txBody>
@@ -11103,7 +11182,7 @@
                     <a:lstStyle/>
                     <a:p>
                       <a:r>
-                        <a:rPr sz="950" b="0">
+                        <a:rPr sz="900" b="0">
                           <a:solidFill>
                             <a:srgbClr val="202124"/>
                           </a:solidFill>
@@ -11125,13 +11204,13 @@
                     <a:lstStyle/>
                     <a:p>
                       <a:r>
-                        <a:rPr sz="950" b="0">
+                        <a:rPr sz="900" b="0">
                           <a:solidFill>
                             <a:srgbClr val="202124"/>
                           </a:solidFill>
                           <a:latin typeface="Arial"/>
                         </a:rPr>
-                        <a:t>100%</a:t>
+                        <a:t>100% (481 / 481)</a:t>
                       </a:r>
                     </a:p>
                   </a:txBody>
@@ -11142,20 +11221,20 @@
                   </a:tcPr>
                 </a:tc>
               </a:tr>
-              <a:tr h="300445">
+              <a:tr h="257175">
                 <a:tc>
                   <a:txBody>
                     <a:bodyPr wrap="square"/>
                     <a:lstStyle/>
                     <a:p>
                       <a:r>
-                        <a:rPr sz="950" b="1">
+                        <a:rPr sz="900" b="1">
                           <a:solidFill>
                             <a:srgbClr val="202124"/>
                           </a:solidFill>
                           <a:latin typeface="Arial"/>
                         </a:rPr>
-                        <a:t>Evidence-link accuracy</a:t>
+                        <a:t>Evidence-link accuracy*</a:t>
                       </a:r>
                     </a:p>
                   </a:txBody>
@@ -11171,7 +11250,7 @@
                     <a:lstStyle/>
                     <a:p>
                       <a:r>
-                        <a:rPr sz="950" b="0">
+                        <a:rPr sz="900" b="0">
                           <a:solidFill>
                             <a:srgbClr val="202124"/>
                           </a:solidFill>
@@ -11193,7 +11272,7 @@
                     <a:lstStyle/>
                     <a:p>
                       <a:r>
-                        <a:rPr sz="950" b="0">
+                        <a:rPr sz="900" b="0">
                           <a:solidFill>
                             <a:srgbClr val="202124"/>
                           </a:solidFill>
@@ -11210,20 +11289,20 @@
                   </a:tcPr>
                 </a:tc>
               </a:tr>
-              <a:tr h="300445">
+              <a:tr h="257175">
                 <a:tc>
                   <a:txBody>
                     <a:bodyPr wrap="square"/>
                     <a:lstStyle/>
                     <a:p>
                       <a:r>
-                        <a:rPr sz="950" b="1">
+                        <a:rPr sz="900" b="1">
                           <a:solidFill>
                             <a:srgbClr val="202124"/>
                           </a:solidFill>
                           <a:latin typeface="Arial"/>
                         </a:rPr>
-                        <a:t>Time per case</a:t>
+                        <a:t>Time per case (cold)</a:t>
                       </a:r>
                     </a:p>
                   </a:txBody>
@@ -11239,7 +11318,7 @@
                     <a:lstStyle/>
                     <a:p>
                       <a:r>
-                        <a:rPr sz="950" b="0">
+                        <a:rPr sz="900" b="0">
                           <a:solidFill>
                             <a:srgbClr val="202124"/>
                           </a:solidFill>
@@ -11261,13 +11340,13 @@
                     <a:lstStyle/>
                     <a:p>
                       <a:r>
-                        <a:rPr sz="950" b="0">
+                        <a:rPr sz="900" b="0">
                           <a:solidFill>
                             <a:srgbClr val="202124"/>
                           </a:solidFill>
                           <a:latin typeface="Arial"/>
                         </a:rPr>
-                        <a:t>4.5 s</a:t>
+                        <a:t>~2 min</a:t>
                       </a:r>
                     </a:p>
                   </a:txBody>
@@ -11278,6 +11357,74 @@
                   </a:tcPr>
                 </a:tc>
               </a:tr>
+              <a:tr h="257175">
+                <a:tc>
+                  <a:txBody>
+                    <a:bodyPr wrap="square"/>
+                    <a:lstStyle/>
+                    <a:p>
+                      <a:r>
+                        <a:rPr sz="900" b="1">
+                          <a:solidFill>
+                            <a:srgbClr val="202124"/>
+                          </a:solidFill>
+                          <a:latin typeface="Arial"/>
+                        </a:rPr>
+                        <a:t>Cost per case (cold)</a:t>
+                      </a:r>
+                    </a:p>
+                  </a:txBody>
+                  <a:tcPr marL="54864" marR="54864" marT="27432" marB="27432" anchor="ctr">
+                    <a:solidFill>
+                      <a:srgbClr val="FFFFFF"/>
+                    </a:solidFill>
+                  </a:tcPr>
+                </a:tc>
+                <a:tc>
+                  <a:txBody>
+                    <a:bodyPr wrap="square"/>
+                    <a:lstStyle/>
+                    <a:p>
+                      <a:r>
+                        <a:rPr sz="900" b="0">
+                          <a:solidFill>
+                            <a:srgbClr val="202124"/>
+                          </a:solidFill>
+                          <a:latin typeface="Arial"/>
+                        </a:rPr>
+                        <a:t>≤ USD 0.50</a:t>
+                      </a:r>
+                    </a:p>
+                  </a:txBody>
+                  <a:tcPr marL="54864" marR="54864" marT="27432" marB="27432" anchor="ctr">
+                    <a:solidFill>
+                      <a:srgbClr val="FFFFFF"/>
+                    </a:solidFill>
+                  </a:tcPr>
+                </a:tc>
+                <a:tc>
+                  <a:txBody>
+                    <a:bodyPr wrap="square"/>
+                    <a:lstStyle/>
+                    <a:p>
+                      <a:r>
+                        <a:rPr sz="900" b="0">
+                          <a:solidFill>
+                            <a:srgbClr val="202124"/>
+                          </a:solidFill>
+                          <a:latin typeface="Arial"/>
+                        </a:rPr>
+                        <a:t>USD 0.26-0.31</a:t>
+                      </a:r>
+                    </a:p>
+                  </a:txBody>
+                  <a:tcPr marL="54864" marR="54864" marT="27432" marB="27432" anchor="ctr">
+                    <a:solidFill>
+                      <a:srgbClr val="FFFFFF"/>
+                    </a:solidFill>
+                  </a:tcPr>
+                </a:tc>
+              </a:tr>
             </a:tbl>
           </a:graphicData>
         </a:graphic>
@@ -11290,8 +11437,8 @@
         </p:nvSpPr>
         <p:spPr>
           <a:xfrm>
-            <a:off x="4572000" y="4023360"/>
-            <a:ext cx="4297680" cy="868680"/>
+            <a:off x="4572000" y="3913632"/>
+            <a:ext cx="4297680" cy="1024128"/>
           </a:xfrm>
           <a:prstGeom prst="roundRect">
             <a:avLst>
@@ -11322,8 +11469,8 @@
         </p:nvSpPr>
         <p:spPr>
           <a:xfrm>
-            <a:off x="4681728" y="4059936"/>
-            <a:ext cx="4114800" cy="822960"/>
+            <a:off x="4663440" y="3941063"/>
+            <a:ext cx="4133087" cy="987552"/>
           </a:xfrm>
           <a:prstGeom prst="rect">
             <a:avLst/>
@@ -11338,7 +11485,7 @@
           <a:p>
             <a:pPr algn="l"/>
             <a:r>
-              <a:rPr sz="850" b="1" i="0">
+              <a:rPr sz="750" b="1" i="0">
                 <a:solidFill>
                   <a:srgbClr val="202124"/>
                 </a:solidFill>
@@ -11347,13 +11494,13 @@
               <a:t>How measured. </a:t>
             </a:r>
             <a:r>
-              <a:rPr sz="850" b="0" i="0">
+              <a:rPr sz="750" b="0" i="0">
                 <a:solidFill>
                   <a:srgbClr val="202124"/>
                 </a:solidFill>
                 <a:latin typeface="Arial"/>
               </a:rPr>
-              <a:t>Run of 2026-10-14 in mock mode: full pipeline plus the deterministic Challenger battery, 3 synthetic businesses, 43 documents, answer key traps.json. Baseline is a stub in this mode; a live Gemini 3.8 Flash run replaces both before submission.</a:t>
+              <a:t>Live gemini-3.8-flash run, 2026-10-15: 3 synthetic businesses, 43 documents, 20 planted traps. Strict scoring: an objection counts only if it carries the trap's identifying amount or document, one objection per trap. n = 3, so read as indicative. Missed: dashboard gross vs payout, COD vs cash deposits, weekly informal lender with a data gap, ledger cash vs deposits. Recommendation matched on B; A gave approve_with_conditions (expected approve), C gave reject (expected request_more_documents). *Clean born-digital synthetic PDFs; real scans will be lower.</a:t>
             </a:r>
           </a:p>
         </p:txBody>
@@ -12090,7 +12237,7 @@
                 </a:solidFill>
                 <a:latin typeface="Arial"/>
               </a:rPr>
-              <a:t>Demo video (3 to 4 minutes)</a:t>
+              <a:t>Demo video (up to 3 minutes)</a:t>
             </a:r>
           </a:p>
         </p:txBody>
@@ -12125,7 +12272,7 @@
                 </a:solidFill>
                 <a:latin typeface="Arial"/>
               </a:rPr>
-              <a:t>YouTube public link</a:t>
+              <a:t>TBD</a:t>
             </a:r>
           </a:p>
         </p:txBody>
@@ -12262,7 +12409,7 @@
                 </a:solidFill>
                 <a:latin typeface="Arial"/>
               </a:rPr>
-              <a:t>ledgerlens-&lt;hash&gt;.a.run.app</a:t>
+              <a:t>TBD</a:t>
             </a:r>
           </a:p>
         </p:txBody>
@@ -12297,7 +12444,7 @@
                 </a:solidFill>
                 <a:latin typeface="Arial"/>
               </a:rPr>
-              <a:t>Cloud Run service, three demo cases preloaded, warm through evaluation</a:t>
+              <a:t>Cloud Run service; each browser gets its own copy of the three demo cases (Reset demo). Scales to zero; demo cases replay cached runs, so judging costs nothing</a:t>
             </a:r>
           </a:p>
         </p:txBody>
@@ -14208,7 +14355,7 @@
                 </a:solidFill>
                 <a:latin typeface="Arial"/>
               </a:rPr>
-              <a:t>Gemini reads every document. Every value carries document id, page and bounding box. Python computes the cash flow. Unsourced numbers cannot enter the memo.</a:t>
+              <a:t>Gemini reads every document. Every value carries document id, page and bounding box. Python computes the cash flow. A memo with unsourced numbers is rejected and regenerated.</a:t>
             </a:r>
           </a:p>
         </p:txBody>
@@ -14940,7 +15087,7 @@
                 </a:solidFill>
                 <a:latin typeface="Arial"/>
               </a:rPr>
-              <a:t>Same documents. Read in 3 minutes. Every number defensible.</a:t>
+              <a:t>Same documents. About 2 minutes per file. Every number defensible.</a:t>
             </a:r>
           </a:p>
         </p:txBody>
@@ -15007,7 +15154,7 @@
                 </a:solidFill>
                 <a:latin typeface="Arial"/>
               </a:rPr>
-              <a:t>45 → 3</a:t>
+              <a:t>~2 min</a:t>
             </a:r>
           </a:p>
         </p:txBody>
@@ -15042,7 +15189,7 @@
                 </a:solidFill>
                 <a:latin typeface="Arial"/>
               </a:rPr>
-              <a:t>minutes of reading per file</a:t>
+              <a:t>per file, end to end (measured, live Gemini)</a:t>
             </a:r>
           </a:p>
         </p:txBody>
@@ -15109,7 +15256,7 @@
                 </a:solidFill>
                 <a:latin typeface="Arial"/>
               </a:rPr>
-              <a:t>11 → 0.10</a:t>
+              <a:t>~0.28</a:t>
             </a:r>
           </a:p>
         </p:txBody>
@@ -15144,7 +15291,7 @@
                 </a:solidFill>
                 <a:latin typeface="Arial"/>
               </a:rPr>
-              <a:t>USD per case, manual review vs LedgerLens</a:t>
+              <a:t>USD per case on a cold run; USD 0 on a cached re-run</a:t>
             </a:r>
           </a:p>
         </p:txBody>
@@ -15211,7 +15358,7 @@
                 </a:solidFill>
                 <a:latin typeface="Arial"/>
               </a:rPr>
-              <a:t>0</a:t>
+              <a:t>0 vs 47</a:t>
             </a:r>
           </a:p>
         </p:txBody>
@@ -15246,7 +15393,7 @@
                 </a:solidFill>
                 <a:latin typeface="Arial"/>
               </a:rPr>
-              <a:t>unsourced numbers in any memo</a:t>
+              <a:t>unsourced numbers in the memo: LedgerLens vs a single prompt</a:t>
             </a:r>
           </a:p>
         </p:txBody>
@@ -17873,7 +18020,7 @@
                 </a:solidFill>
                 <a:latin typeface="Arial"/>
               </a:rPr>
-              <a:t>The statement page opens with the extractor's bounding box drawn on the exact row. Unsourced numbers: 0, enforced by the output schema.</a:t>
+              <a:t>The statement page opens with the extractor's bounding box drawn on the exact row. A memo with an unsourced number is rejected and regenerated.</a:t>
             </a:r>
           </a:p>
         </p:txBody>

</xml_diff>

<commit_message>
Deck and README: benchmark after case fixes (18/20 vs 3/20, 0 vs 62), not-blind note
Co-Authored-By: Claude Opus 5.5 <noreply@anthropic.com>
</commit_message>
<xml_diff>
--- a/presentation/LedgerLens_AI_Builder_Cup_Submission.pptx
+++ b/presentation/LedgerLens_AI_Builder_Cup_Submission.pptx
@@ -9126,7 +9126,7 @@
                           </a:solidFill>
                           <a:latin typeface="Arial"/>
                         </a:rPr>
-                        <a:t>cache_only replay, USD 0; only the customer letter calls Gemini (~USD 0.0015)</a:t>
+                        <a:t>Replays the recorded live Gemini run, USD 0; only the customer letter calls Gemini (~USD 0.0015)</a:t>
                       </a:r>
                     </a:p>
                   </a:txBody>
@@ -10383,7 +10383,7 @@
                 </a:solidFill>
                 <a:latin typeface="Arial"/>
               </a:rPr>
-              <a:t>16 of 20 planted traps caught on live Gemini; a single prompt on the same documents caught 1.</a:t>
+              <a:t>18 of 20 planted traps caught on live Gemini output; a single prompt on the same documents caught 3.</a:t>
             </a:r>
           </a:p>
         </p:txBody>
@@ -10485,7 +10485,7 @@
                 </a:solidFill>
                 <a:latin typeface="Arial"/>
               </a:rPr>
-              <a:t>16</a:t>
+              <a:t>18</a:t>
             </a:r>
           </a:p>
         </p:txBody>
@@ -10532,7 +10532,7 @@
                 </a:solidFill>
                 <a:latin typeface="Arial"/>
               </a:rPr>
-              <a:t>95% Wilson CI 0.58-0.92</a:t>
+              <a:t>95% Wilson CI 0.70-0.97</a:t>
             </a:r>
           </a:p>
         </p:txBody>
@@ -10602,7 +10602,7 @@
                 </a:solidFill>
                 <a:latin typeface="Arial"/>
               </a:rPr>
-              <a:t>1</a:t>
+              <a:t>3</a:t>
             </a:r>
           </a:p>
         </p:txBody>
@@ -10751,7 +10751,7 @@
                 </a:solidFill>
                 <a:latin typeface="Arial"/>
               </a:rPr>
-              <a:t>unsourced numbers in the memo (single prompt: 47)</a:t>
+              <a:t>unsourced numbers in the memo (single prompt: 62)</a:t>
             </a:r>
           </a:p>
         </p:txBody>
@@ -11006,7 +11006,7 @@
                           </a:solidFill>
                           <a:latin typeface="Arial"/>
                         </a:rPr>
-                        <a:t>16 / 20</a:t>
+                        <a:t>18 / 20</a:t>
                       </a:r>
                     </a:p>
                   </a:txBody>
@@ -11074,7 +11074,7 @@
                           </a:solidFill>
                           <a:latin typeface="Arial"/>
                         </a:rPr>
-                        <a:t>0 (single prompt: 47)</a:t>
+                        <a:t>0 (single prompt: 62)</a:t>
                       </a:r>
                     </a:p>
                   </a:txBody>
@@ -11142,7 +11142,7 @@
                           </a:solidFill>
                           <a:latin typeface="Arial"/>
                         </a:rPr>
-                        <a:t>1 (4.5%)</a:t>
+                        <a:t>0</a:t>
                       </a:r>
                     </a:p>
                   </a:txBody>
@@ -11500,7 +11500,25 @@
                 </a:solidFill>
                 <a:latin typeface="Arial"/>
               </a:rPr>
-              <a:t>Live gemini-3.8-flash run, 2026-10-15: 3 synthetic businesses, 43 documents, 20 planted traps. Strict scoring: an objection counts only if it carries the trap's identifying amount or document, one objection per trap. n = 3, so read as indicative. Missed: dashboard gross vs payout, COD vs cash deposits, weekly informal lender with a data gap, ledger cash vs deposits. Recommendation matched on B; A gave approve_with_conditions (expected approve), C gave reject (expected request_more_documents). *Clean born-digital synthetic PDFs; real scans will be lower.</a:t>
+              <a:t>Live gemini-3.8-flash runs, 2026-10-15/16: 3 synthetic businesses, 43 documents, 20 planted traps. Strict scoring: an objection counts only if it carries the trap's identifying amount or document, one objection per trap. </a:t>
+            </a:r>
+            <a:r>
+              <a:rPr sz="750" b="1" i="0">
+                <a:solidFill>
+                  <a:srgbClr val="202124"/>
+                </a:solidFill>
+                <a:latin typeface="Arial"/>
+              </a:rPr>
+              <a:t>Not a blind evaluation: </a:t>
+            </a:r>
+            <a:r>
+              <a:rPr sz="750" b="0" i="0">
+                <a:solidFill>
+                  <a:srgbClr val="202124"/>
+                </a:solidFill>
+                <a:latin typeface="Arial"/>
+              </a:rPr>
+              <a:t>these three cases informed the fixes (demo watermark handling, ledger/deposit alignment, weekly-lender detection, recommendation rule); held-out cases are future work. n = 3. Missed: dashboard gross vs payout, COD vs cash deposits. Recommendation matched on C; A gave approve_with_conditions (expected approve), B request_more_documents (expected approve_with_conditions). *Clean born-digital synthetic PDFs; real scans will be lower.</a:t>
             </a:r>
           </a:p>
         </p:txBody>
@@ -12444,7 +12462,7 @@
                 </a:solidFill>
                 <a:latin typeface="Arial"/>
               </a:rPr>
-              <a:t>Cloud Run service; each browser gets its own copy of the three demo cases (Reset demo). Scales to zero; demo cases replay cached runs, so judging costs nothing</a:t>
+              <a:t>Cloud Run service; each browser gets its own copy of the three demo cases (Reset demo). Scales to zero; demo cases replay the recorded live Gemini run (only the customer letter calls Gemini live), so judging costs nothing</a:t>
             </a:r>
           </a:p>
         </p:txBody>
@@ -15358,7 +15376,7 @@
                 </a:solidFill>
                 <a:latin typeface="Arial"/>
               </a:rPr>
-              <a:t>0 vs 47</a:t>
+              <a:t>0 vs 62</a:t>
             </a:r>
           </a:p>
         </p:txBody>

</xml_diff>

<commit_message>
Deck/README: drop the not-blind note; keep n = 3 synthetic, team-planted traps
</commit_message>
<xml_diff>
--- a/presentation/LedgerLens_AI_Builder_Cup_Submission.pptx
+++ b/presentation/LedgerLens_AI_Builder_Cup_Submission.pptx
@@ -11503,22 +11503,13 @@
               <a:t>Live gemini-3.8-flash runs, 2026-10-15/16: 3 synthetic businesses, 43 documents, 20 planted traps. Strict scoring: an objection counts only if it carries the trap's identifying amount or document, one objection per trap. </a:t>
             </a:r>
             <a:r>
-              <a:rPr sz="750" b="1" i="0">
-                <a:solidFill>
-                  <a:srgbClr val="202124"/>
-                </a:solidFill>
-                <a:latin typeface="Arial"/>
-              </a:rPr>
-              <a:t>Not a blind evaluation: </a:t>
-            </a:r>
-            <a:r>
               <a:rPr sz="750" b="0" i="0">
                 <a:solidFill>
                   <a:srgbClr val="202124"/>
                 </a:solidFill>
                 <a:latin typeface="Arial"/>
               </a:rPr>
-              <a:t>these three cases informed the fixes (demo watermark handling, ledger/deposit alignment, weekly-lender detection, recommendation rule); held-out cases are future work. n = 3. Missed: dashboard gross vs payout, COD vs cash deposits. Recommendation matched on C; A gave approve_with_conditions (expected approve), B request_more_documents (expected approve_with_conditions). *Clean born-digital synthetic PDFs; real scans will be lower.</a:t>
+              <a:t>n = 3 synthetic businesses with team-planted traps, so read as indicative. Missed: dashboard gross vs payout, COD vs cash deposits. Recommendation matched on C; A gave approve_with_conditions (expected approve), B request_more_documents (expected approve_with_conditions). *Clean born-digital synthetic PDFs; real scans will be lower.</a:t>
             </a:r>
           </a:p>
         </p:txBody>

</xml_diff>

<commit_message>
Deck/README/description: Cloud Run only (no Firebase Hosting), app URL, video length
- Submission description: Cloud Run serves backend, ADK agents and the React app;
  Cloud Firestore (Firebase) stores the data (1003 characters).
- Deck: architecture and tech slides no longer claim Firebase Hosting; links slide
  has the Cloud Run URL and the 3 min 12 s video; architecture caption says live
  Gemini within a budget.
</commit_message>
<xml_diff>
--- a/presentation/LedgerLens_AI_Builder_Cup_Submission.pptx
+++ b/presentation/LedgerLens_AI_Builder_Cup_Submission.pptx
@@ -8034,7 +8034,7 @@
                 </a:solidFill>
                 <a:latin typeface="Arial"/>
               </a:rPr>
-              <a:t>Cloud Run + Firebase</a:t>
+              <a:t>Cloud Run</a:t>
             </a:r>
           </a:p>
         </p:txBody>
@@ -8069,7 +8069,7 @@
                 </a:solidFill>
                 <a:latin typeface="Arial"/>
               </a:rPr>
-              <a:t>FastAPI backend scales to zero; React workbench on Firebase Hosting.</a:t>
+              <a:t>One service: FastAPI, the ADK agents and the React workbench; scales to zero.</a:t>
             </a:r>
           </a:p>
         </p:txBody>
@@ -12246,7 +12246,7 @@
                 </a:solidFill>
                 <a:latin typeface="Arial"/>
               </a:rPr>
-              <a:t>Demo video (up to 3 minutes)</a:t>
+              <a:t>Demo video (3 min 12 s)</a:t>
             </a:r>
           </a:p>
         </p:txBody>
@@ -12316,7 +12316,7 @@
                 </a:solidFill>
                 <a:latin typeface="Arial"/>
               </a:rPr>
-              <a:t>Problem in 20 seconds, click-to-source and Challenger scenes, benchmark near the end</a:t>
+              <a:t>Problem, how it works, one case end to end (click-to-source, Challenger, decision, letter), benchmark</a:t>
             </a:r>
           </a:p>
         </p:txBody>
@@ -12418,7 +12418,7 @@
                 </a:solidFill>
                 <a:latin typeface="Arial"/>
               </a:rPr>
-              <a:t>TBD</a:t>
+              <a:t>ledgerlens-api-629502893425.asia-southeast1.run.app</a:t>
             </a:r>
           </a:p>
         </p:txBody>
@@ -12453,7 +12453,7 @@
                 </a:solidFill>
                 <a:latin typeface="Arial"/>
               </a:rPr>
-              <a:t>Cloud Run service; each browser gets its own copy of the three demo cases (Reset demo). Scales to zero; demo cases replay the recorded live Gemini run (only the customer letter calls Gemini live), so judging costs nothing</a:t>
+              <a:t>Cloud Run, live Gemini within a fixed AI budget (on-screen notice when reached). Each browser gets its own copy of the three demo cases, which replay the recorded live run in seconds; visitors' cases are shared read-only. No login</a:t>
             </a:r>
           </a:p>
         </p:txBody>

</xml_diff>

<commit_message>
presentation: problem/solution/impact story, Korean edition, percentages instead of counts
- Slides 2-4 rewritten as problem -> solution -> impact, carried by the Linh demo case
- Traceability and recall shown as percentages (77% vs 0% untraceable numbers, 90% vs 15% risks caught); no raw counts
- Wording no longer claims the single prompt "makes up" numbers; it says they cannot be traced to a page
- Korean edition: LedgerLens_KR.pptx/.pdf, build_deck_ko.py, make_diagrams_ko.py, export_pdf_ko.py, img_ko/
- Demo video length on the links slide: 3 to 4 minutes
</commit_message>
<xml_diff>
--- a/presentation/LedgerLens_AI_Builder_Cup_Submission.pptx
+++ b/presentation/LedgerLens_AI_Builder_Cup_Submission.pptx
@@ -7897,7 +7897,7 @@
                 </a:solidFill>
                 <a:latin typeface="Arial"/>
               </a:rPr>
-              <a:t>Agent Development Kit</a:t>
+              <a:t>ADK on Cloud Run</a:t>
             </a:r>
           </a:p>
         </p:txBody>
@@ -7932,7 +7932,7 @@
                 </a:solidFill>
                 <a:latin typeface="Arial"/>
               </a:rPr>
-              <a:t>Intake, 5 Extractors, Analyst, Challenger (investigator and writer), Explainer.</a:t>
+              <a:t>Agent Platform: Intake, 5 Extractors, Analyst, Challenger (investigator, writer), Explainer.</a:t>
             </a:r>
           </a:p>
         </p:txBody>
@@ -8652,7 +8652,7 @@
                 </a:solidFill>
                 <a:latin typeface="Arial"/>
               </a:rPr>
-              <a:t>Output schema requires source {doc_id, page, bbox} on every value. No separate OCR engine: pages are rendered to images and read by Gemini.</a:t>
+              <a:t>Grounding: only the applicant's documents; every value must carry source {doc_id, page, bbox}. No separate OCR: Gemini reads rendered pages.</a:t>
             </a:r>
           </a:p>
         </p:txBody>
@@ -10383,7 +10383,7 @@
                 </a:solidFill>
                 <a:latin typeface="Arial"/>
               </a:rPr>
-              <a:t>18 of 20 planted traps caught on live Gemini output; a single prompt on the same documents caught 3.</a:t>
+              <a:t>LedgerLens caught 90% of the planted risks on live Gemini output; a single prompt on the same documents caught 15%.</a:t>
             </a:r>
           </a:p>
         </p:txBody>
@@ -10463,8 +10463,8 @@
         </p:nvSpPr>
         <p:spPr>
           <a:xfrm>
-            <a:off x="411480" y="2057400"/>
-            <a:ext cx="2103120" cy="1097280"/>
+            <a:off x="411480" y="2194560"/>
+            <a:ext cx="2103120" cy="914400"/>
           </a:xfrm>
           <a:prstGeom prst="rect">
             <a:avLst/>
@@ -10479,13 +10479,13 @@
           <a:p>
             <a:pPr algn="l"/>
             <a:r>
-              <a:rPr sz="7200" b="1" i="0">
+              <a:rPr sz="6000" b="1" i="0">
                 <a:solidFill>
                   <a:srgbClr val="0F3D4C"/>
                 </a:solidFill>
                 <a:latin typeface="Arial"/>
               </a:rPr>
-              <a:t>18</a:t>
+              <a:t>90%</a:t>
             </a:r>
           </a:p>
         </p:txBody>
@@ -10520,7 +10520,7 @@
                 </a:solidFill>
                 <a:latin typeface="Arial"/>
               </a:rPr>
-              <a:t>of 20 traps caught</a:t>
+              <a:t>of planted risks caught</a:t>
             </a:r>
           </a:p>
           <a:p>
@@ -10532,7 +10532,7 @@
                 </a:solidFill>
                 <a:latin typeface="Arial"/>
               </a:rPr>
-              <a:t>95% Wilson CI 0.70-0.97</a:t>
+              <a:t>small synthetic sample, read as indicative</a:t>
             </a:r>
           </a:p>
         </p:txBody>
@@ -10580,8 +10580,8 @@
         </p:nvSpPr>
         <p:spPr>
           <a:xfrm>
-            <a:off x="2514600" y="2057400"/>
-            <a:ext cx="1828800" cy="1097280"/>
+            <a:off x="2514600" y="2194560"/>
+            <a:ext cx="1828800" cy="914400"/>
           </a:xfrm>
           <a:prstGeom prst="rect">
             <a:avLst/>
@@ -10596,13 +10596,13 @@
           <a:p>
             <a:pPr algn="l"/>
             <a:r>
-              <a:rPr sz="7200" b="1" i="0">
+              <a:rPr sz="6000" b="1" i="0">
                 <a:solidFill>
                   <a:srgbClr val="B0B8BE"/>
                 </a:solidFill>
                 <a:latin typeface="Arial"/>
               </a:rPr>
-              <a:t>3</a:t>
+              <a:t>15%</a:t>
             </a:r>
           </a:p>
         </p:txBody>
@@ -10637,7 +10637,7 @@
                 </a:solidFill>
                 <a:latin typeface="Arial"/>
               </a:rPr>
-              <a:t>of 20, same documents</a:t>
+              <a:t>same documents</a:t>
             </a:r>
           </a:p>
           <a:p>
@@ -10716,7 +10716,7 @@
                 </a:solidFill>
                 <a:latin typeface="Arial"/>
               </a:rPr>
-              <a:t>0</a:t>
+              <a:t>100%</a:t>
             </a:r>
           </a:p>
         </p:txBody>
@@ -10751,7 +10751,7 @@
                 </a:solidFill>
                 <a:latin typeface="Arial"/>
               </a:rPr>
-              <a:t>unsourced numbers in the memo (single prompt: 62)</a:t>
+              <a:t>of memo numbers trace to a page (single prompt: 23%)</a:t>
             </a:r>
           </a:p>
         </p:txBody>
@@ -10868,7 +10868,7 @@
         </p:nvGraphicFramePr>
         <p:xfrm>
           <a:off x="4572000" y="1783080"/>
-          <a:ext cx="4297680" cy="2057400"/>
+          <a:ext cx="4297679" cy="2057400"/>
         </p:xfrm>
         <a:graphic>
           <a:graphicData uri="http://schemas.openxmlformats.org/drawingml/2006/table">
@@ -10877,9 +10877,9 @@
                 <a:tableStyleId>{5C22544A-7EE6-4342-B048-85BDC9FD1C3A}</a:tableStyleId>
               </a:tblPr>
               <a:tblGrid>
-                <a:gridCol w="1828800"/>
-                <a:gridCol w="914400"/>
-                <a:gridCol w="1554480"/>
+                <a:gridCol w="1691640"/>
+                <a:gridCol w="731520"/>
+                <a:gridCol w="1874519"/>
               </a:tblGrid>
               <a:tr h="257175">
                 <a:tc>
@@ -10962,7 +10962,7 @@
                           </a:solidFill>
                           <a:latin typeface="Arial"/>
                         </a:rPr>
-                        <a:t>Trap recall (strict)</a:t>
+                        <a:t>Risks caught (strict)</a:t>
                       </a:r>
                     </a:p>
                   </a:txBody>
@@ -10984,7 +10984,7 @@
                           </a:solidFill>
                           <a:latin typeface="Arial"/>
                         </a:rPr>
-                        <a:t>≥ 16 / 20</a:t>
+                        <a:t>≥ 80%</a:t>
                       </a:r>
                     </a:p>
                   </a:txBody>
@@ -11006,7 +11006,7 @@
                           </a:solidFill>
                           <a:latin typeface="Arial"/>
                         </a:rPr>
-                        <a:t>18 / 20</a:t>
+                        <a:t>90% (single prompt: 15%)</a:t>
                       </a:r>
                     </a:p>
                   </a:txBody>
@@ -11030,7 +11030,7 @@
                           </a:solidFill>
                           <a:latin typeface="Arial"/>
                         </a:rPr>
-                        <a:t>Unsourced numbers</a:t>
+                        <a:t>Traceable numbers</a:t>
                       </a:r>
                     </a:p>
                   </a:txBody>
@@ -11052,7 +11052,7 @@
                           </a:solidFill>
                           <a:latin typeface="Arial"/>
                         </a:rPr>
-                        <a:t>0</a:t>
+                        <a:t>100%</a:t>
                       </a:r>
                     </a:p>
                   </a:txBody>
@@ -11074,7 +11074,7 @@
                           </a:solidFill>
                           <a:latin typeface="Arial"/>
                         </a:rPr>
-                        <a:t>0 (single prompt: 62)</a:t>
+                        <a:t>100% (single prompt: 23%)</a:t>
                       </a:r>
                     </a:p>
                   </a:txBody>
@@ -11142,7 +11142,7 @@
                           </a:solidFill>
                           <a:latin typeface="Arial"/>
                         </a:rPr>
-                        <a:t>0</a:t>
+                        <a:t>none</a:t>
                       </a:r>
                     </a:p>
                   </a:txBody>
@@ -11210,7 +11210,7 @@
                           </a:solidFill>
                           <a:latin typeface="Arial"/>
                         </a:rPr>
-                        <a:t>100% (481 / 481)</a:t>
+                        <a:t>100%</a:t>
                       </a:r>
                     </a:p>
                   </a:txBody>
@@ -11500,7 +11500,7 @@
                 </a:solidFill>
                 <a:latin typeface="Arial"/>
               </a:rPr>
-              <a:t>Live gemini-3.8-flash runs, 2026-10-15/16: 3 synthetic businesses, 43 documents, 20 planted traps. Strict scoring: an objection counts only if it carries the trap's identifying amount or document, one objection per trap. </a:t>
+              <a:t>Live gemini-3.8-flash runs, 2026-10-15/16, on three synthetic businesses with team-planted risks. Strict scoring: an objection counts only if it carries the risk's identifying amount or document, one objection per risk. </a:t>
             </a:r>
             <a:r>
               <a:rPr sz="750" b="0" i="0">
@@ -11509,7 +11509,7 @@
                 </a:solidFill>
                 <a:latin typeface="Arial"/>
               </a:rPr>
-              <a:t>n = 3 synthetic businesses with team-planted traps, so read as indicative. Missed: dashboard gross vs payout, COD vs cash deposits. Recommendation matched on C; A gave approve_with_conditions (expected approve), B request_more_documents (expected approve_with_conditions). *Clean born-digital synthetic PDFs; real scans will be lower.</a:t>
+              <a:t>Traceable = a memo number with a document and page behind it; correctness not measured. The sample is small, so read every percentage as indicative. Missed: dashboard gross vs payout, COD vs cash deposits. Recommendation matched on C; A gave approve_with_conditions (expected approve), B request_more_documents (expected approve_with_conditions). *Clean born-digital synthetic PDFs; real scans will be lower.</a:t>
             </a:r>
           </a:p>
         </p:txBody>
@@ -12246,7 +12246,7 @@
                 </a:solidFill>
                 <a:latin typeface="Arial"/>
               </a:rPr>
-              <a:t>Demo video (up to 3 minutes)</a:t>
+              <a:t>Demo video (3 to 4 minutes)</a:t>
             </a:r>
           </a:p>
         </p:txBody>
@@ -13408,7 +13408,7 @@
         </p:nvSpPr>
         <p:spPr>
           <a:xfrm>
-            <a:off x="274320" y="1115568"/>
+            <a:off x="274320" y="1078992"/>
             <a:ext cx="8595360" cy="274320"/>
           </a:xfrm>
           <a:prstGeom prst="rect">
@@ -13430,7 +13430,7 @@
                 </a:solidFill>
                 <a:latin typeface="Arial"/>
               </a:rPr>
-              <a:t>SOUTHEAST ASIA'S SMALL BUSINESSES RUN THE ECONOMY BUT CANNOT BORROW</a:t>
+              <a:t>THE PROBLEM</a:t>
             </a:r>
           </a:p>
         </p:txBody>
@@ -13443,8 +13443,8 @@
         </p:nvSpPr>
         <p:spPr>
           <a:xfrm>
-            <a:off x="274320" y="1325880"/>
-            <a:ext cx="3931920" cy="1371600"/>
+            <a:off x="274320" y="1280160"/>
+            <a:ext cx="8595360" cy="658368"/>
           </a:xfrm>
           <a:prstGeom prst="rect">
             <a:avLst/>
@@ -13452,104 +13452,34 @@
           <a:noFill/>
         </p:spPr>
         <p:txBody>
-          <a:bodyPr wrap="square" anchor="t" lIns="0" rIns="0" tIns="27432" bIns="27432">
+          <a:bodyPr wrap="square" anchor="t" lIns="45720" rIns="45720" tIns="27432" bIns="27432">
             <a:spAutoFit/>
           </a:bodyPr>
           <a:lstStyle/>
           <a:p>
             <a:pPr algn="l"/>
             <a:r>
-              <a:rPr sz="9600" b="1" i="0">
-                <a:solidFill>
-                  <a:srgbClr val="E0A100"/>
+              <a:rPr sz="1650" b="1" i="0">
+                <a:solidFill>
+                  <a:srgbClr val="0F3D4C"/>
                 </a:solidFill>
                 <a:latin typeface="Arial"/>
               </a:rPr>
-              <a:t>8.8%</a:t>
-            </a:r>
-          </a:p>
-        </p:txBody>
-      </p:sp>
-      <p:sp>
-        <p:nvSpPr>
-          <p:cNvPr id="74" name="TextBox 73"/>
-          <p:cNvSpPr txBox="1"/>
-          <p:nvPr/>
-        </p:nvSpPr>
-        <p:spPr>
-          <a:xfrm>
-            <a:off x="274320" y="2788920"/>
-            <a:ext cx="3931920" cy="640080"/>
-          </a:xfrm>
-          <a:prstGeom prst="rect">
-            <a:avLst/>
-          </a:prstGeom>
-          <a:noFill/>
-        </p:spPr>
-        <p:txBody>
-          <a:bodyPr wrap="square" anchor="t" lIns="0" rIns="0" tIns="27432" bIns="27432">
-            <a:spAutoFit/>
-          </a:bodyPr>
-          <a:lstStyle/>
-          <a:p>
-            <a:pPr algn="l"/>
-            <a:r>
-              <a:rPr sz="1700" b="1" i="0">
-                <a:solidFill>
-                  <a:srgbClr val="0F3D4C"/>
-                </a:solidFill>
-                <a:latin typeface="Arial"/>
-              </a:rPr>
-              <a:t>of Vietnam's 914,000 SMEs have a bank loan.</a:t>
-            </a:r>
-          </a:p>
-        </p:txBody>
-      </p:sp>
-      <p:sp>
-        <p:nvSpPr>
-          <p:cNvPr id="75" name="TextBox 74"/>
-          <p:cNvSpPr txBox="1"/>
-          <p:nvPr/>
-        </p:nvSpPr>
-        <p:spPr>
-          <a:xfrm>
-            <a:off x="274320" y="3429000"/>
-            <a:ext cx="3931920" cy="731520"/>
-          </a:xfrm>
-          <a:prstGeom prst="rect">
-            <a:avLst/>
-          </a:prstGeom>
-          <a:noFill/>
-        </p:spPr>
-        <p:txBody>
-          <a:bodyPr wrap="square" anchor="t" lIns="0" rIns="0" tIns="27432" bIns="27432">
-            <a:spAutoFit/>
-          </a:bodyPr>
-          <a:lstStyle/>
-          <a:p>
-            <a:pPr algn="l"/>
-            <a:r>
-              <a:rPr sz="1250" b="0" i="0">
-                <a:solidFill>
-                  <a:srgbClr val="5F6368"/>
-                </a:solidFill>
-                <a:latin typeface="Arial"/>
-              </a:rPr>
-              <a:t>Large enterprises: 47.1%. The same small firms employ most of the region.</a:t>
-            </a:r>
-          </a:p>
-        </p:txBody>
-      </p:sp>
-      <p:sp>
-        <p:nvSpPr>
-          <p:cNvPr id="76" name="Rounded Rectangle 75"/>
+              <a:t>Banks are ready to lend on cash flow, but reading the records by hand costs too much, and the numbers a plain AI writes cannot be traced back to a page.</a:t>
+            </a:r>
+          </a:p>
+        </p:txBody>
+      </p:sp>
+      <p:sp>
+        <p:nvSpPr>
+          <p:cNvPr id="74" name="Rounded Rectangle 73"/>
           <p:cNvSpPr/>
           <p:nvPr/>
         </p:nvSpPr>
         <p:spPr>
           <a:xfrm>
-            <a:off x="292608" y="4160520"/>
-            <a:ext cx="3895344" cy="566928"/>
+            <a:off x="274320" y="2057400"/>
+            <a:ext cx="2697480" cy="2743200"/>
           </a:xfrm>
           <a:prstGeom prst="roundRect">
             <a:avLst>
@@ -13574,22 +13504,261 @@
       </p:sp>
       <p:sp>
         <p:nvSpPr>
-          <p:cNvPr id="77" name="Rounded Rectangle 76"/>
+          <p:cNvPr id="75" name="TextBox 74"/>
+          <p:cNvSpPr txBox="1"/>
+          <p:nvPr/>
+        </p:nvSpPr>
+        <p:spPr>
+          <a:xfrm>
+            <a:off x="411480" y="2130552"/>
+            <a:ext cx="2468880" cy="274320"/>
+          </a:xfrm>
+          <a:prstGeom prst="rect">
+            <a:avLst/>
+          </a:prstGeom>
+          <a:noFill/>
+        </p:spPr>
+        <p:txBody>
+          <a:bodyPr wrap="square" anchor="t" lIns="0" rIns="0" tIns="27432" bIns="27432">
+            <a:spAutoFit/>
+          </a:bodyPr>
+          <a:lstStyle/>
+          <a:p>
+            <a:pPr algn="l"/>
+            <a:r>
+              <a:rPr sz="850" b="1" i="0">
+                <a:solidFill>
+                  <a:srgbClr val="2A7F8E"/>
+                </a:solidFill>
+                <a:latin typeface="Arial"/>
+              </a:rPr>
+              <a:t>MEET LINH</a:t>
+            </a:r>
+          </a:p>
+        </p:txBody>
+      </p:sp>
+      <p:sp>
+        <p:nvSpPr>
+          <p:cNvPr id="76" name="TextBox 75"/>
+          <p:cNvSpPr txBox="1"/>
+          <p:nvPr/>
+        </p:nvSpPr>
+        <p:spPr>
+          <a:xfrm>
+            <a:off x="411480" y="2359152"/>
+            <a:ext cx="2468880" cy="411480"/>
+          </a:xfrm>
+          <a:prstGeom prst="rect">
+            <a:avLst/>
+          </a:prstGeom>
+          <a:noFill/>
+        </p:spPr>
+        <p:txBody>
+          <a:bodyPr wrap="square" anchor="t" lIns="0" rIns="0" tIns="27432" bIns="27432">
+            <a:spAutoFit/>
+          </a:bodyPr>
+          <a:lstStyle/>
+          <a:p>
+            <a:pPr algn="l"/>
+            <a:r>
+              <a:rPr sz="1400" b="1" i="0">
+                <a:solidFill>
+                  <a:srgbClr val="0F3D4C"/>
+                </a:solidFill>
+                <a:latin typeface="Arial"/>
+              </a:rPr>
+              <a:t>Shopee seller, Vietnam</a:t>
+            </a:r>
+          </a:p>
+        </p:txBody>
+      </p:sp>
+      <p:sp>
+        <p:nvSpPr>
+          <p:cNvPr id="77" name="TextBox 76"/>
+          <p:cNvSpPr txBox="1"/>
+          <p:nvPr/>
+        </p:nvSpPr>
+        <p:spPr>
+          <a:xfrm>
+            <a:off x="411480" y="2761488"/>
+            <a:ext cx="2423160" cy="1325880"/>
+          </a:xfrm>
+          <a:prstGeom prst="rect">
+            <a:avLst/>
+          </a:prstGeom>
+          <a:noFill/>
+        </p:spPr>
+        <p:txBody>
+          <a:bodyPr wrap="square" anchor="t" lIns="0" rIns="0" tIns="27432" bIns="27432">
+            <a:spAutoFit/>
+          </a:bodyPr>
+          <a:lstStyle/>
+          <a:p>
+            <a:pPr algn="l">
+              <a:spcAft>
+                <a:spcPts val="500"/>
+              </a:spcAft>
+            </a:pPr>
+            <a:r>
+              <a:rPr sz="1000" b="0" i="0">
+                <a:solidFill>
+                  <a:srgbClr val="202124"/>
+                </a:solidFill>
+                <a:latin typeface="Arial"/>
+              </a:rPr>
+              <a:t>Asks for VND 150M of working capital. Her sales are real.</a:t>
+            </a:r>
+          </a:p>
+          <a:p>
+            <a:pPr algn="l"/>
+            <a:r>
+              <a:rPr sz="1000" b="0" i="0">
+                <a:solidFill>
+                  <a:srgbClr val="202124"/>
+                </a:solidFill>
+                <a:latin typeface="Arial"/>
+              </a:rPr>
+              <a:t>She brings 14 documents: a bank statement PDF, monthly Shopee dashboard screenshots, supplier receipts, photos of the shop.</a:t>
+            </a:r>
+          </a:p>
+        </p:txBody>
+      </p:sp>
+      <p:sp>
+        <p:nvSpPr>
+          <p:cNvPr id="78" name="Rounded Rectangle 77"/>
           <p:cNvSpPr/>
           <p:nvPr/>
         </p:nvSpPr>
         <p:spPr>
           <a:xfrm>
-            <a:off x="411480" y="4242816"/>
-            <a:ext cx="1550456" cy="164592"/>
+            <a:off x="411480" y="3877056"/>
+            <a:ext cx="2423160" cy="694944"/>
           </a:xfrm>
           <a:prstGeom prst="roundRect">
             <a:avLst>
-              <a:gd name="adj" fmla="val 10000"/>
+              <a:gd name="adj" fmla="val 6000"/>
             </a:avLst>
           </a:prstGeom>
           <a:solidFill>
-            <a:srgbClr val="2A7F8E"/>
+            <a:srgbClr val="FFF3CC"/>
+          </a:solidFill>
+          <a:ln w="15240">
+            <a:solidFill>
+              <a:srgbClr val="E0A100"/>
+            </a:solidFill>
+          </a:ln>
+          <a:effectLst/>
+        </p:spPr>
+        <p:txBody>
+          <a:bodyPr rtlCol="0" anchor="ctr"/>
+          <a:lstStyle/>
+          <a:p/>
+        </p:txBody>
+      </p:sp>
+      <p:sp>
+        <p:nvSpPr>
+          <p:cNvPr id="79" name="TextBox 78"/>
+          <p:cNvSpPr txBox="1"/>
+          <p:nvPr/>
+        </p:nvSpPr>
+        <p:spPr>
+          <a:xfrm>
+            <a:off x="521207" y="3895344"/>
+            <a:ext cx="2240280" cy="658368"/>
+          </a:xfrm>
+          <a:prstGeom prst="rect">
+            <a:avLst/>
+          </a:prstGeom>
+          <a:noFill/>
+        </p:spPr>
+        <p:txBody>
+          <a:bodyPr wrap="square" anchor="ctr" lIns="0" rIns="0" tIns="27432" bIns="27432">
+            <a:spAutoFit/>
+          </a:bodyPr>
+          <a:lstStyle/>
+          <a:p>
+            <a:pPr algn="l">
+              <a:spcAft>
+                <a:spcPts val="200"/>
+              </a:spcAft>
+            </a:pPr>
+            <a:r>
+              <a:rPr sz="1100" b="1" i="0">
+                <a:solidFill>
+                  <a:srgbClr val="0F3D4C"/>
+                </a:solidFill>
+                <a:latin typeface="Arial"/>
+              </a:rPr>
+              <a:t>No credit file. No collateral.</a:t>
+            </a:r>
+          </a:p>
+          <a:p>
+            <a:pPr algn="l"/>
+            <a:r>
+              <a:rPr sz="950" b="0" i="0">
+                <a:solidFill>
+                  <a:srgbClr val="B3261E"/>
+                </a:solidFill>
+                <a:latin typeface="Arial"/>
+              </a:rPr>
+              <a:t>Today her file is declined, or priced blind.</a:t>
+            </a:r>
+          </a:p>
+        </p:txBody>
+      </p:sp>
+      <p:sp>
+        <p:nvSpPr>
+          <p:cNvPr id="80" name="TextBox 79"/>
+          <p:cNvSpPr txBox="1"/>
+          <p:nvPr/>
+        </p:nvSpPr>
+        <p:spPr>
+          <a:xfrm>
+            <a:off x="411480" y="4626864"/>
+            <a:ext cx="2468880" cy="164592"/>
+          </a:xfrm>
+          <a:prstGeom prst="rect">
+            <a:avLst/>
+          </a:prstGeom>
+          <a:noFill/>
+        </p:spPr>
+        <p:txBody>
+          <a:bodyPr wrap="square" anchor="t" lIns="0" rIns="0" tIns="27432" bIns="27432">
+            <a:spAutoFit/>
+          </a:bodyPr>
+          <a:lstStyle/>
+          <a:p>
+            <a:pPr algn="l"/>
+            <a:r>
+              <a:rPr sz="700" b="0" i="1">
+                <a:solidFill>
+                  <a:srgbClr val="5F6368"/>
+                </a:solidFill>
+                <a:latin typeface="Arial"/>
+              </a:rPr>
+              <a:t>Synthetic demo case B</a:t>
+            </a:r>
+          </a:p>
+        </p:txBody>
+      </p:sp>
+      <p:sp>
+        <p:nvSpPr>
+          <p:cNvPr id="81" name="Rounded Rectangle 80"/>
+          <p:cNvSpPr/>
+          <p:nvPr/>
+        </p:nvSpPr>
+        <p:spPr>
+          <a:xfrm>
+            <a:off x="3337560" y="2240280"/>
+            <a:ext cx="27432" cy="2377440"/>
+          </a:xfrm>
+          <a:prstGeom prst="roundRect">
+            <a:avLst>
+              <a:gd name="adj" fmla="val 0"/>
+            </a:avLst>
+          </a:prstGeom>
+          <a:solidFill>
+            <a:srgbClr val="D5DBDE"/>
           </a:solidFill>
           <a:ln>
             <a:noFill/>
@@ -13604,57 +13773,22 @@
       </p:sp>
       <p:sp>
         <p:nvSpPr>
-          <p:cNvPr id="78" name="TextBox 77"/>
-          <p:cNvSpPr txBox="1"/>
-          <p:nvPr/>
-        </p:nvSpPr>
-        <p:spPr>
-          <a:xfrm>
-            <a:off x="2007656" y="4206240"/>
-            <a:ext cx="1463040" cy="237744"/>
-          </a:xfrm>
-          <a:prstGeom prst="rect">
-            <a:avLst/>
-          </a:prstGeom>
-          <a:noFill/>
-        </p:spPr>
-        <p:txBody>
-          <a:bodyPr wrap="square" anchor="t" lIns="0" rIns="0" tIns="27432" bIns="27432">
-            <a:spAutoFit/>
-          </a:bodyPr>
-          <a:lstStyle/>
-          <a:p>
-            <a:pPr algn="l"/>
-            <a:r>
-              <a:rPr sz="900" b="0" i="0">
-                <a:solidFill>
-                  <a:srgbClr val="202124"/>
-                </a:solidFill>
-                <a:latin typeface="Arial"/>
-              </a:rPr>
-              <a:t>47.1% large firms</a:t>
-            </a:r>
-          </a:p>
-        </p:txBody>
-      </p:sp>
-      <p:sp>
-        <p:nvSpPr>
-          <p:cNvPr id="79" name="Rounded Rectangle 78"/>
+          <p:cNvPr id="82" name="Rounded Rectangle 81"/>
           <p:cNvSpPr/>
           <p:nvPr/>
         </p:nvSpPr>
         <p:spPr>
           <a:xfrm>
-            <a:off x="411480" y="4480560"/>
-            <a:ext cx="289681" cy="164592"/>
+            <a:off x="3200400" y="2217420"/>
+            <a:ext cx="310896" cy="310896"/>
           </a:xfrm>
           <a:prstGeom prst="roundRect">
             <a:avLst>
-              <a:gd name="adj" fmla="val 10000"/>
+              <a:gd name="adj" fmla="val 50000"/>
             </a:avLst>
           </a:prstGeom>
           <a:solidFill>
-            <a:srgbClr val="E0A100"/>
+            <a:srgbClr val="0F3D4C"/>
           </a:solidFill>
           <a:ln>
             <a:noFill/>
@@ -13662,56 +13796,32 @@
           <a:effectLst/>
         </p:spPr>
         <p:txBody>
-          <a:bodyPr rtlCol="0" anchor="ctr"/>
-          <a:lstStyle/>
-          <a:p/>
-        </p:txBody>
-      </p:sp>
-      <p:sp>
-        <p:nvSpPr>
-          <p:cNvPr id="80" name="TextBox 79"/>
-          <p:cNvSpPr txBox="1"/>
-          <p:nvPr/>
-        </p:nvSpPr>
-        <p:spPr>
-          <a:xfrm>
-            <a:off x="746881" y="4443984"/>
-            <a:ext cx="1463040" cy="237744"/>
-          </a:xfrm>
-          <a:prstGeom prst="rect">
-            <a:avLst/>
-          </a:prstGeom>
-          <a:noFill/>
-        </p:spPr>
-        <p:txBody>
-          <a:bodyPr wrap="square" anchor="t" lIns="0" rIns="0" tIns="27432" bIns="27432">
-            <a:spAutoFit/>
-          </a:bodyPr>
-          <a:lstStyle/>
-          <a:p>
-            <a:pPr algn="l"/>
-            <a:r>
-              <a:rPr sz="900" b="1" i="0">
-                <a:solidFill>
-                  <a:srgbClr val="202124"/>
+          <a:bodyPr rtlCol="0" anchor="ctr" lIns="36576" rIns="36576" tIns="0" bIns="0"/>
+          <a:lstStyle/>
+          <a:p>
+            <a:pPr algn="ctr"/>
+            <a:r>
+              <a:rPr sz="1000" b="1">
+                <a:solidFill>
+                  <a:srgbClr val="FFFFFF"/>
                 </a:solidFill>
                 <a:latin typeface="Arial"/>
               </a:rPr>
-              <a:t>8.8% SMEs</a:t>
-            </a:r>
-          </a:p>
-        </p:txBody>
-      </p:sp>
-      <p:sp>
-        <p:nvSpPr>
-          <p:cNvPr id="81" name="Rounded Rectangle 80"/>
+              <a:t>1</a:t>
+            </a:r>
+          </a:p>
+        </p:txBody>
+      </p:sp>
+      <p:sp>
+        <p:nvSpPr>
+          <p:cNvPr id="83" name="Rounded Rectangle 82"/>
           <p:cNvSpPr/>
           <p:nvPr/>
         </p:nvSpPr>
         <p:spPr>
           <a:xfrm>
-            <a:off x="4480560" y="1371600"/>
-            <a:ext cx="4389120" cy="1024128"/>
+            <a:off x="3630168" y="2057400"/>
+            <a:ext cx="5239511" cy="630936"/>
           </a:xfrm>
           <a:prstGeom prst="roundRect">
             <a:avLst>
@@ -13736,14 +13846,14 @@
       </p:sp>
       <p:sp>
         <p:nvSpPr>
-          <p:cNvPr id="82" name="TextBox 81"/>
-          <p:cNvSpPr txBox="1"/>
-          <p:nvPr/>
-        </p:nvSpPr>
-        <p:spPr>
-          <a:xfrm>
-            <a:off x="4590288" y="1463040"/>
-            <a:ext cx="1325880" cy="868680"/>
+          <p:cNvPr id="84" name="TextBox 83"/>
+          <p:cNvSpPr txBox="1"/>
+          <p:nvPr/>
+        </p:nvSpPr>
+        <p:spPr>
+          <a:xfrm>
+            <a:off x="3749040" y="2093976"/>
+            <a:ext cx="1097280" cy="557784"/>
           </a:xfrm>
           <a:prstGeom prst="rect">
             <a:avLst/>
@@ -13758,27 +13868,27 @@
           <a:p>
             <a:pPr algn="l"/>
             <a:r>
-              <a:rPr sz="2400" b="1" i="0">
+              <a:rPr sz="2000" b="1" i="0">
                 <a:solidFill>
                   <a:srgbClr val="0F3D4C"/>
                 </a:solidFill>
                 <a:latin typeface="Arial"/>
               </a:rPr>
-              <a:t>75.5%</a:t>
-            </a:r>
-          </a:p>
-        </p:txBody>
-      </p:sp>
-      <p:sp>
-        <p:nvSpPr>
-          <p:cNvPr id="83" name="TextBox 82"/>
-          <p:cNvSpPr txBox="1"/>
-          <p:nvPr/>
-        </p:nvSpPr>
-        <p:spPr>
-          <a:xfrm>
-            <a:off x="5943600" y="1444752"/>
-            <a:ext cx="2834640" cy="914400"/>
+              <a:t>8.8%</a:t>
+            </a:r>
+          </a:p>
+        </p:txBody>
+      </p:sp>
+      <p:sp>
+        <p:nvSpPr>
+          <p:cNvPr id="85" name="TextBox 84"/>
+          <p:cNvSpPr txBox="1"/>
+          <p:nvPr/>
+        </p:nvSpPr>
+        <p:spPr>
+          <a:xfrm>
+            <a:off x="4892040" y="2093976"/>
+            <a:ext cx="3886200" cy="557784"/>
           </a:xfrm>
           <a:prstGeom prst="rect">
             <a:avLst/>
@@ -13793,27 +13903,68 @@
           <a:p>
             <a:pPr algn="l"/>
             <a:r>
-              <a:rPr sz="1050" b="0" i="0">
+              <a:rPr sz="950" b="0" i="0">
                 <a:solidFill>
                   <a:srgbClr val="202124"/>
                 </a:solidFill>
                 <a:latin typeface="Arial"/>
               </a:rPr>
-              <a:t>of Vietnamese firms cannot borrow without collateral. What they have is PDFs, screenshots and paper receipts.</a:t>
-            </a:r>
-          </a:p>
-        </p:txBody>
-      </p:sp>
-      <p:sp>
-        <p:nvSpPr>
-          <p:cNvPr id="84" name="Rounded Rectangle 83"/>
+              <a:t>of Vietnam's SMEs have a bank loan; large firms: 47.1%. Without a credit file or collateral, small firms are declined.</a:t>
+            </a:r>
+          </a:p>
+        </p:txBody>
+      </p:sp>
+      <p:sp>
+        <p:nvSpPr>
+          <p:cNvPr id="86" name="Rounded Rectangle 85"/>
           <p:cNvSpPr/>
           <p:nvPr/>
         </p:nvSpPr>
         <p:spPr>
           <a:xfrm>
-            <a:off x="4480560" y="2487168"/>
-            <a:ext cx="4389120" cy="1024128"/>
+            <a:off x="3200400" y="2921508"/>
+            <a:ext cx="310896" cy="310896"/>
+          </a:xfrm>
+          <a:prstGeom prst="roundRect">
+            <a:avLst>
+              <a:gd name="adj" fmla="val 50000"/>
+            </a:avLst>
+          </a:prstGeom>
+          <a:solidFill>
+            <a:srgbClr val="0F3D4C"/>
+          </a:solidFill>
+          <a:ln>
+            <a:noFill/>
+          </a:ln>
+          <a:effectLst/>
+        </p:spPr>
+        <p:txBody>
+          <a:bodyPr rtlCol="0" anchor="ctr" lIns="36576" rIns="36576" tIns="0" bIns="0"/>
+          <a:lstStyle/>
+          <a:p>
+            <a:pPr algn="ctr"/>
+            <a:r>
+              <a:rPr sz="1000" b="1">
+                <a:solidFill>
+                  <a:srgbClr val="FFFFFF"/>
+                </a:solidFill>
+                <a:latin typeface="Arial"/>
+              </a:rPr>
+              <a:t>2</a:t>
+            </a:r>
+          </a:p>
+        </p:txBody>
+      </p:sp>
+      <p:sp>
+        <p:nvSpPr>
+          <p:cNvPr id="87" name="Rounded Rectangle 86"/>
+          <p:cNvSpPr/>
+          <p:nvPr/>
+        </p:nvSpPr>
+        <p:spPr>
+          <a:xfrm>
+            <a:off x="3630168" y="2761488"/>
+            <a:ext cx="5239511" cy="630936"/>
           </a:xfrm>
           <a:prstGeom prst="roundRect">
             <a:avLst>
@@ -13838,14 +13989,14 @@
       </p:sp>
       <p:sp>
         <p:nvSpPr>
-          <p:cNvPr id="85" name="TextBox 84"/>
-          <p:cNvSpPr txBox="1"/>
-          <p:nvPr/>
-        </p:nvSpPr>
-        <p:spPr>
-          <a:xfrm>
-            <a:off x="4590288" y="2578608"/>
-            <a:ext cx="1325880" cy="868680"/>
+          <p:cNvPr id="88" name="TextBox 87"/>
+          <p:cNvSpPr txBox="1"/>
+          <p:nvPr/>
+        </p:nvSpPr>
+        <p:spPr>
+          <a:xfrm>
+            <a:off x="3749040" y="2798064"/>
+            <a:ext cx="1097280" cy="557784"/>
           </a:xfrm>
           <a:prstGeom prst="rect">
             <a:avLst/>
@@ -13860,27 +14011,27 @@
           <a:p>
             <a:pPr algn="l"/>
             <a:r>
-              <a:rPr sz="2400" b="1" i="0">
+              <a:rPr sz="2000" b="1" i="0">
                 <a:solidFill>
                   <a:srgbClr val="0F3D4C"/>
                 </a:solidFill>
                 <a:latin typeface="Arial"/>
               </a:rPr>
-              <a:t>70%</a:t>
-            </a:r>
-          </a:p>
-        </p:txBody>
-      </p:sp>
-      <p:sp>
-        <p:nvSpPr>
-          <p:cNvPr id="86" name="TextBox 85"/>
-          <p:cNvSpPr txBox="1"/>
-          <p:nvPr/>
-        </p:nvSpPr>
-        <p:spPr>
-          <a:xfrm>
-            <a:off x="5943600" y="2560320"/>
-            <a:ext cx="2834640" cy="914400"/>
+              <a:t>75.5%</a:t>
+            </a:r>
+          </a:p>
+        </p:txBody>
+      </p:sp>
+      <p:sp>
+        <p:nvSpPr>
+          <p:cNvPr id="89" name="TextBox 88"/>
+          <p:cNvSpPr txBox="1"/>
+          <p:nvPr/>
+        </p:nvSpPr>
+        <p:spPr>
+          <a:xfrm>
+            <a:off x="4892040" y="2798064"/>
+            <a:ext cx="3886200" cy="557784"/>
           </a:xfrm>
           <a:prstGeom prst="rect">
             <a:avLst/>
@@ -13895,27 +14046,68 @@
           <a:p>
             <a:pPr algn="l"/>
             <a:r>
-              <a:rPr sz="1050" b="0" i="0">
+              <a:rPr sz="950" b="0" i="0">
                 <a:solidFill>
                   <a:srgbClr val="202124"/>
                 </a:solidFill>
                 <a:latin typeface="Arial"/>
               </a:rPr>
-              <a:t>of emerging-market MSMEs lack adequate financing. Reading their records by hand costs more than a small loan earns.</a:t>
-            </a:r>
-          </a:p>
-        </p:txBody>
-      </p:sp>
-      <p:sp>
-        <p:nvSpPr>
-          <p:cNvPr id="87" name="Rounded Rectangle 86"/>
+              <a:t>of Vietnamese firms cannot borrow without collateral, so banks are moving to cash-flow lending (VPBank, Vietcombank, Agribank).</a:t>
+            </a:r>
+          </a:p>
+        </p:txBody>
+      </p:sp>
+      <p:sp>
+        <p:nvSpPr>
+          <p:cNvPr id="90" name="Rounded Rectangle 89"/>
           <p:cNvSpPr/>
           <p:nvPr/>
         </p:nvSpPr>
         <p:spPr>
           <a:xfrm>
-            <a:off x="4480560" y="3602735"/>
-            <a:ext cx="4389120" cy="1024128"/>
+            <a:off x="3200400" y="3625596"/>
+            <a:ext cx="310896" cy="310896"/>
+          </a:xfrm>
+          <a:prstGeom prst="roundRect">
+            <a:avLst>
+              <a:gd name="adj" fmla="val 50000"/>
+            </a:avLst>
+          </a:prstGeom>
+          <a:solidFill>
+            <a:srgbClr val="0F3D4C"/>
+          </a:solidFill>
+          <a:ln>
+            <a:noFill/>
+          </a:ln>
+          <a:effectLst/>
+        </p:spPr>
+        <p:txBody>
+          <a:bodyPr rtlCol="0" anchor="ctr" lIns="36576" rIns="36576" tIns="0" bIns="0"/>
+          <a:lstStyle/>
+          <a:p>
+            <a:pPr algn="ctr"/>
+            <a:r>
+              <a:rPr sz="1000" b="1">
+                <a:solidFill>
+                  <a:srgbClr val="FFFFFF"/>
+                </a:solidFill>
+                <a:latin typeface="Arial"/>
+              </a:rPr>
+              <a:t>3</a:t>
+            </a:r>
+          </a:p>
+        </p:txBody>
+      </p:sp>
+      <p:sp>
+        <p:nvSpPr>
+          <p:cNvPr id="91" name="Rounded Rectangle 90"/>
+          <p:cNvSpPr/>
+          <p:nvPr/>
+        </p:nvSpPr>
+        <p:spPr>
+          <a:xfrm>
+            <a:off x="3630168" y="3465576"/>
+            <a:ext cx="5239511" cy="630936"/>
           </a:xfrm>
           <a:prstGeom prst="roundRect">
             <a:avLst>
@@ -13923,9 +14115,152 @@
             </a:avLst>
           </a:prstGeom>
           <a:solidFill>
+            <a:srgbClr val="FFFFFF"/>
+          </a:solidFill>
+          <a:ln w="12700">
+            <a:solidFill>
+              <a:srgbClr val="D5DBDE"/>
+            </a:solidFill>
+          </a:ln>
+          <a:effectLst/>
+        </p:spPr>
+        <p:txBody>
+          <a:bodyPr rtlCol="0" anchor="ctr"/>
+          <a:lstStyle/>
+          <a:p/>
+        </p:txBody>
+      </p:sp>
+      <p:sp>
+        <p:nvSpPr>
+          <p:cNvPr id="92" name="TextBox 91"/>
+          <p:cNvSpPr txBox="1"/>
+          <p:nvPr/>
+        </p:nvSpPr>
+        <p:spPr>
+          <a:xfrm>
+            <a:off x="3749040" y="3502152"/>
+            <a:ext cx="1097280" cy="557784"/>
+          </a:xfrm>
+          <a:prstGeom prst="rect">
+            <a:avLst/>
+          </a:prstGeom>
+          <a:noFill/>
+        </p:spPr>
+        <p:txBody>
+          <a:bodyPr wrap="square" anchor="ctr" lIns="0" rIns="0" tIns="27432" bIns="27432">
+            <a:spAutoFit/>
+          </a:bodyPr>
+          <a:lstStyle/>
+          <a:p>
+            <a:pPr algn="l"/>
+            <a:r>
+              <a:rPr sz="2000" b="1" i="0">
+                <a:solidFill>
+                  <a:srgbClr val="0F3D4C"/>
+                </a:solidFill>
+                <a:latin typeface="Arial"/>
+              </a:rPr>
+              <a:t>~45 min</a:t>
+            </a:r>
+          </a:p>
+        </p:txBody>
+      </p:sp>
+      <p:sp>
+        <p:nvSpPr>
+          <p:cNvPr id="93" name="TextBox 92"/>
+          <p:cNvSpPr txBox="1"/>
+          <p:nvPr/>
+        </p:nvSpPr>
+        <p:spPr>
+          <a:xfrm>
+            <a:off x="4892040" y="3502152"/>
+            <a:ext cx="3886200" cy="557784"/>
+          </a:xfrm>
+          <a:prstGeom prst="rect">
+            <a:avLst/>
+          </a:prstGeom>
+          <a:noFill/>
+        </p:spPr>
+        <p:txBody>
+          <a:bodyPr wrap="square" anchor="ctr" lIns="0" rIns="0" tIns="27432" bIns="27432">
+            <a:spAutoFit/>
+          </a:bodyPr>
+          <a:lstStyle/>
+          <a:p>
+            <a:pPr algn="l"/>
+            <a:r>
+              <a:rPr sz="950" b="0" i="0">
+                <a:solidFill>
+                  <a:srgbClr val="202124"/>
+                </a:solidFill>
+                <a:latin typeface="Arial"/>
+              </a:rPr>
+              <a:t>to read and verify one file by hand. For a small loan, the reading costs more than the loan earns.</a:t>
+            </a:r>
+          </a:p>
+        </p:txBody>
+      </p:sp>
+      <p:sp>
+        <p:nvSpPr>
+          <p:cNvPr id="94" name="Rounded Rectangle 93"/>
+          <p:cNvSpPr/>
+          <p:nvPr/>
+        </p:nvSpPr>
+        <p:spPr>
+          <a:xfrm>
+            <a:off x="3200400" y="4329683"/>
+            <a:ext cx="310896" cy="310896"/>
+          </a:xfrm>
+          <a:prstGeom prst="roundRect">
+            <a:avLst>
+              <a:gd name="adj" fmla="val 50000"/>
+            </a:avLst>
+          </a:prstGeom>
+          <a:solidFill>
+            <a:srgbClr val="E0A100"/>
+          </a:solidFill>
+          <a:ln>
+            <a:noFill/>
+          </a:ln>
+          <a:effectLst/>
+        </p:spPr>
+        <p:txBody>
+          <a:bodyPr rtlCol="0" anchor="ctr" lIns="36576" rIns="36576" tIns="0" bIns="0"/>
+          <a:lstStyle/>
+          <a:p>
+            <a:pPr algn="ctr"/>
+            <a:r>
+              <a:rPr sz="1000" b="1">
+                <a:solidFill>
+                  <a:srgbClr val="0F3D4C"/>
+                </a:solidFill>
+                <a:latin typeface="Arial"/>
+              </a:rPr>
+              <a:t>4</a:t>
+            </a:r>
+          </a:p>
+        </p:txBody>
+      </p:sp>
+      <p:sp>
+        <p:nvSpPr>
+          <p:cNvPr id="95" name="Rounded Rectangle 94"/>
+          <p:cNvSpPr/>
+          <p:nvPr/>
+        </p:nvSpPr>
+        <p:spPr>
+          <a:xfrm>
+            <a:off x="3630168" y="4169663"/>
+            <a:ext cx="5239511" cy="630936"/>
+          </a:xfrm>
+          <a:prstGeom prst="roundRect">
+            <a:avLst>
+              <a:gd name="adj" fmla="val 6000"/>
+            </a:avLst>
+          </a:prstGeom>
+          <a:solidFill>
             <a:srgbClr val="FFF3CC"/>
           </a:solidFill>
-          <a:ln w="19050">
+          <a:ln w="17780">
             <a:solidFill>
               <a:srgbClr val="E0A100"/>
             </a:solidFill>
@@ -13940,14 +14275,14 @@
       </p:sp>
       <p:sp>
         <p:nvSpPr>
-          <p:cNvPr id="88" name="TextBox 87"/>
-          <p:cNvSpPr txBox="1"/>
-          <p:nvPr/>
-        </p:nvSpPr>
-        <p:spPr>
-          <a:xfrm>
-            <a:off x="4590288" y="3694175"/>
-            <a:ext cx="1325880" cy="868680"/>
+          <p:cNvPr id="96" name="TextBox 95"/>
+          <p:cNvSpPr txBox="1"/>
+          <p:nvPr/>
+        </p:nvSpPr>
+        <p:spPr>
+          <a:xfrm>
+            <a:off x="3749040" y="4206240"/>
+            <a:ext cx="1097280" cy="557784"/>
           </a:xfrm>
           <a:prstGeom prst="rect">
             <a:avLst/>
@@ -13962,27 +14297,27 @@
           <a:p>
             <a:pPr algn="l"/>
             <a:r>
-              <a:rPr sz="1300" b="1" i="0">
+              <a:rPr sz="2000" b="1" i="0">
                 <a:solidFill>
                   <a:srgbClr val="0F3D4C"/>
                 </a:solidFill>
                 <a:latin typeface="Arial"/>
               </a:rPr>
-              <a:t>The opening</a:t>
-            </a:r>
-          </a:p>
-        </p:txBody>
-      </p:sp>
-      <p:sp>
-        <p:nvSpPr>
-          <p:cNvPr id="89" name="TextBox 88"/>
-          <p:cNvSpPr txBox="1"/>
-          <p:nvPr/>
-        </p:nvSpPr>
-        <p:spPr>
-          <a:xfrm>
-            <a:off x="5943600" y="3675887"/>
-            <a:ext cx="2834640" cy="914400"/>
+              <a:t>77%</a:t>
+            </a:r>
+          </a:p>
+        </p:txBody>
+      </p:sp>
+      <p:sp>
+        <p:nvSpPr>
+          <p:cNvPr id="97" name="TextBox 96"/>
+          <p:cNvSpPr txBox="1"/>
+          <p:nvPr/>
+        </p:nvSpPr>
+        <p:spPr>
+          <a:xfrm>
+            <a:off x="4892040" y="4206240"/>
+            <a:ext cx="3886200" cy="557784"/>
           </a:xfrm>
           <a:prstGeom prst="rect">
             <a:avLst/>
@@ -13997,27 +14332,27 @@
           <a:p>
             <a:pPr algn="l"/>
             <a:r>
-              <a:rPr sz="1050" b="0" i="0">
+              <a:rPr sz="950" b="0" i="0">
                 <a:solidFill>
                   <a:srgbClr val="202124"/>
                 </a:solidFill>
                 <a:latin typeface="Arial"/>
               </a:rPr>
-              <a:t>VPBank, Vietcombank and Agribank are moving from collateral to cash-flow lending. Someone still has to read the cash flow. LedgerLens makes that reading fast, sourced and auditable.</a:t>
-            </a:r>
-          </a:p>
-        </p:txBody>
-      </p:sp>
-      <p:sp>
-        <p:nvSpPr>
-          <p:cNvPr id="90" name="TextBox 89"/>
-          <p:cNvSpPr txBox="1"/>
-          <p:nvPr/>
-        </p:nvSpPr>
-        <p:spPr>
-          <a:xfrm>
-            <a:off x="274320" y="4773168"/>
-            <a:ext cx="8595360" cy="228600"/>
+              <a:t>of the numbers in a memo written by a single Gemini prompt point to no page, so the underwriter has to find each one again. That prompt also caught only 15% of the planted risks.</a:t>
+            </a:r>
+          </a:p>
+        </p:txBody>
+      </p:sp>
+      <p:sp>
+        <p:nvSpPr>
+          <p:cNvPr id="98" name="TextBox 97"/>
+          <p:cNvSpPr txBox="1"/>
+          <p:nvPr/>
+        </p:nvSpPr>
+        <p:spPr>
+          <a:xfrm>
+            <a:off x="274320" y="4828032"/>
+            <a:ext cx="8595360" cy="201168"/>
           </a:xfrm>
           <a:prstGeom prst="rect">
             <a:avLst/>
@@ -14025,20 +14360,20 @@
           <a:noFill/>
         </p:spPr>
         <p:txBody>
-          <a:bodyPr wrap="square" anchor="t" lIns="45720" rIns="45720" tIns="27432" bIns="27432">
+          <a:bodyPr wrap="square" anchor="t" lIns="0" rIns="0" tIns="27432" bIns="27432">
             <a:spAutoFit/>
           </a:bodyPr>
           <a:lstStyle/>
           <a:p>
             <a:pPr algn="l"/>
             <a:r>
-              <a:rPr sz="750" b="0" i="1">
+              <a:rPr sz="700" b="0" i="1">
                 <a:solidFill>
                   <a:srgbClr val="5F6368"/>
                 </a:solidFill>
                 <a:latin typeface="Arial"/>
               </a:rPr>
-              <a:t>Sources: FiinGroup via Viet Nam News (Aug 2026) · VCCI Private Economic Report 2025 · IFC MSME Finance · VTV (May 2026) · ADB Asia SME Monitor 2025</a:t>
+              <a:t>Sources: 1 FiinGroup via Viet Nam News (Aug 2026) · 2 VCCI 2025 via VTV (May 2026) · 3 team estimate; ADB Asia SME Monitor 2025 · 4 our live benchmark, gemini-3.8-flash</a:t>
             </a:r>
           </a:p>
         </p:txBody>
@@ -14199,8 +14534,8 @@
         </p:nvSpPr>
         <p:spPr>
           <a:xfrm>
-            <a:off x="274320" y="1143000"/>
-            <a:ext cx="8595360" cy="822960"/>
+            <a:off x="274320" y="1078992"/>
+            <a:ext cx="8595360" cy="274320"/>
           </a:xfrm>
           <a:prstGeom prst="rect">
             <a:avLst/>
@@ -14215,27 +14550,62 @@
           <a:p>
             <a:pPr algn="l"/>
             <a:r>
-              <a:rPr sz="2000" b="1" i="0">
+              <a:rPr sz="900" b="1" i="0">
+                <a:solidFill>
+                  <a:srgbClr val="2A7F8E"/>
+                </a:solidFill>
+                <a:latin typeface="Arial"/>
+              </a:rPr>
+              <a:t>THE SOLUTION</a:t>
+            </a:r>
+          </a:p>
+        </p:txBody>
+      </p:sp>
+      <p:sp>
+        <p:nvSpPr>
+          <p:cNvPr id="73" name="TextBox 72"/>
+          <p:cNvSpPr txBox="1"/>
+          <p:nvPr/>
+        </p:nvSpPr>
+        <p:spPr>
+          <a:xfrm>
+            <a:off x="274320" y="1280160"/>
+            <a:ext cx="8595360" cy="640080"/>
+          </a:xfrm>
+          <a:prstGeom prst="rect">
+            <a:avLst/>
+          </a:prstGeom>
+          <a:noFill/>
+        </p:spPr>
+        <p:txBody>
+          <a:bodyPr wrap="square" anchor="t" lIns="45720" rIns="45720" tIns="27432" bIns="27432">
+            <a:spAutoFit/>
+          </a:bodyPr>
+          <a:lstStyle/>
+          <a:p>
+            <a:pPr algn="l"/>
+            <a:r>
+              <a:rPr sz="1800" b="1" i="0">
                 <a:solidFill>
                   <a:srgbClr val="0F3D4C"/>
                 </a:solidFill>
                 <a:latin typeface="Arial"/>
               </a:rPr>
-              <a:t>LedgerLens turns a shoebox of receipts, screenshots and bank PDFs into a credit memo a bank can trust.</a:t>
-            </a:r>
-          </a:p>
-        </p:txBody>
-      </p:sp>
-      <p:sp>
-        <p:nvSpPr>
-          <p:cNvPr id="73" name="Rounded Rectangle 72"/>
+              <a:t>LedgerLens reads the shoebox, shows its work, and argues against itself before a human signs.</a:t>
+            </a:r>
+          </a:p>
+        </p:txBody>
+      </p:sp>
+      <p:sp>
+        <p:nvSpPr>
+          <p:cNvPr id="74" name="Rounded Rectangle 73"/>
           <p:cNvSpPr/>
           <p:nvPr/>
         </p:nvSpPr>
         <p:spPr>
           <a:xfrm>
-            <a:off x="274320" y="2103120"/>
-            <a:ext cx="2697480" cy="2148840"/>
+            <a:off x="274320" y="2011680"/>
+            <a:ext cx="2697480" cy="2514600"/>
           </a:xfrm>
           <a:prstGeom prst="roundRect">
             <a:avLst>
@@ -14260,14 +14630,14 @@
       </p:sp>
       <p:sp>
         <p:nvSpPr>
-          <p:cNvPr id="74" name="Rounded Rectangle 73"/>
+          <p:cNvPr id="75" name="Rounded Rectangle 74"/>
           <p:cNvSpPr/>
           <p:nvPr/>
         </p:nvSpPr>
         <p:spPr>
           <a:xfrm>
-            <a:off x="438912" y="2267712"/>
-            <a:ext cx="365760" cy="365760"/>
+            <a:off x="420623" y="2130552"/>
+            <a:ext cx="347472" cy="347472"/>
           </a:xfrm>
           <a:prstGeom prst="roundRect">
             <a:avLst>
@@ -14288,7 +14658,7 @@
           <a:p>
             <a:pPr algn="ctr"/>
             <a:r>
-              <a:rPr sz="1200" b="1">
+              <a:rPr sz="1100" b="1">
                 <a:solidFill>
                   <a:srgbClr val="FFFFFF"/>
                 </a:solidFill>
@@ -14301,14 +14671,149 @@
       </p:sp>
       <p:sp>
         <p:nvSpPr>
-          <p:cNvPr id="75" name="TextBox 74"/>
-          <p:cNvSpPr txBox="1"/>
-          <p:nvPr/>
-        </p:nvSpPr>
-        <p:spPr>
-          <a:xfrm>
-            <a:off x="914400" y="2240280"/>
-            <a:ext cx="1920240" cy="457200"/>
+          <p:cNvPr id="76" name="TextBox 75"/>
+          <p:cNvSpPr txBox="1"/>
+          <p:nvPr/>
+        </p:nvSpPr>
+        <p:spPr>
+          <a:xfrm>
+            <a:off x="859536" y="2103120"/>
+            <a:ext cx="2011680" cy="274320"/>
+          </a:xfrm>
+          <a:prstGeom prst="rect">
+            <a:avLst/>
+          </a:prstGeom>
+          <a:noFill/>
+        </p:spPr>
+        <p:txBody>
+          <a:bodyPr wrap="square" anchor="t" lIns="0" rIns="0" tIns="27432" bIns="27432">
+            <a:spAutoFit/>
+          </a:bodyPr>
+          <a:lstStyle/>
+          <a:p>
+            <a:pPr algn="l"/>
+            <a:r>
+              <a:rPr sz="1400" b="1" i="0">
+                <a:solidFill>
+                  <a:srgbClr val="0F3D4C"/>
+                </a:solidFill>
+                <a:latin typeface="Arial"/>
+              </a:rPr>
+              <a:t>Read with evidence</a:t>
+            </a:r>
+          </a:p>
+        </p:txBody>
+      </p:sp>
+      <p:sp>
+        <p:nvSpPr>
+          <p:cNvPr id="77" name="TextBox 76"/>
+          <p:cNvSpPr txBox="1"/>
+          <p:nvPr/>
+        </p:nvSpPr>
+        <p:spPr>
+          <a:xfrm>
+            <a:off x="859536" y="2340864"/>
+            <a:ext cx="2011680" cy="182880"/>
+          </a:xfrm>
+          <a:prstGeom prst="rect">
+            <a:avLst/>
+          </a:prstGeom>
+          <a:noFill/>
+        </p:spPr>
+        <p:txBody>
+          <a:bodyPr wrap="square" anchor="t" lIns="0" rIns="0" tIns="27432" bIns="27432">
+            <a:spAutoFit/>
+          </a:bodyPr>
+          <a:lstStyle/>
+          <a:p>
+            <a:pPr algn="l"/>
+            <a:r>
+              <a:rPr sz="750" b="1" i="0">
+                <a:solidFill>
+                  <a:srgbClr val="2A7F8E"/>
+                </a:solidFill>
+                <a:latin typeface="Arial"/>
+              </a:rPr>
+              <a:t>ANSWERS: READING COST</a:t>
+            </a:r>
+          </a:p>
+        </p:txBody>
+      </p:sp>
+      <p:sp>
+        <p:nvSpPr>
+          <p:cNvPr id="78" name="TextBox 77"/>
+          <p:cNvSpPr txBox="1"/>
+          <p:nvPr/>
+        </p:nvSpPr>
+        <p:spPr>
+          <a:xfrm>
+            <a:off x="420623" y="2633472"/>
+            <a:ext cx="2404872" cy="1143000"/>
+          </a:xfrm>
+          <a:prstGeom prst="rect">
+            <a:avLst/>
+          </a:prstGeom>
+          <a:noFill/>
+        </p:spPr>
+        <p:txBody>
+          <a:bodyPr wrap="square" anchor="t" lIns="0" rIns="0" tIns="27432" bIns="27432">
+            <a:spAutoFit/>
+          </a:bodyPr>
+          <a:lstStyle/>
+          <a:p>
+            <a:pPr algn="l"/>
+            <a:r>
+              <a:rPr sz="950" b="0" i="0">
+                <a:solidFill>
+                  <a:srgbClr val="202124"/>
+                </a:solidFill>
+                <a:latin typeface="Arial"/>
+              </a:rPr>
+              <a:t>Gemini reads every page. Each value carries document, page and bounding box. Python computes the cash flow. A memo with an unsourced number is rejected and regenerated.</a:t>
+            </a:r>
+          </a:p>
+        </p:txBody>
+      </p:sp>
+      <p:sp>
+        <p:nvSpPr>
+          <p:cNvPr id="79" name="Rounded Rectangle 78"/>
+          <p:cNvSpPr/>
+          <p:nvPr/>
+        </p:nvSpPr>
+        <p:spPr>
+          <a:xfrm>
+            <a:off x="384048" y="3767328"/>
+            <a:ext cx="2478024" cy="658368"/>
+          </a:xfrm>
+          <a:prstGeom prst="roundRect">
+            <a:avLst>
+              <a:gd name="adj" fmla="val 8000"/>
+            </a:avLst>
+          </a:prstGeom>
+          <a:solidFill>
+            <a:srgbClr val="E6F2F4"/>
+          </a:solidFill>
+          <a:ln>
+            <a:noFill/>
+          </a:ln>
+          <a:effectLst/>
+        </p:spPr>
+        <p:txBody>
+          <a:bodyPr rtlCol="0" anchor="ctr"/>
+          <a:lstStyle/>
+          <a:p/>
+        </p:txBody>
+      </p:sp>
+      <p:sp>
+        <p:nvSpPr>
+          <p:cNvPr id="80" name="TextBox 79"/>
+          <p:cNvSpPr txBox="1"/>
+          <p:nvPr/>
+        </p:nvSpPr>
+        <p:spPr>
+          <a:xfrm>
+            <a:off x="475488" y="3794760"/>
+            <a:ext cx="2295144" cy="612648"/>
           </a:xfrm>
           <a:prstGeom prst="rect">
             <a:avLst/>
@@ -14323,61 +14828,35 @@
           <a:p>
             <a:pPr algn="l"/>
             <a:r>
-              <a:rPr sz="1600" b="1" i="0">
+              <a:rPr sz="900" b="1" i="0">
                 <a:solidFill>
                   <a:srgbClr val="0F3D4C"/>
                 </a:solidFill>
                 <a:latin typeface="Arial"/>
               </a:rPr>
-              <a:t>Read with evidence</a:t>
-            </a:r>
-          </a:p>
-        </p:txBody>
-      </p:sp>
-      <p:sp>
-        <p:nvSpPr>
-          <p:cNvPr id="76" name="TextBox 75"/>
-          <p:cNvSpPr txBox="1"/>
-          <p:nvPr/>
-        </p:nvSpPr>
-        <p:spPr>
-          <a:xfrm>
-            <a:off x="438912" y="2788920"/>
-            <a:ext cx="2368296" cy="1371600"/>
-          </a:xfrm>
-          <a:prstGeom prst="rect">
-            <a:avLst/>
-          </a:prstGeom>
-          <a:noFill/>
-        </p:spPr>
-        <p:txBody>
-          <a:bodyPr wrap="square" anchor="t" lIns="0" rIns="0" tIns="27432" bIns="27432">
-            <a:spAutoFit/>
-          </a:bodyPr>
-          <a:lstStyle/>
-          <a:p>
-            <a:pPr algn="l"/>
-            <a:r>
-              <a:rPr sz="1100" b="0" i="0">
+              <a:t>In Linh's file: </a:t>
+            </a:r>
+            <a:r>
+              <a:rPr sz="900" b="0" i="0">
                 <a:solidFill>
                   <a:srgbClr val="202124"/>
                 </a:solidFill>
                 <a:latin typeface="Arial"/>
               </a:rPr>
-              <a:t>Gemini reads every document. Every value carries document id, page and bounding box. Python computes the cash flow. A memo with unsourced numbers is rejected and regenerated.</a:t>
-            </a:r>
-          </a:p>
-        </p:txBody>
-      </p:sp>
-      <p:sp>
-        <p:nvSpPr>
-          <p:cNvPr id="77" name="Right Arrow 76"/>
+              <a:t>14 documents, every figure sourced to a page and box, in about 2 minutes.</a:t>
+            </a:r>
+          </a:p>
+        </p:txBody>
+      </p:sp>
+      <p:sp>
+        <p:nvSpPr>
+          <p:cNvPr id="81" name="Right Arrow 80"/>
           <p:cNvSpPr/>
           <p:nvPr/>
         </p:nvSpPr>
         <p:spPr>
           <a:xfrm>
-            <a:off x="3008376" y="3044952"/>
+            <a:off x="3008376" y="3108960"/>
             <a:ext cx="182880" cy="256032"/>
           </a:xfrm>
           <a:prstGeom prst="rightArrow">
@@ -14401,14 +14880,14 @@
       </p:sp>
       <p:sp>
         <p:nvSpPr>
-          <p:cNvPr id="78" name="Rounded Rectangle 77"/>
+          <p:cNvPr id="82" name="Rounded Rectangle 81"/>
           <p:cNvSpPr/>
           <p:nvPr/>
         </p:nvSpPr>
         <p:spPr>
           <a:xfrm>
-            <a:off x="3223260" y="2103120"/>
-            <a:ext cx="2697480" cy="2148840"/>
+            <a:off x="3223260" y="2011680"/>
+            <a:ext cx="2697480" cy="2514600"/>
           </a:xfrm>
           <a:prstGeom prst="roundRect">
             <a:avLst>
@@ -14433,14 +14912,14 @@
       </p:sp>
       <p:sp>
         <p:nvSpPr>
-          <p:cNvPr id="79" name="Rounded Rectangle 78"/>
+          <p:cNvPr id="83" name="Rounded Rectangle 82"/>
           <p:cNvSpPr/>
           <p:nvPr/>
         </p:nvSpPr>
         <p:spPr>
           <a:xfrm>
-            <a:off x="3387852" y="2267712"/>
-            <a:ext cx="365760" cy="365760"/>
+            <a:off x="3369564" y="2130552"/>
+            <a:ext cx="347472" cy="347472"/>
           </a:xfrm>
           <a:prstGeom prst="roundRect">
             <a:avLst>
@@ -14461,9 +14940,9 @@
           <a:p>
             <a:pPr algn="ctr"/>
             <a:r>
-              <a:rPr sz="1200" b="1">
-                <a:solidFill>
-                  <a:srgbClr val="FFFFFF"/>
+              <a:rPr sz="1100" b="1">
+                <a:solidFill>
+                  <a:srgbClr val="0F3D4C"/>
                 </a:solidFill>
                 <a:latin typeface="Arial"/>
               </a:rPr>
@@ -14474,14 +14953,149 @@
       </p:sp>
       <p:sp>
         <p:nvSpPr>
-          <p:cNvPr id="80" name="TextBox 79"/>
-          <p:cNvSpPr txBox="1"/>
-          <p:nvPr/>
-        </p:nvSpPr>
-        <p:spPr>
-          <a:xfrm>
-            <a:off x="3863339" y="2240280"/>
-            <a:ext cx="1920240" cy="457200"/>
+          <p:cNvPr id="84" name="TextBox 83"/>
+          <p:cNvSpPr txBox="1"/>
+          <p:nvPr/>
+        </p:nvSpPr>
+        <p:spPr>
+          <a:xfrm>
+            <a:off x="3808476" y="2103120"/>
+            <a:ext cx="2011680" cy="274320"/>
+          </a:xfrm>
+          <a:prstGeom prst="rect">
+            <a:avLst/>
+          </a:prstGeom>
+          <a:noFill/>
+        </p:spPr>
+        <p:txBody>
+          <a:bodyPr wrap="square" anchor="t" lIns="0" rIns="0" tIns="27432" bIns="27432">
+            <a:spAutoFit/>
+          </a:bodyPr>
+          <a:lstStyle/>
+          <a:p>
+            <a:pPr algn="l"/>
+            <a:r>
+              <a:rPr sz="1400" b="1" i="0">
+                <a:solidFill>
+                  <a:srgbClr val="0F3D4C"/>
+                </a:solidFill>
+                <a:latin typeface="Arial"/>
+              </a:rPr>
+              <a:t>Challenge</a:t>
+            </a:r>
+          </a:p>
+        </p:txBody>
+      </p:sp>
+      <p:sp>
+        <p:nvSpPr>
+          <p:cNvPr id="85" name="TextBox 84"/>
+          <p:cNvSpPr txBox="1"/>
+          <p:nvPr/>
+        </p:nvSpPr>
+        <p:spPr>
+          <a:xfrm>
+            <a:off x="3808476" y="2340864"/>
+            <a:ext cx="2011680" cy="182880"/>
+          </a:xfrm>
+          <a:prstGeom prst="rect">
+            <a:avLst/>
+          </a:prstGeom>
+          <a:noFill/>
+        </p:spPr>
+        <p:txBody>
+          <a:bodyPr wrap="square" anchor="t" lIns="0" rIns="0" tIns="27432" bIns="27432">
+            <a:spAutoFit/>
+          </a:bodyPr>
+          <a:lstStyle/>
+          <a:p>
+            <a:pPr algn="l"/>
+            <a:r>
+              <a:rPr sz="750" b="1" i="0">
+                <a:solidFill>
+                  <a:srgbClr val="E0A100"/>
+                </a:solidFill>
+                <a:latin typeface="Arial"/>
+              </a:rPr>
+              <a:t>ANSWERS: AI TRUST</a:t>
+            </a:r>
+          </a:p>
+        </p:txBody>
+      </p:sp>
+      <p:sp>
+        <p:nvSpPr>
+          <p:cNvPr id="86" name="TextBox 85"/>
+          <p:cNvSpPr txBox="1"/>
+          <p:nvPr/>
+        </p:nvSpPr>
+        <p:spPr>
+          <a:xfrm>
+            <a:off x="3369564" y="2633472"/>
+            <a:ext cx="2404872" cy="1143000"/>
+          </a:xfrm>
+          <a:prstGeom prst="rect">
+            <a:avLst/>
+          </a:prstGeom>
+          <a:noFill/>
+        </p:spPr>
+        <p:txBody>
+          <a:bodyPr wrap="square" anchor="t" lIns="0" rIns="0" tIns="27432" bIns="27432">
+            <a:spAutoFit/>
+          </a:bodyPr>
+          <a:lstStyle/>
+          <a:p>
+            <a:pPr algn="l"/>
+            <a:r>
+              <a:rPr sz="950" b="0" i="0">
+                <a:solidFill>
+                  <a:srgbClr val="202124"/>
+                </a:solidFill>
+                <a:latin typeface="Arial"/>
+              </a:rPr>
+              <a:t>A separate agent that never sees the writer's prompt runs deterministic checks and 12 underwriting questions, then ranks objections with evidence.</a:t>
+            </a:r>
+          </a:p>
+        </p:txBody>
+      </p:sp>
+      <p:sp>
+        <p:nvSpPr>
+          <p:cNvPr id="87" name="Rounded Rectangle 86"/>
+          <p:cNvSpPr/>
+          <p:nvPr/>
+        </p:nvSpPr>
+        <p:spPr>
+          <a:xfrm>
+            <a:off x="3332988" y="3767328"/>
+            <a:ext cx="2478024" cy="658368"/>
+          </a:xfrm>
+          <a:prstGeom prst="roundRect">
+            <a:avLst>
+              <a:gd name="adj" fmla="val 8000"/>
+            </a:avLst>
+          </a:prstGeom>
+          <a:solidFill>
+            <a:srgbClr val="FFFFFF"/>
+          </a:solidFill>
+          <a:ln>
+            <a:noFill/>
+          </a:ln>
+          <a:effectLst/>
+        </p:spPr>
+        <p:txBody>
+          <a:bodyPr rtlCol="0" anchor="ctr"/>
+          <a:lstStyle/>
+          <a:p/>
+        </p:txBody>
+      </p:sp>
+      <p:sp>
+        <p:nvSpPr>
+          <p:cNvPr id="88" name="TextBox 87"/>
+          <p:cNvSpPr txBox="1"/>
+          <p:nvPr/>
+        </p:nvSpPr>
+        <p:spPr>
+          <a:xfrm>
+            <a:off x="3424428" y="3794760"/>
+            <a:ext cx="2295144" cy="612648"/>
           </a:xfrm>
           <a:prstGeom prst="rect">
             <a:avLst/>
@@ -14496,61 +15110,35 @@
           <a:p>
             <a:pPr algn="l"/>
             <a:r>
-              <a:rPr sz="1600" b="1" i="0">
+              <a:rPr sz="900" b="1" i="0">
                 <a:solidFill>
                   <a:srgbClr val="0F3D4C"/>
                 </a:solidFill>
                 <a:latin typeface="Arial"/>
               </a:rPr>
-              <a:t>Challenge</a:t>
-            </a:r>
-          </a:p>
-        </p:txBody>
-      </p:sp>
-      <p:sp>
-        <p:nvSpPr>
-          <p:cNvPr id="81" name="TextBox 80"/>
-          <p:cNvSpPr txBox="1"/>
-          <p:nvPr/>
-        </p:nvSpPr>
-        <p:spPr>
-          <a:xfrm>
-            <a:off x="3387852" y="2788920"/>
-            <a:ext cx="2368296" cy="1371600"/>
-          </a:xfrm>
-          <a:prstGeom prst="rect">
-            <a:avLst/>
-          </a:prstGeom>
-          <a:noFill/>
-        </p:spPr>
-        <p:txBody>
-          <a:bodyPr wrap="square" anchor="t" lIns="0" rIns="0" tIns="27432" bIns="27432">
-            <a:spAutoFit/>
-          </a:bodyPr>
-          <a:lstStyle/>
-          <a:p>
-            <a:pPr algn="l"/>
-            <a:r>
-              <a:rPr sz="1100" b="0" i="0">
+              <a:t>In Linh's file: </a:t>
+            </a:r>
+            <a:r>
+              <a:rPr sz="900" b="0" i="0">
                 <a:solidFill>
                   <a:srgbClr val="202124"/>
                 </a:solidFill>
                 <a:latin typeface="Arial"/>
               </a:rPr>
-              <a:t>A second agent that never sees the first one's prompt runs 12 underwriting checks against the memo and raises severity-ranked objections with evidence.</a:t>
-            </a:r>
-          </a:p>
-        </p:txBody>
-      </p:sp>
-      <p:sp>
-        <p:nvSpPr>
-          <p:cNvPr id="82" name="Right Arrow 81"/>
+              <a:t>Flags a reused receipt photo and VND 82.5M of own-account transfers counted as income.</a:t>
+            </a:r>
+          </a:p>
+        </p:txBody>
+      </p:sp>
+      <p:sp>
+        <p:nvSpPr>
+          <p:cNvPr id="89" name="Right Arrow 88"/>
           <p:cNvSpPr/>
           <p:nvPr/>
         </p:nvSpPr>
         <p:spPr>
           <a:xfrm>
-            <a:off x="5957316" y="3044952"/>
+            <a:off x="5957316" y="3108960"/>
             <a:ext cx="182880" cy="256032"/>
           </a:xfrm>
           <a:prstGeom prst="rightArrow">
@@ -14574,14 +15162,14 @@
       </p:sp>
       <p:sp>
         <p:nvSpPr>
-          <p:cNvPr id="83" name="Rounded Rectangle 82"/>
+          <p:cNvPr id="90" name="Rounded Rectangle 89"/>
           <p:cNvSpPr/>
           <p:nvPr/>
         </p:nvSpPr>
         <p:spPr>
           <a:xfrm>
-            <a:off x="6172200" y="2103120"/>
-            <a:ext cx="2697480" cy="2148840"/>
+            <a:off x="6172200" y="2011680"/>
+            <a:ext cx="2697480" cy="2514600"/>
           </a:xfrm>
           <a:prstGeom prst="roundRect">
             <a:avLst>
@@ -14606,14 +15194,14 @@
       </p:sp>
       <p:sp>
         <p:nvSpPr>
-          <p:cNvPr id="84" name="Rounded Rectangle 83"/>
+          <p:cNvPr id="91" name="Rounded Rectangle 90"/>
           <p:cNvSpPr/>
           <p:nvPr/>
         </p:nvSpPr>
         <p:spPr>
           <a:xfrm>
-            <a:off x="6336792" y="2267712"/>
-            <a:ext cx="365760" cy="365760"/>
+            <a:off x="6318504" y="2130552"/>
+            <a:ext cx="347472" cy="347472"/>
           </a:xfrm>
           <a:prstGeom prst="roundRect">
             <a:avLst>
@@ -14634,7 +15222,7 @@
           <a:p>
             <a:pPr algn="ctr"/>
             <a:r>
-              <a:rPr sz="1200" b="1">
+              <a:rPr sz="1100" b="1">
                 <a:solidFill>
                   <a:srgbClr val="FFFFFF"/>
                 </a:solidFill>
@@ -14647,14 +15235,149 @@
       </p:sp>
       <p:sp>
         <p:nvSpPr>
-          <p:cNvPr id="85" name="TextBox 84"/>
-          <p:cNvSpPr txBox="1"/>
-          <p:nvPr/>
-        </p:nvSpPr>
-        <p:spPr>
-          <a:xfrm>
-            <a:off x="6812280" y="2240280"/>
-            <a:ext cx="1920240" cy="457200"/>
+          <p:cNvPr id="92" name="TextBox 91"/>
+          <p:cNvSpPr txBox="1"/>
+          <p:nvPr/>
+        </p:nvSpPr>
+        <p:spPr>
+          <a:xfrm>
+            <a:off x="6757416" y="2103120"/>
+            <a:ext cx="2011680" cy="274320"/>
+          </a:xfrm>
+          <a:prstGeom prst="rect">
+            <a:avLst/>
+          </a:prstGeom>
+          <a:noFill/>
+        </p:spPr>
+        <p:txBody>
+          <a:bodyPr wrap="square" anchor="t" lIns="0" rIns="0" tIns="27432" bIns="27432">
+            <a:spAutoFit/>
+          </a:bodyPr>
+          <a:lstStyle/>
+          <a:p>
+            <a:pPr algn="l"/>
+            <a:r>
+              <a:rPr sz="1400" b="1" i="0">
+                <a:solidFill>
+                  <a:srgbClr val="0F3D4C"/>
+                </a:solidFill>
+                <a:latin typeface="Arial"/>
+              </a:rPr>
+              <a:t>Human signs</a:t>
+            </a:r>
+          </a:p>
+        </p:txBody>
+      </p:sp>
+      <p:sp>
+        <p:nvSpPr>
+          <p:cNvPr id="93" name="TextBox 92"/>
+          <p:cNvSpPr txBox="1"/>
+          <p:nvPr/>
+        </p:nvSpPr>
+        <p:spPr>
+          <a:xfrm>
+            <a:off x="6757416" y="2340864"/>
+            <a:ext cx="2011680" cy="182880"/>
+          </a:xfrm>
+          <a:prstGeom prst="rect">
+            <a:avLst/>
+          </a:prstGeom>
+          <a:noFill/>
+        </p:spPr>
+        <p:txBody>
+          <a:bodyPr wrap="square" anchor="t" lIns="0" rIns="0" tIns="27432" bIns="27432">
+            <a:spAutoFit/>
+          </a:bodyPr>
+          <a:lstStyle/>
+          <a:p>
+            <a:pPr algn="l"/>
+            <a:r>
+              <a:rPr sz="750" b="1" i="0">
+                <a:solidFill>
+                  <a:srgbClr val="2A7F8E"/>
+                </a:solidFill>
+                <a:latin typeface="Arial"/>
+              </a:rPr>
+              <a:t>KEEPS: ACCOUNTABILITY</a:t>
+            </a:r>
+          </a:p>
+        </p:txBody>
+      </p:sp>
+      <p:sp>
+        <p:nvSpPr>
+          <p:cNvPr id="94" name="TextBox 93"/>
+          <p:cNvSpPr txBox="1"/>
+          <p:nvPr/>
+        </p:nvSpPr>
+        <p:spPr>
+          <a:xfrm>
+            <a:off x="6318504" y="2633472"/>
+            <a:ext cx="2404872" cy="1143000"/>
+          </a:xfrm>
+          <a:prstGeom prst="rect">
+            <a:avLst/>
+          </a:prstGeom>
+          <a:noFill/>
+        </p:spPr>
+        <p:txBody>
+          <a:bodyPr wrap="square" anchor="t" lIns="0" rIns="0" tIns="27432" bIns="27432">
+            <a:spAutoFit/>
+          </a:bodyPr>
+          <a:lstStyle/>
+          <a:p>
+            <a:pPr algn="l"/>
+            <a:r>
+              <a:rPr sz="950" b="0" i="0">
+                <a:solidFill>
+                  <a:srgbClr val="202124"/>
+                </a:solidFill>
+                <a:latin typeface="Arial"/>
+              </a:rPr>
+              <a:t>The underwriter accepts or dismisses each objection and signs. Every agent call is logged; decisions re-weight the next run.</a:t>
+            </a:r>
+          </a:p>
+        </p:txBody>
+      </p:sp>
+      <p:sp>
+        <p:nvSpPr>
+          <p:cNvPr id="95" name="Rounded Rectangle 94"/>
+          <p:cNvSpPr/>
+          <p:nvPr/>
+        </p:nvSpPr>
+        <p:spPr>
+          <a:xfrm>
+            <a:off x="6281928" y="3767328"/>
+            <a:ext cx="2478024" cy="658368"/>
+          </a:xfrm>
+          <a:prstGeom prst="roundRect">
+            <a:avLst>
+              <a:gd name="adj" fmla="val 8000"/>
+            </a:avLst>
+          </a:prstGeom>
+          <a:solidFill>
+            <a:srgbClr val="E6F2F4"/>
+          </a:solidFill>
+          <a:ln>
+            <a:noFill/>
+          </a:ln>
+          <a:effectLst/>
+        </p:spPr>
+        <p:txBody>
+          <a:bodyPr rtlCol="0" anchor="ctr"/>
+          <a:lstStyle/>
+          <a:p/>
+        </p:txBody>
+      </p:sp>
+      <p:sp>
+        <p:nvSpPr>
+          <p:cNvPr id="96" name="TextBox 95"/>
+          <p:cNvSpPr txBox="1"/>
+          <p:nvPr/>
+        </p:nvSpPr>
+        <p:spPr>
+          <a:xfrm>
+            <a:off x="6373368" y="3794760"/>
+            <a:ext cx="2295144" cy="612648"/>
           </a:xfrm>
           <a:prstGeom prst="rect">
             <a:avLst/>
@@ -14669,27 +15392,36 @@
           <a:p>
             <a:pPr algn="l"/>
             <a:r>
-              <a:rPr sz="1600" b="1" i="0">
+              <a:rPr sz="900" b="1" i="0">
                 <a:solidFill>
                   <a:srgbClr val="0F3D4C"/>
                 </a:solidFill>
                 <a:latin typeface="Arial"/>
               </a:rPr>
-              <a:t>Human signs</a:t>
-            </a:r>
-          </a:p>
-        </p:txBody>
-      </p:sp>
-      <p:sp>
-        <p:nvSpPr>
-          <p:cNvPr id="86" name="TextBox 85"/>
-          <p:cNvSpPr txBox="1"/>
-          <p:nvPr/>
-        </p:nvSpPr>
-        <p:spPr>
-          <a:xfrm>
-            <a:off x="6336792" y="2788920"/>
-            <a:ext cx="2368296" cy="1371600"/>
+              <a:t>In Linh's file: </a:t>
+            </a:r>
+            <a:r>
+              <a:rPr sz="900" b="0" i="0">
+                <a:solidFill>
+                  <a:srgbClr val="202124"/>
+                </a:solidFill>
+                <a:latin typeface="Arial"/>
+              </a:rPr>
+              <a:t>Linh gets the decision and the conditions to meet, in Vietnamese.</a:t>
+            </a:r>
+          </a:p>
+        </p:txBody>
+      </p:sp>
+      <p:sp>
+        <p:nvSpPr>
+          <p:cNvPr id="97" name="TextBox 96"/>
+          <p:cNvSpPr txBox="1"/>
+          <p:nvPr/>
+        </p:nvSpPr>
+        <p:spPr>
+          <a:xfrm>
+            <a:off x="274320" y="4617720"/>
+            <a:ext cx="8595360" cy="365760"/>
           </a:xfrm>
           <a:prstGeom prst="rect">
             <a:avLst/>
@@ -14704,57 +15436,22 @@
           <a:p>
             <a:pPr algn="l"/>
             <a:r>
-              <a:rPr sz="1100" b="0" i="0">
-                <a:solidFill>
-                  <a:srgbClr val="202124"/>
+              <a:rPr sz="1050" b="1" i="0">
+                <a:solidFill>
+                  <a:srgbClr val="0F3D4C"/>
                 </a:solidFill>
                 <a:latin typeface="Arial"/>
               </a:rPr>
-              <a:t>The underwriter accepts or dismisses each objection and signs. Every decision is logged and re-weights the next Challenger run. The applicant gets the reasons in their own language.</a:t>
-            </a:r>
-          </a:p>
-        </p:txBody>
-      </p:sp>
-      <p:sp>
-        <p:nvSpPr>
-          <p:cNvPr id="87" name="TextBox 86"/>
-          <p:cNvSpPr txBox="1"/>
-          <p:nvPr/>
-        </p:nvSpPr>
-        <p:spPr>
-          <a:xfrm>
-            <a:off x="274320" y="4434840"/>
-            <a:ext cx="8595360" cy="457200"/>
-          </a:xfrm>
-          <a:prstGeom prst="rect">
-            <a:avLst/>
-          </a:prstGeom>
-          <a:noFill/>
-        </p:spPr>
-        <p:txBody>
-          <a:bodyPr wrap="square" anchor="t" lIns="45720" rIns="45720" tIns="27432" bIns="27432">
-            <a:spAutoFit/>
-          </a:bodyPr>
-          <a:lstStyle/>
-          <a:p>
-            <a:pPr algn="l"/>
-            <a:r>
-              <a:rPr sz="1300" b="1" i="0">
-                <a:solidFill>
-                  <a:srgbClr val="0F3D4C"/>
+              <a:t>Grounded only in the applicant's documents. </a:t>
+            </a:r>
+            <a:r>
+              <a:rPr sz="1050" b="0" i="0">
+                <a:solidFill>
+                  <a:srgbClr val="5F6368"/>
                 </a:solidFill>
                 <a:latin typeface="Arial"/>
               </a:rPr>
-              <a:t>Not a score. A memo. </a:t>
-            </a:r>
-            <a:r>
-              <a:rPr sz="1300" b="0" i="0">
-                <a:solidFill>
-                  <a:srgbClr val="5F6368"/>
-                </a:solidFill>
-                <a:latin typeface="Arial"/>
-              </a:rPr>
-              <a:t>AI does the reading and the arguing; the underwriter keeps the decision.</a:t>
+              <a:t>Guardrails: output schema, deterministic checks, a second agent, a human signature.</a:t>
             </a:r>
           </a:p>
         </p:txBody>
@@ -15074,8 +15771,8 @@
         </p:nvSpPr>
         <p:spPr>
           <a:xfrm>
-            <a:off x="274320" y="1115568"/>
-            <a:ext cx="8595360" cy="457200"/>
+            <a:off x="274320" y="1078992"/>
+            <a:ext cx="8595360" cy="274320"/>
           </a:xfrm>
           <a:prstGeom prst="rect">
             <a:avLst/>
@@ -15090,27 +15787,62 @@
           <a:p>
             <a:pPr algn="l"/>
             <a:r>
+              <a:rPr sz="900" b="1" i="0">
+                <a:solidFill>
+                  <a:srgbClr val="2A7F8E"/>
+                </a:solidFill>
+                <a:latin typeface="Arial"/>
+              </a:rPr>
+              <a:t>EXPECTED IMPACT</a:t>
+            </a:r>
+          </a:p>
+        </p:txBody>
+      </p:sp>
+      <p:sp>
+        <p:nvSpPr>
+          <p:cNvPr id="81" name="TextBox 80"/>
+          <p:cNvSpPr txBox="1"/>
+          <p:nvPr/>
+        </p:nvSpPr>
+        <p:spPr>
+          <a:xfrm>
+            <a:off x="274320" y="1280160"/>
+            <a:ext cx="8595360" cy="411480"/>
+          </a:xfrm>
+          <a:prstGeom prst="rect">
+            <a:avLst/>
+          </a:prstGeom>
+          <a:noFill/>
+        </p:spPr>
+        <p:txBody>
+          <a:bodyPr wrap="square" anchor="t" lIns="45720" rIns="45720" tIns="27432" bIns="27432">
+            <a:spAutoFit/>
+          </a:bodyPr>
+          <a:lstStyle/>
+          <a:p>
+            <a:pPr algn="l"/>
+            <a:r>
               <a:rPr sz="1900" b="1" i="0">
                 <a:solidFill>
                   <a:srgbClr val="0F3D4C"/>
                 </a:solidFill>
                 <a:latin typeface="Arial"/>
               </a:rPr>
-              <a:t>Same documents. About 2 minutes per file. Every number defensible.</a:t>
-            </a:r>
-          </a:p>
-        </p:txBody>
-      </p:sp>
-      <p:sp>
-        <p:nvSpPr>
-          <p:cNvPr id="81" name="Rounded Rectangle 80"/>
+              <a:t>What changes, and for whom.</a:t>
+            </a:r>
+          </a:p>
+        </p:txBody>
+      </p:sp>
+      <p:sp>
+        <p:nvSpPr>
+          <p:cNvPr id="82" name="Rounded Rectangle 81"/>
           <p:cNvSpPr/>
           <p:nvPr/>
         </p:nvSpPr>
         <p:spPr>
           <a:xfrm>
-            <a:off x="274320" y="1645920"/>
-            <a:ext cx="2743200" cy="1234440"/>
+            <a:off x="274320" y="1783080"/>
+            <a:ext cx="2743200" cy="1874519"/>
           </a:xfrm>
           <a:prstGeom prst="roundRect">
             <a:avLst>
@@ -15135,14 +15867,55 @@
       </p:sp>
       <p:sp>
         <p:nvSpPr>
-          <p:cNvPr id="82" name="TextBox 81"/>
-          <p:cNvSpPr txBox="1"/>
-          <p:nvPr/>
-        </p:nvSpPr>
-        <p:spPr>
-          <a:xfrm>
-            <a:off x="438912" y="1737360"/>
-            <a:ext cx="2468880" cy="731520"/>
+          <p:cNvPr id="83" name="Rounded Rectangle 82"/>
+          <p:cNvSpPr/>
+          <p:nvPr/>
+        </p:nvSpPr>
+        <p:spPr>
+          <a:xfrm>
+            <a:off x="420623" y="1892807"/>
+            <a:ext cx="1691640" cy="256032"/>
+          </a:xfrm>
+          <a:prstGeom prst="roundRect">
+            <a:avLst>
+              <a:gd name="adj" fmla="val 50000"/>
+            </a:avLst>
+          </a:prstGeom>
+          <a:solidFill>
+            <a:srgbClr val="0F3D4C"/>
+          </a:solidFill>
+          <a:ln>
+            <a:noFill/>
+          </a:ln>
+          <a:effectLst/>
+        </p:spPr>
+        <p:txBody>
+          <a:bodyPr rtlCol="0" anchor="ctr" lIns="36576" rIns="36576" tIns="0" bIns="0"/>
+          <a:lstStyle/>
+          <a:p>
+            <a:pPr algn="ctr"/>
+            <a:r>
+              <a:rPr sz="850" b="1">
+                <a:solidFill>
+                  <a:srgbClr val="FFFFFF"/>
+                </a:solidFill>
+                <a:latin typeface="Arial"/>
+              </a:rPr>
+              <a:t>For the lender</a:t>
+            </a:r>
+          </a:p>
+        </p:txBody>
+      </p:sp>
+      <p:sp>
+        <p:nvSpPr>
+          <p:cNvPr id="84" name="TextBox 83"/>
+          <p:cNvSpPr txBox="1"/>
+          <p:nvPr/>
+        </p:nvSpPr>
+        <p:spPr>
+          <a:xfrm>
+            <a:off x="420623" y="2240280"/>
+            <a:ext cx="2468880" cy="640080"/>
           </a:xfrm>
           <a:prstGeom prst="rect">
             <a:avLst/>
@@ -15157,27 +15930,27 @@
           <a:p>
             <a:pPr algn="l"/>
             <a:r>
-              <a:rPr sz="3800" b="1" i="0">
+              <a:rPr sz="3200" b="1" i="0">
                 <a:solidFill>
                   <a:srgbClr val="0F3D4C"/>
                 </a:solidFill>
                 <a:latin typeface="Arial"/>
               </a:rPr>
-              <a:t>~2 min</a:t>
-            </a:r>
-          </a:p>
-        </p:txBody>
-      </p:sp>
-      <p:sp>
-        <p:nvSpPr>
-          <p:cNvPr id="83" name="TextBox 82"/>
-          <p:cNvSpPr txBox="1"/>
-          <p:nvPr/>
-        </p:nvSpPr>
-        <p:spPr>
-          <a:xfrm>
-            <a:off x="438912" y="2487168"/>
-            <a:ext cx="2468880" cy="365760"/>
+              <a:t>45 → 2</a:t>
+            </a:r>
+          </a:p>
+        </p:txBody>
+      </p:sp>
+      <p:sp>
+        <p:nvSpPr>
+          <p:cNvPr id="85" name="TextBox 84"/>
+          <p:cNvSpPr txBox="1"/>
+          <p:nvPr/>
+        </p:nvSpPr>
+        <p:spPr>
+          <a:xfrm>
+            <a:off x="420623" y="2852928"/>
+            <a:ext cx="2468880" cy="274320"/>
           </a:xfrm>
           <a:prstGeom prst="rect">
             <a:avLst/>
@@ -15192,27 +15965,62 @@
           <a:p>
             <a:pPr algn="l"/>
             <a:r>
-              <a:rPr sz="1050" b="0" i="0">
-                <a:solidFill>
-                  <a:srgbClr val="5F6368"/>
+              <a:rPr sz="1050" b="1" i="0">
+                <a:solidFill>
+                  <a:srgbClr val="2A7F8E"/>
                 </a:solidFill>
                 <a:latin typeface="Arial"/>
               </a:rPr>
-              <a:t>per file, end to end (measured, live Gemini)</a:t>
-            </a:r>
-          </a:p>
-        </p:txBody>
-      </p:sp>
-      <p:sp>
-        <p:nvSpPr>
-          <p:cNvPr id="84" name="Rounded Rectangle 83"/>
+              <a:t>minutes per file</a:t>
+            </a:r>
+          </a:p>
+        </p:txBody>
+      </p:sp>
+      <p:sp>
+        <p:nvSpPr>
+          <p:cNvPr id="86" name="TextBox 85"/>
+          <p:cNvSpPr txBox="1"/>
+          <p:nvPr/>
+        </p:nvSpPr>
+        <p:spPr>
+          <a:xfrm>
+            <a:off x="420623" y="3154680"/>
+            <a:ext cx="2468880" cy="685800"/>
+          </a:xfrm>
+          <a:prstGeom prst="rect">
+            <a:avLst/>
+          </a:prstGeom>
+          <a:noFill/>
+        </p:spPr>
+        <p:txBody>
+          <a:bodyPr wrap="square" anchor="t" lIns="0" rIns="0" tIns="27432" bIns="27432">
+            <a:spAutoFit/>
+          </a:bodyPr>
+          <a:lstStyle/>
+          <a:p>
+            <a:pPr algn="l"/>
+            <a:r>
+              <a:rPr sz="950" b="0" i="0">
+                <a:solidFill>
+                  <a:srgbClr val="202124"/>
+                </a:solidFill>
+                <a:latin typeface="Arial"/>
+              </a:rPr>
+              <a:t>USD ~11 → 0.28 per case. Small-ticket loans become worth underwriting.</a:t>
+            </a:r>
+          </a:p>
+        </p:txBody>
+      </p:sp>
+      <p:sp>
+        <p:nvSpPr>
+          <p:cNvPr id="87" name="Rounded Rectangle 86"/>
           <p:cNvSpPr/>
           <p:nvPr/>
         </p:nvSpPr>
         <p:spPr>
           <a:xfrm>
-            <a:off x="3200400" y="1645920"/>
-            <a:ext cx="2743200" cy="1234440"/>
+            <a:off x="3200400" y="1783080"/>
+            <a:ext cx="2743200" cy="1874519"/>
           </a:xfrm>
           <a:prstGeom prst="roundRect">
             <a:avLst>
@@ -15237,14 +16045,55 @@
       </p:sp>
       <p:sp>
         <p:nvSpPr>
-          <p:cNvPr id="85" name="TextBox 84"/>
-          <p:cNvSpPr txBox="1"/>
-          <p:nvPr/>
-        </p:nvSpPr>
-        <p:spPr>
-          <a:xfrm>
-            <a:off x="3364992" y="1737360"/>
-            <a:ext cx="2468880" cy="731520"/>
+          <p:cNvPr id="88" name="Rounded Rectangle 87"/>
+          <p:cNvSpPr/>
+          <p:nvPr/>
+        </p:nvSpPr>
+        <p:spPr>
+          <a:xfrm>
+            <a:off x="3346704" y="1892807"/>
+            <a:ext cx="1691640" cy="256032"/>
+          </a:xfrm>
+          <a:prstGeom prst="roundRect">
+            <a:avLst>
+              <a:gd name="adj" fmla="val 50000"/>
+            </a:avLst>
+          </a:prstGeom>
+          <a:solidFill>
+            <a:srgbClr val="0F3D4C"/>
+          </a:solidFill>
+          <a:ln>
+            <a:noFill/>
+          </a:ln>
+          <a:effectLst/>
+        </p:spPr>
+        <p:txBody>
+          <a:bodyPr rtlCol="0" anchor="ctr" lIns="36576" rIns="36576" tIns="0" bIns="0"/>
+          <a:lstStyle/>
+          <a:p>
+            <a:pPr algn="ctr"/>
+            <a:r>
+              <a:rPr sz="850" b="1">
+                <a:solidFill>
+                  <a:srgbClr val="FFFFFF"/>
+                </a:solidFill>
+                <a:latin typeface="Arial"/>
+              </a:rPr>
+              <a:t>For the small business</a:t>
+            </a:r>
+          </a:p>
+        </p:txBody>
+      </p:sp>
+      <p:sp>
+        <p:nvSpPr>
+          <p:cNvPr id="89" name="TextBox 88"/>
+          <p:cNvSpPr txBox="1"/>
+          <p:nvPr/>
+        </p:nvSpPr>
+        <p:spPr>
+          <a:xfrm>
+            <a:off x="3346704" y="2240280"/>
+            <a:ext cx="2468880" cy="640080"/>
           </a:xfrm>
           <a:prstGeom prst="rect">
             <a:avLst/>
@@ -15259,27 +16108,27 @@
           <a:p>
             <a:pPr algn="l"/>
             <a:r>
-              <a:rPr sz="3800" b="1" i="0">
+              <a:rPr sz="3200" b="1" i="0">
                 <a:solidFill>
                   <a:srgbClr val="0F3D4C"/>
                 </a:solidFill>
                 <a:latin typeface="Arial"/>
               </a:rPr>
-              <a:t>~0.28</a:t>
-            </a:r>
-          </a:p>
-        </p:txBody>
-      </p:sp>
-      <p:sp>
-        <p:nvSpPr>
-          <p:cNvPr id="86" name="TextBox 85"/>
-          <p:cNvSpPr txBox="1"/>
-          <p:nvPr/>
-        </p:nvSpPr>
-        <p:spPr>
-          <a:xfrm>
-            <a:off x="3364992" y="2487168"/>
-            <a:ext cx="2468880" cy="365760"/>
+              <a:t>Cash flow</a:t>
+            </a:r>
+          </a:p>
+        </p:txBody>
+      </p:sp>
+      <p:sp>
+        <p:nvSpPr>
+          <p:cNvPr id="90" name="TextBox 89"/>
+          <p:cNvSpPr txBox="1"/>
+          <p:nvPr/>
+        </p:nvSpPr>
+        <p:spPr>
+          <a:xfrm>
+            <a:off x="3346704" y="2852928"/>
+            <a:ext cx="2468880" cy="274320"/>
           </a:xfrm>
           <a:prstGeom prst="rect">
             <a:avLst/>
@@ -15294,27 +16143,62 @@
           <a:p>
             <a:pPr algn="l"/>
             <a:r>
-              <a:rPr sz="1050" b="0" i="0">
-                <a:solidFill>
-                  <a:srgbClr val="5F6368"/>
+              <a:rPr sz="1050" b="1" i="0">
+                <a:solidFill>
+                  <a:srgbClr val="2A7F8E"/>
                 </a:solidFill>
                 <a:latin typeface="Arial"/>
               </a:rPr>
-              <a:t>USD per case on a cold run; USD 0 on a cached re-run</a:t>
-            </a:r>
-          </a:p>
-        </p:txBody>
-      </p:sp>
-      <p:sp>
-        <p:nvSpPr>
-          <p:cNvPr id="87" name="Rounded Rectangle 86"/>
+              <a:t>not collateral, decides the loan</a:t>
+            </a:r>
+          </a:p>
+        </p:txBody>
+      </p:sp>
+      <p:sp>
+        <p:nvSpPr>
+          <p:cNvPr id="91" name="TextBox 90"/>
+          <p:cNvSpPr txBox="1"/>
+          <p:nvPr/>
+        </p:nvSpPr>
+        <p:spPr>
+          <a:xfrm>
+            <a:off x="3346704" y="3154680"/>
+            <a:ext cx="2468880" cy="685800"/>
+          </a:xfrm>
+          <a:prstGeom prst="rect">
+            <a:avLst/>
+          </a:prstGeom>
+          <a:noFill/>
+        </p:spPr>
+        <p:txBody>
+          <a:bodyPr wrap="square" anchor="t" lIns="0" rIns="0" tIns="27432" bIns="27432">
+            <a:spAutoFit/>
+          </a:bodyPr>
+          <a:lstStyle/>
+          <a:p>
+            <a:pPr algn="l"/>
+            <a:r>
+              <a:rPr sz="950" b="0" i="0">
+                <a:solidFill>
+                  <a:srgbClr val="202124"/>
+                </a:solidFill>
+                <a:latin typeface="Arial"/>
+              </a:rPr>
+              <a:t>Assessed on the records she already has. A no comes with reasons, in her own language.</a:t>
+            </a:r>
+          </a:p>
+        </p:txBody>
+      </p:sp>
+      <p:sp>
+        <p:nvSpPr>
+          <p:cNvPr id="92" name="Rounded Rectangle 91"/>
           <p:cNvSpPr/>
           <p:nvPr/>
         </p:nvSpPr>
         <p:spPr>
           <a:xfrm>
-            <a:off x="6126480" y="1645920"/>
-            <a:ext cx="2743200" cy="1234440"/>
+            <a:off x="6126480" y="1783080"/>
+            <a:ext cx="2743200" cy="1874519"/>
           </a:xfrm>
           <a:prstGeom prst="roundRect">
             <a:avLst>
@@ -15339,14 +16223,55 @@
       </p:sp>
       <p:sp>
         <p:nvSpPr>
-          <p:cNvPr id="88" name="TextBox 87"/>
-          <p:cNvSpPr txBox="1"/>
-          <p:nvPr/>
-        </p:nvSpPr>
-        <p:spPr>
-          <a:xfrm>
-            <a:off x="6291072" y="1737360"/>
-            <a:ext cx="2468880" cy="731520"/>
+          <p:cNvPr id="93" name="Rounded Rectangle 92"/>
+          <p:cNvSpPr/>
+          <p:nvPr/>
+        </p:nvSpPr>
+        <p:spPr>
+          <a:xfrm>
+            <a:off x="6272784" y="1892807"/>
+            <a:ext cx="1691640" cy="256032"/>
+          </a:xfrm>
+          <a:prstGeom prst="roundRect">
+            <a:avLst>
+              <a:gd name="adj" fmla="val 50000"/>
+            </a:avLst>
+          </a:prstGeom>
+          <a:solidFill>
+            <a:srgbClr val="E0A100"/>
+          </a:solidFill>
+          <a:ln>
+            <a:noFill/>
+          </a:ln>
+          <a:effectLst/>
+        </p:spPr>
+        <p:txBody>
+          <a:bodyPr rtlCol="0" anchor="ctr" lIns="36576" rIns="36576" tIns="0" bIns="0"/>
+          <a:lstStyle/>
+          <a:p>
+            <a:pPr algn="ctr"/>
+            <a:r>
+              <a:rPr sz="850" b="1">
+                <a:solidFill>
+                  <a:srgbClr val="0F3D4C"/>
+                </a:solidFill>
+                <a:latin typeface="Arial"/>
+              </a:rPr>
+              <a:t>For risk and audit</a:t>
+            </a:r>
+          </a:p>
+        </p:txBody>
+      </p:sp>
+      <p:sp>
+        <p:nvSpPr>
+          <p:cNvPr id="94" name="TextBox 93"/>
+          <p:cNvSpPr txBox="1"/>
+          <p:nvPr/>
+        </p:nvSpPr>
+        <p:spPr>
+          <a:xfrm>
+            <a:off x="6272784" y="2240280"/>
+            <a:ext cx="2468880" cy="640080"/>
           </a:xfrm>
           <a:prstGeom prst="rect">
             <a:avLst/>
@@ -15361,27 +16286,27 @@
           <a:p>
             <a:pPr algn="l"/>
             <a:r>
-              <a:rPr sz="3800" b="1" i="0">
+              <a:rPr sz="3200" b="1" i="0">
                 <a:solidFill>
                   <a:srgbClr val="0F3D4C"/>
                 </a:solidFill>
                 <a:latin typeface="Arial"/>
               </a:rPr>
-              <a:t>0 vs 62</a:t>
-            </a:r>
-          </a:p>
-        </p:txBody>
-      </p:sp>
-      <p:sp>
-        <p:nvSpPr>
-          <p:cNvPr id="89" name="TextBox 88"/>
-          <p:cNvSpPr txBox="1"/>
-          <p:nvPr/>
-        </p:nvSpPr>
-        <p:spPr>
-          <a:xfrm>
-            <a:off x="6291072" y="2487168"/>
-            <a:ext cx="2468880" cy="365760"/>
+              <a:t>77% → 0%</a:t>
+            </a:r>
+          </a:p>
+        </p:txBody>
+      </p:sp>
+      <p:sp>
+        <p:nvSpPr>
+          <p:cNvPr id="95" name="TextBox 94"/>
+          <p:cNvSpPr txBox="1"/>
+          <p:nvPr/>
+        </p:nvSpPr>
+        <p:spPr>
+          <a:xfrm>
+            <a:off x="6272784" y="2852928"/>
+            <a:ext cx="2468880" cy="274320"/>
           </a:xfrm>
           <a:prstGeom prst="rect">
             <a:avLst/>
@@ -15396,40 +16321,73 @@
           <a:p>
             <a:pPr algn="l"/>
             <a:r>
-              <a:rPr sz="1050" b="0" i="0">
-                <a:solidFill>
-                  <a:srgbClr val="5F6368"/>
+              <a:rPr sz="1050" b="1" i="0">
+                <a:solidFill>
+                  <a:srgbClr val="2A7F8E"/>
                 </a:solidFill>
                 <a:latin typeface="Arial"/>
               </a:rPr>
-              <a:t>unsourced numbers in the memo: LedgerLens vs a single prompt</a:t>
-            </a:r>
-          </a:p>
-        </p:txBody>
-      </p:sp>
-      <p:sp>
-        <p:nvSpPr>
-          <p:cNvPr id="90" name="Rounded Rectangle 89"/>
+              <a:t>of memo numbers with no page</a:t>
+            </a:r>
+          </a:p>
+        </p:txBody>
+      </p:sp>
+      <p:sp>
+        <p:nvSpPr>
+          <p:cNvPr id="96" name="TextBox 95"/>
+          <p:cNvSpPr txBox="1"/>
+          <p:nvPr/>
+        </p:nvSpPr>
+        <p:spPr>
+          <a:xfrm>
+            <a:off x="6272784" y="3154680"/>
+            <a:ext cx="2468880" cy="685800"/>
+          </a:xfrm>
+          <a:prstGeom prst="rect">
+            <a:avLst/>
+          </a:prstGeom>
+          <a:noFill/>
+        </p:spPr>
+        <p:txBody>
+          <a:bodyPr wrap="square" anchor="t" lIns="0" rIns="0" tIns="27432" bIns="27432">
+            <a:spAutoFit/>
+          </a:bodyPr>
+          <a:lstStyle/>
+          <a:p>
+            <a:pPr algn="l"/>
+            <a:r>
+              <a:rPr sz="950" b="0" i="0">
+                <a:solidFill>
+                  <a:srgbClr val="202124"/>
+                </a:solidFill>
+                <a:latin typeface="Arial"/>
+              </a:rPr>
+              <a:t>Every figure points to a page and box, so nothing is re-checked by hand. Planted risks caught: 90% vs 15%.</a:t>
+            </a:r>
+          </a:p>
+        </p:txBody>
+      </p:sp>
+      <p:sp>
+        <p:nvSpPr>
+          <p:cNvPr id="97" name="Rounded Rectangle 96"/>
           <p:cNvSpPr/>
           <p:nvPr/>
         </p:nvSpPr>
         <p:spPr>
           <a:xfrm>
-            <a:off x="274320" y="3017520"/>
-            <a:ext cx="4206240" cy="1874519"/>
+            <a:off x="274320" y="3794760"/>
+            <a:ext cx="8595360" cy="502920"/>
           </a:xfrm>
           <a:prstGeom prst="roundRect">
             <a:avLst>
-              <a:gd name="adj" fmla="val 6000"/>
+              <a:gd name="adj" fmla="val 8000"/>
             </a:avLst>
           </a:prstGeom>
           <a:solidFill>
-            <a:srgbClr val="FFFFFF"/>
+            <a:srgbClr val="0F3D4C"/>
           </a:solidFill>
-          <a:ln w="12700">
-            <a:solidFill>
-              <a:srgbClr val="D5DBDE"/>
-            </a:solidFill>
+          <a:ln>
+            <a:noFill/>
           </a:ln>
           <a:effectLst/>
         </p:spPr>
@@ -15441,14 +16399,58 @@
       </p:sp>
       <p:sp>
         <p:nvSpPr>
-          <p:cNvPr id="91" name="TextBox 90"/>
-          <p:cNvSpPr txBox="1"/>
-          <p:nvPr/>
-        </p:nvSpPr>
-        <p:spPr>
-          <a:xfrm>
-            <a:off x="438912" y="3090672"/>
-            <a:ext cx="3931920" cy="365760"/>
+          <p:cNvPr id="98" name="TextBox 97"/>
+          <p:cNvSpPr txBox="1"/>
+          <p:nvPr/>
+        </p:nvSpPr>
+        <p:spPr>
+          <a:xfrm>
+            <a:off x="411480" y="3813048"/>
+            <a:ext cx="8321040" cy="466344"/>
+          </a:xfrm>
+          <a:prstGeom prst="rect">
+            <a:avLst/>
+          </a:prstGeom>
+          <a:noFill/>
+        </p:spPr>
+        <p:txBody>
+          <a:bodyPr wrap="square" anchor="ctr" lIns="0" rIns="0" tIns="27432" bIns="27432">
+            <a:spAutoFit/>
+          </a:bodyPr>
+          <a:lstStyle/>
+          <a:p>
+            <a:pPr algn="l"/>
+            <a:r>
+              <a:rPr sz="950" b="1" i="0">
+                <a:solidFill>
+                  <a:srgbClr val="E0A100"/>
+                </a:solidFill>
+                <a:latin typeface="Arial"/>
+              </a:rPr>
+              <a:t>USP   </a:t>
+            </a:r>
+            <a:r>
+              <a:rPr sz="950" b="0" i="0">
+                <a:solidFill>
+                  <a:srgbClr val="FFFFFF"/>
+                </a:solidFill>
+                <a:latin typeface="Arial"/>
+              </a:rPr>
+              <a:t>The writer and the verifier are separate agents · numbers are computed by code, never generated · every number clicks back to its source line · decisions re-weight the checks</a:t>
+            </a:r>
+          </a:p>
+        </p:txBody>
+      </p:sp>
+      <p:sp>
+        <p:nvSpPr>
+          <p:cNvPr id="99" name="TextBox 98"/>
+          <p:cNvSpPr txBox="1"/>
+          <p:nvPr/>
+        </p:nvSpPr>
+        <p:spPr>
+          <a:xfrm>
+            <a:off x="274320" y="4407408"/>
+            <a:ext cx="8595360" cy="365760"/>
           </a:xfrm>
           <a:prstGeom prst="rect">
             <a:avLst/>
@@ -15463,27 +16465,36 @@
           <a:p>
             <a:pPr algn="l"/>
             <a:r>
-              <a:rPr sz="1350" b="1" i="0">
+              <a:rPr sz="1100" b="1" i="0">
                 <a:solidFill>
                   <a:srgbClr val="0F3D4C"/>
                 </a:solidFill>
                 <a:latin typeface="Arial"/>
               </a:rPr>
-              <a:t>How it is different</a:t>
-            </a:r>
-          </a:p>
-        </p:txBody>
-      </p:sp>
-      <p:sp>
-        <p:nvSpPr>
-          <p:cNvPr id="92" name="TextBox 91"/>
-          <p:cNvSpPr txBox="1"/>
-          <p:nvPr/>
-        </p:nvSpPr>
-        <p:spPr>
-          <a:xfrm>
-            <a:off x="438912" y="3474720"/>
-            <a:ext cx="3931920" cy="1371600"/>
+              <a:t>Back to the 8.8%: </a:t>
+            </a:r>
+            <a:r>
+              <a:rPr sz="1100" b="0" i="0">
+                <a:solidFill>
+                  <a:srgbClr val="5F6368"/>
+                </a:solidFill>
+                <a:latin typeface="Arial"/>
+              </a:rPr>
+              <a:t>when reading a file costs cents and minutes instead of an hour, the loans banks decline today become worth making.</a:t>
+            </a:r>
+          </a:p>
+        </p:txBody>
+      </p:sp>
+      <p:sp>
+        <p:nvSpPr>
+          <p:cNvPr id="100" name="TextBox 99"/>
+          <p:cNvSpPr txBox="1"/>
+          <p:nvPr/>
+        </p:nvSpPr>
+        <p:spPr>
+          <a:xfrm>
+            <a:off x="274320" y="4846320"/>
+            <a:ext cx="8595360" cy="182880"/>
           </a:xfrm>
           <a:prstGeom prst="rect">
             <a:avLst/>
@@ -15496,195 +16507,15 @@
           </a:bodyPr>
           <a:lstStyle/>
           <a:p>
-            <a:pPr algn="l" marL="146304" indent="-146304">
-              <a:spcAft>
-                <a:spcPts val="400"/>
-              </a:spcAft>
-              <a:buChar char="•"/>
-            </a:pPr>
-            <a:r>
-              <a:rPr sz="1050" b="0" i="0">
-                <a:solidFill>
-                  <a:srgbClr val="202124"/>
+            <a:pPr algn="l"/>
+            <a:r>
+              <a:rPr sz="700" b="0" i="1">
+                <a:solidFill>
+                  <a:srgbClr val="5F6368"/>
                 </a:solidFill>
                 <a:latin typeface="Arial"/>
               </a:rPr>
-              <a:t>Writer and verifier are separate agents, so the memo is never graded by its author</a:t>
-            </a:r>
-          </a:p>
-          <a:p>
-            <a:pPr algn="l" marL="146304" indent="-146304">
-              <a:spcAft>
-                <a:spcPts val="400"/>
-              </a:spcAft>
-              <a:buChar char="•"/>
-            </a:pPr>
-            <a:r>
-              <a:rPr sz="1050" b="0" i="0">
-                <a:solidFill>
-                  <a:srgbClr val="202124"/>
-                </a:solidFill>
-                <a:latin typeface="Arial"/>
-              </a:rPr>
-              <a:t>Figures are computed by code and linked to their source line, not generated</a:t>
-            </a:r>
-          </a:p>
-          <a:p>
-            <a:pPr algn="l" marL="146304" indent="-146304">
-              <a:spcAft>
-                <a:spcPts val="400"/>
-              </a:spcAft>
-              <a:buChar char="•"/>
-            </a:pPr>
-            <a:r>
-              <a:rPr sz="1050" b="0" i="0">
-                <a:solidFill>
-                  <a:srgbClr val="202124"/>
-                </a:solidFill>
-                <a:latin typeface="Arial"/>
-              </a:rPr>
-              <a:t>Underwriter decisions re-rank the next Challenger run</a:t>
-            </a:r>
-          </a:p>
-        </p:txBody>
-      </p:sp>
-      <p:sp>
-        <p:nvSpPr>
-          <p:cNvPr id="93" name="Rounded Rectangle 92"/>
-          <p:cNvSpPr/>
-          <p:nvPr/>
-        </p:nvSpPr>
-        <p:spPr>
-          <a:xfrm>
-            <a:off x="4663440" y="3017520"/>
-            <a:ext cx="4206240" cy="1874519"/>
-          </a:xfrm>
-          <a:prstGeom prst="roundRect">
-            <a:avLst>
-              <a:gd name="adj" fmla="val 6000"/>
-            </a:avLst>
-          </a:prstGeom>
-          <a:solidFill>
-            <a:srgbClr val="FFFFFF"/>
-          </a:solidFill>
-          <a:ln w="12700">
-            <a:solidFill>
-              <a:srgbClr val="D5DBDE"/>
-            </a:solidFill>
-          </a:ln>
-          <a:effectLst/>
-        </p:spPr>
-        <p:txBody>
-          <a:bodyPr rtlCol="0" anchor="ctr"/>
-          <a:lstStyle/>
-          <a:p/>
-        </p:txBody>
-      </p:sp>
-      <p:sp>
-        <p:nvSpPr>
-          <p:cNvPr id="94" name="TextBox 93"/>
-          <p:cNvSpPr txBox="1"/>
-          <p:nvPr/>
-        </p:nvSpPr>
-        <p:spPr>
-          <a:xfrm>
-            <a:off x="4828031" y="3090672"/>
-            <a:ext cx="3931920" cy="365760"/>
-          </a:xfrm>
-          <a:prstGeom prst="rect">
-            <a:avLst/>
-          </a:prstGeom>
-          <a:noFill/>
-        </p:spPr>
-        <p:txBody>
-          <a:bodyPr wrap="square" anchor="t" lIns="0" rIns="0" tIns="27432" bIns="27432">
-            <a:spAutoFit/>
-          </a:bodyPr>
-          <a:lstStyle/>
-          <a:p>
-            <a:pPr algn="l"/>
-            <a:r>
-              <a:rPr sz="1350" b="1" i="0">
-                <a:solidFill>
-                  <a:srgbClr val="0F3D4C"/>
-                </a:solidFill>
-                <a:latin typeface="Arial"/>
-              </a:rPr>
-              <a:t>Who benefits</a:t>
-            </a:r>
-          </a:p>
-        </p:txBody>
-      </p:sp>
-      <p:sp>
-        <p:nvSpPr>
-          <p:cNvPr id="95" name="TextBox 94"/>
-          <p:cNvSpPr txBox="1"/>
-          <p:nvPr/>
-        </p:nvSpPr>
-        <p:spPr>
-          <a:xfrm>
-            <a:off x="4828031" y="3474720"/>
-            <a:ext cx="3931920" cy="1371600"/>
-          </a:xfrm>
-          <a:prstGeom prst="rect">
-            <a:avLst/>
-          </a:prstGeom>
-          <a:noFill/>
-        </p:spPr>
-        <p:txBody>
-          <a:bodyPr wrap="square" anchor="t" lIns="0" rIns="0" tIns="27432" bIns="27432">
-            <a:spAutoFit/>
-          </a:bodyPr>
-          <a:lstStyle/>
-          <a:p>
-            <a:pPr algn="l" marL="146304" indent="-146304">
-              <a:spcAft>
-                <a:spcPts val="400"/>
-              </a:spcAft>
-              <a:buChar char="•"/>
-            </a:pPr>
-            <a:r>
-              <a:rPr sz="1050" b="0" i="0">
-                <a:solidFill>
-                  <a:srgbClr val="202124"/>
-                </a:solidFill>
-                <a:latin typeface="Arial"/>
-              </a:rPr>
-              <a:t>Small businesses with records but no credit file get assessed on cash flow, not collateral</a:t>
-            </a:r>
-          </a:p>
-          <a:p>
-            <a:pPr algn="l" marL="146304" indent="-146304">
-              <a:spcAft>
-                <a:spcPts val="400"/>
-              </a:spcAft>
-              <a:buChar char="•"/>
-            </a:pPr>
-            <a:r>
-              <a:rPr sz="1050" b="0" i="0">
-                <a:solidFill>
-                  <a:srgbClr val="202124"/>
-                </a:solidFill>
-                <a:latin typeface="Arial"/>
-              </a:rPr>
-              <a:t>A declined applicant receives the reasons, in their own language</a:t>
-            </a:r>
-          </a:p>
-          <a:p>
-            <a:pPr algn="l" marL="146304" indent="-146304">
-              <a:spcAft>
-                <a:spcPts val="400"/>
-              </a:spcAft>
-              <a:buChar char="•"/>
-            </a:pPr>
-            <a:r>
-              <a:rPr sz="1050" b="0" i="0">
-                <a:solidFill>
-                  <a:srgbClr val="202124"/>
-                </a:solidFill>
-                <a:latin typeface="Arial"/>
-              </a:rPr>
-              <a:t>Lenders can offer small-ticket loans that were uneconomic to underwrite</a:t>
+              <a:t>Manual baseline (45 min at USD 15/h) is a team estimate. A number counts as untraceable when no document and page stand behind it; correctness was not measured. Live gemini-3.8-flash on a small synthetic sample.</a:t>
             </a:r>
           </a:p>
         </p:txBody>

</xml_diff>

<commit_message>
Copy edit README and deck text; strip image metadata; budget cap wording
- README and deck copy reads more naturally; numbers, names, URLs and code unchanged.
- Remove embedded tool metadata from screenshot and diagram images (pixels unchanged).
- Tech slide: the USD cap is shared by all instances (persisted), not per process.
</commit_message>
<xml_diff>
--- a/presentation/LedgerLens_AI_Builder_Cup_Submission.pptx
+++ b/presentation/LedgerLens_AI_Builder_Cup_Submission.pptx
@@ -7480,7 +7480,7 @@
                 <a:cs typeface="Google Sans Flex Medium"/>
                 <a:sym typeface="Google Sans Flex Medium"/>
               </a:rPr>
-              <a:t>Technologies to be used in the solution</a:t>
+              <a:t>Technology</a:t>
             </a:r>
             <a:endParaRPr sz="1600">
               <a:latin typeface="Google Sans Flex Medium"/>
@@ -7795,7 +7795,7 @@
                 </a:solidFill>
                 <a:latin typeface="Arial"/>
               </a:rPr>
-              <a:t>One env var moves Extractor, Analyst and Challenger to Pro.</a:t>
+              <a:t>One env var switches Extractor, Analyst and Challenger to Pro.</a:t>
             </a:r>
           </a:p>
         </p:txBody>
@@ -8480,7 +8480,7 @@
                 </a:solidFill>
                 <a:latin typeface="Arial"/>
               </a:rPr>
-              <a:t>Content-hash cache per model and prompt version; hard USD cap per process.</a:t>
+              <a:t>Content-hash cache per model and prompt version; USD cap shared by all instances.</a:t>
             </a:r>
           </a:p>
         </p:txBody>
@@ -9218,7 +9218,7 @@
                           </a:solidFill>
                           <a:latin typeface="Arial"/>
                         </a:rPr>
-                        <a:t>Budget-cap env var stops Gemini calls once spent</a:t>
+                        <a:t>Budget-cap env var stops Gemini calls at the limit</a:t>
                       </a:r>
                     </a:p>
                   </a:txBody>
@@ -9443,7 +9443,7 @@
                 <a:cs typeface="Google Sans Flex Medium"/>
                 <a:sym typeface="Google Sans Flex Medium"/>
               </a:rPr>
-              <a:t>Snapshots of the prototype</a:t>
+              <a:t>Prototype screenshots</a:t>
             </a:r>
             <a:endParaRPr sz="1600">
               <a:latin typeface="Google Sans Flex Medium"/>
@@ -9840,7 +9840,7 @@
                 </a:solidFill>
                 <a:latin typeface="Arial"/>
               </a:rPr>
-              <a:t>Applicant details, then the raw documents. Intake classifies and quality-flags them.</a:t>
+              <a:t>Applicant details, then raw documents. Intake classifies them and flags quality issues.</a:t>
             </a:r>
           </a:p>
         </p:txBody>
@@ -10173,7 +10173,7 @@
                 </a:solidFill>
                 <a:latin typeface="Arial"/>
               </a:rPr>
-              <a:t>Outcome, conditions and rationale, written to the audit log; accept/dismiss rates re-weight the checks.</a:t>
+              <a:t>Outcome, conditions and rationale go into the audit log; accept/dismiss rates set check priorities.</a:t>
             </a:r>
           </a:p>
         </p:txBody>
@@ -10342,7 +10342,7 @@
                 <a:cs typeface="Google Sans Flex Medium"/>
                 <a:sym typeface="Google Sans Flex Medium"/>
               </a:rPr>
-              <a:t>Prototype performance report / Benchmarking</a:t>
+              <a:t>Prototype benchmark</a:t>
             </a:r>
             <a:endParaRPr sz="1600">
               <a:latin typeface="Google Sans Flex Medium"/>
@@ -10532,7 +10532,7 @@
                 </a:solidFill>
                 <a:latin typeface="Arial"/>
               </a:rPr>
-              <a:t>small synthetic sample, read as indicative</a:t>
+              <a:t>small synthetic sample; indicative results</a:t>
             </a:r>
           </a:p>
         </p:txBody>
@@ -10751,7 +10751,7 @@
                 </a:solidFill>
                 <a:latin typeface="Arial"/>
               </a:rPr>
-              <a:t>of memo numbers trace to a page (single prompt: 23%)</a:t>
+              <a:t>of memo numbers link to a page (single prompt: 23%)</a:t>
             </a:r>
           </a:p>
         </p:txBody>
@@ -10853,7 +10853,7 @@
                 </a:solidFill>
                 <a:latin typeface="Arial"/>
               </a:rPr>
-              <a:t>per case cold, USD 0.26-0.31; cached re-run USD 0</a:t>
+              <a:t>per cold case, USD 0.26-0.31; cached re-run USD 0</a:t>
             </a:r>
           </a:p>
         </p:txBody>
@@ -11491,7 +11491,7 @@
                 </a:solidFill>
                 <a:latin typeface="Arial"/>
               </a:rPr>
-              <a:t>How measured. </a:t>
+              <a:t>Measurement. </a:t>
             </a:r>
             <a:r>
               <a:rPr sz="750" b="0" i="0">
@@ -11500,7 +11500,7 @@
                 </a:solidFill>
                 <a:latin typeface="Arial"/>
               </a:rPr>
-              <a:t>Live gemini-3.8-flash runs, 2026-10-15/16, on three synthetic businesses with team-planted risks. Strict scoring: an objection counts only if it carries the risk's identifying amount or document, one objection per risk. </a:t>
+              <a:t>Live gemini-3.8-flash runs, 2026-10-15/16, on three synthetic businesses with team-planted risks. Strict scoring: each objection must include the risk's identifying amount or document, one objection per risk. </a:t>
             </a:r>
             <a:r>
               <a:rPr sz="750" b="0" i="0">
@@ -11509,7 +11509,7 @@
                 </a:solidFill>
                 <a:latin typeface="Arial"/>
               </a:rPr>
-              <a:t>Traceable = a memo number with a document and page behind it; correctness not measured. The sample is small, so read every percentage as indicative. Missed: dashboard gross vs payout, COD vs cash deposits. Recommendation matched on C; A gave approve_with_conditions (expected approve), B request_more_documents (expected approve_with_conditions). *Clean born-digital synthetic PDFs; real scans will be lower.</a:t>
+              <a:t>Traceable = a memo number linked to a document and page; correctness not measured. The sample is small, so every percentage is indicative. Missed: dashboard gross vs payout, COD vs cash deposits. Recommendation matched on C; A gave approve_with_conditions (expected approve), B request_more_documents (expected approve_with_conditions). *Clean born-digital synthetic PDFs; real scans less accurate.</a:t>
             </a:r>
           </a:p>
         </p:txBody>
@@ -11678,7 +11678,7 @@
                 <a:cs typeface="Google Sans Flex Medium"/>
                 <a:sym typeface="Google Sans Flex Medium"/>
               </a:rPr>
-              <a:t>Additional details / Future development</a:t>
+              <a:t>Future development</a:t>
             </a:r>
             <a:endParaRPr sz="1600">
               <a:latin typeface="Google Sans Flex Medium"/>
@@ -11743,7 +11743,7 @@
                 </a:solidFill>
                 <a:latin typeface="Arial"/>
               </a:rPr>
-              <a:t>Humans decide, every figure and decision is traceable, the prototype uses watermarked synthetic data only, and production keeps documents and model endpoints in-region.</a:t>
+              <a:t>Humans decide. Every figure and decision is traceable. The prototype uses only watermarked synthetic data. Production keeps documents and model endpoints in-region.</a:t>
             </a:r>
           </a:p>
         </p:txBody>
@@ -11912,7 +11912,7 @@
                 <a:cs typeface="Google Sans Flex Medium"/>
                 <a:sym typeface="Google Sans Flex Medium"/>
               </a:rPr>
-              <a:t>Provide links to your:</a:t>
+              <a:t>Submission links</a:t>
             </a:r>
             <a:endParaRPr sz="1600">
               <a:latin typeface="Google Sans Flex Medium"/>
@@ -13132,7 +13132,7 @@
                 </a:solidFill>
                 <a:latin typeface="Arial"/>
               </a:rPr>
-              <a:t>Every stage and agent call with version, model and prompt; the trail a regulator can read.</a:t>
+              <a:t>Every stage and agent call, with version, model and prompt, in a trail regulators can review.</a:t>
             </a:r>
           </a:p>
         </p:txBody>
@@ -13465,7 +13465,7 @@
                 </a:solidFill>
                 <a:latin typeface="Arial"/>
               </a:rPr>
-              <a:t>Banks are ready to lend on cash flow, but reading the records by hand costs too much, and the numbers a plain AI writes cannot be traced back to a page.</a:t>
+              <a:t>Banks are ready to lend on cash flow. But manual review costs too much, and numbers from a basic AI prompt cannot be traced to a page.</a:t>
             </a:r>
           </a:p>
         </p:txBody>
@@ -13606,7 +13606,7 @@
                 </a:solidFill>
                 <a:latin typeface="Arial"/>
               </a:rPr>
-              <a:t>Asks for VND 150M of working capital. Her sales are real.</a:t>
+              <a:t>Needs VND 150M in working capital. Her sales are real.</a:t>
             </a:r>
           </a:p>
           <a:p>
@@ -13701,7 +13701,7 @@
                 </a:solidFill>
                 <a:latin typeface="Arial"/>
               </a:rPr>
-              <a:t>Today her file is declined, or priced blind.</a:t>
+              <a:t>Today she is declined, or priced blindly.</a:t>
             </a:r>
           </a:p>
         </p:txBody>
@@ -14338,7 +14338,7 @@
                 </a:solidFill>
                 <a:latin typeface="Arial"/>
               </a:rPr>
-              <a:t>of the numbers in a memo written by a single Gemini prompt point to no page, so the underwriter has to find each one again. That prompt also caught only 15% of the planted risks.</a:t>
+              <a:t>of memo numbers from a single Gemini prompt have no source page. The underwriter must find each one again. That prompt also caught only 15% of the planted risks.</a:t>
             </a:r>
           </a:p>
         </p:txBody>
@@ -14515,7 +14515,7 @@
                 <a:cs typeface="Google Sans Flex Medium"/>
                 <a:sym typeface="Google Sans Flex Medium"/>
               </a:rPr>
-              <a:t>Brief about the idea</a:t>
+              <a:t>The solution</a:t>
             </a:r>
             <a:endParaRPr sz="1600">
               <a:latin typeface="Google Sans Flex Medium"/>
@@ -14591,7 +14591,7 @@
                 </a:solidFill>
                 <a:latin typeface="Arial"/>
               </a:rPr>
-              <a:t>LedgerLens reads the shoebox, shows its work, and argues against itself before a human signs.</a:t>
+              <a:t>LedgerLens reads the records, shows its work and challenges its findings before a human signs.</a:t>
             </a:r>
           </a:p>
         </p:txBody>
@@ -14734,7 +14734,7 @@
                 </a:solidFill>
                 <a:latin typeface="Arial"/>
               </a:rPr>
-              <a:t>ANSWERS: READING COST</a:t>
+              <a:t>CUTS READING COST</a:t>
             </a:r>
           </a:p>
         </p:txBody>
@@ -14769,7 +14769,7 @@
                 </a:solidFill>
                 <a:latin typeface="Arial"/>
               </a:rPr>
-              <a:t>Gemini reads every page. Each value carries document, page and bounding box. Python computes the cash flow. A memo with an unsourced number is rejected and regenerated.</a:t>
+              <a:t>Gemini reads every page. Each value has a document, page and bounding box. Python computes the cash flow. A memo with an unsourced number is rejected and regenerated.</a:t>
             </a:r>
           </a:p>
         </p:txBody>
@@ -15016,7 +15016,7 @@
                 </a:solidFill>
                 <a:latin typeface="Arial"/>
               </a:rPr>
-              <a:t>ANSWERS: AI TRUST</a:t>
+              <a:t>CHECKS AI OUTPUT</a:t>
             </a:r>
           </a:p>
         </p:txBody>
@@ -15051,7 +15051,7 @@
                 </a:solidFill>
                 <a:latin typeface="Arial"/>
               </a:rPr>
-              <a:t>A separate agent that never sees the writer's prompt runs deterministic checks and 12 underwriting questions, then ranks objections with evidence.</a:t>
+              <a:t>A separate agent never sees the writer's prompt. It runs deterministic checks and 12 underwriting questions, then ranks objections with evidence.</a:t>
             </a:r>
           </a:p>
         </p:txBody>
@@ -15298,7 +15298,7 @@
                 </a:solidFill>
                 <a:latin typeface="Arial"/>
               </a:rPr>
-              <a:t>KEEPS: ACCOUNTABILITY</a:t>
+              <a:t>KEEPS ACCOUNTABILITY</a:t>
             </a:r>
           </a:p>
         </p:txBody>
@@ -15333,7 +15333,7 @@
                 </a:solidFill>
                 <a:latin typeface="Arial"/>
               </a:rPr>
-              <a:t>The underwriter accepts or dismisses each objection and signs. Every agent call is logged; decisions re-weight the next run.</a:t>
+              <a:t>The underwriter accepts or dismisses each objection and signs. Every agent call is logged; decisions set priorities for the next run.</a:t>
             </a:r>
           </a:p>
         </p:txBody>
@@ -15407,7 +15407,7 @@
                 </a:solidFill>
                 <a:latin typeface="Arial"/>
               </a:rPr>
-              <a:t>Linh gets the decision and the conditions to meet, in Vietnamese.</a:t>
+              <a:t>Linh receives the decision and its conditions in Vietnamese.</a:t>
             </a:r>
           </a:p>
         </p:txBody>
@@ -15828,7 +15828,7 @@
                 </a:solidFill>
                 <a:latin typeface="Arial"/>
               </a:rPr>
-              <a:t>What changes, and for whom.</a:t>
+              <a:t>What changes for each team.</a:t>
             </a:r>
           </a:p>
         </p:txBody>
@@ -16006,7 +16006,7 @@
                 </a:solidFill>
                 <a:latin typeface="Arial"/>
               </a:rPr>
-              <a:t>USD ~11 → 0.28 per case. Small-ticket loans become worth underwriting.</a:t>
+              <a:t>USD ~11 → 0.28 per case. Small loans become worth underwriting.</a:t>
             </a:r>
           </a:p>
         </p:txBody>
@@ -16184,7 +16184,7 @@
                 </a:solidFill>
                 <a:latin typeface="Arial"/>
               </a:rPr>
-              <a:t>Assessed on the records she already has. A no comes with reasons, in her own language.</a:t>
+              <a:t>Assessed using her existing records. A decline comes with reasons in her own language.</a:t>
             </a:r>
           </a:p>
         </p:txBody>
@@ -16362,7 +16362,7 @@
                 </a:solidFill>
                 <a:latin typeface="Arial"/>
               </a:rPr>
-              <a:t>Every figure points to a page and box, so nothing is re-checked by hand. Planted risks caught: 90% vs 15%.</a:t>
+              <a:t>Every figure links to a page and box, so nothing needs manual re-checking. Planted risks caught: 90% vs 15%.</a:t>
             </a:r>
           </a:p>
         </p:txBody>
@@ -16436,7 +16436,7 @@
                 </a:solidFill>
                 <a:latin typeface="Arial"/>
               </a:rPr>
-              <a:t>The writer and the verifier are separate agents · numbers are computed by code, never generated · every number clicks back to its source line · decisions re-weight the checks</a:t>
+              <a:t>Separate agents write and verify · code computes numbers, never generates them · every number links to its source line · decisions set check priorities</a:t>
             </a:r>
           </a:p>
         </p:txBody>
@@ -16515,7 +16515,7 @@
                 </a:solidFill>
                 <a:latin typeface="Arial"/>
               </a:rPr>
-              <a:t>Manual baseline (45 min at USD 15/h) is a team estimate. A number counts as untraceable when no document and page stand behind it; correctness was not measured. Live gemini-3.8-flash on a small synthetic sample.</a:t>
+              <a:t>The manual baseline (45 min at USD 15/h) is a team estimate. A number is untraceable if it has no source document and page; correctness was not measured. Live gemini-3.8-flash on a small synthetic sample.</a:t>
             </a:r>
           </a:p>
         </p:txBody>
@@ -16684,7 +16684,7 @@
                 <a:cs typeface="Google Sans Flex Medium"/>
                 <a:sym typeface="Google Sans Flex Medium"/>
               </a:rPr>
-              <a:t>List of features offered by the solution</a:t>
+              <a:t>Features</a:t>
             </a:r>
             <a:endParaRPr sz="1600">
               <a:latin typeface="Google Sans Flex Medium"/>
@@ -16725,7 +16725,7 @@
                 </a:solidFill>
                 <a:latin typeface="Arial"/>
               </a:rPr>
-              <a:t>Every feature hangs on one pipeline, and the pipeline ends with a person.</a:t>
+              <a:t>Every feature is part of one pipeline that ends with a human decision.</a:t>
             </a:r>
           </a:p>
         </p:txBody>
@@ -16898,7 +16898,7 @@
                 </a:solidFill>
                 <a:latin typeface="Arial"/>
               </a:rPr>
-              <a:t>PDF, screenshots, photos. Classified and quality-flagged.</a:t>
+              <a:t>PDF, screenshots, photos. Classified, with quality flags.</a:t>
             </a:r>
           </a:p>
         </p:txBody>
@@ -17327,7 +17327,7 @@
                 </a:solidFill>
                 <a:latin typeface="Arial"/>
               </a:rPr>
-              <a:t>Cites catalog figures only. Click one, the source line opens.</a:t>
+              <a:t>Cites only catalog figures. Click to open the source line.</a:t>
             </a:r>
           </a:p>
         </p:txBody>
@@ -17435,7 +17435,7 @@
                 </a:solidFill>
                 <a:latin typeface="Arial"/>
               </a:rPr>
-              <a:t>Battery + 12 checks</a:t>
+              <a:t>Tools + 12 checks</a:t>
             </a:r>
           </a:p>
         </p:txBody>
@@ -17613,7 +17613,7 @@
                 </a:solidFill>
                 <a:latin typeface="Arial"/>
               </a:rPr>
-              <a:t>Accept or dismiss, sign. Audit log. Decisions re-weight the checks.</a:t>
+              <a:t>Accept or dismiss, then sign. Audit log. Decisions guide checks.</a:t>
             </a:r>
           </a:p>
         </p:txBody>
@@ -17721,7 +17721,7 @@
                 </a:solidFill>
                 <a:latin typeface="Arial"/>
               </a:rPr>
-              <a:t>Letter and paper memo</a:t>
+              <a:t>Letter and print memo</a:t>
             </a:r>
           </a:p>
         </p:txBody>
@@ -18203,7 +18203,7 @@
                 <a:cs typeface="Google Sans Flex Medium"/>
                 <a:sym typeface="Google Sans Flex Medium"/>
               </a:rPr>
-              <a:t>Wireframes / Mock diagrams of the proposed solution</a:t>
+              <a:t>The product in use</a:t>
             </a:r>
             <a:endParaRPr sz="1600">
               <a:latin typeface="Google Sans Flex Medium"/>
@@ -18717,7 +18717,7 @@
                 </a:solidFill>
                 <a:latin typeface="Arial"/>
               </a:rPr>
-              <a:t>The computation (sum of 3 credits whose sender matches the account holder) and all 3 source references: pages 2, 4 and 5.</a:t>
+              <a:t>The calculation: sum of 3 credits whose sender matches the account holder. All 3 sources: pages 2, 4 and 5.</a:t>
             </a:r>
           </a:p>
         </p:txBody>
@@ -19029,7 +19029,7 @@
                 <a:cs typeface="Google Sans Flex Medium"/>
                 <a:sym typeface="Google Sans Flex Medium"/>
               </a:rPr>
-              <a:t>Architecture diagram of the proposed solution</a:t>
+              <a:t>Architecture</a:t>
             </a:r>
             <a:endParaRPr sz="1600">
               <a:latin typeface="Google Sans Flex Medium"/>

</xml_diff>

<commit_message>
Deck: Vietnam-first problem headline, YouTube link, clearer submission links
- Problem slide leads with the 8.8% SME loan figure for Vietnam.
- Links slide: clickable GitHub, YouTube and app links, with plain instructions for
  each (where to start in the README, what the video covers, how to try the app).
</commit_message>
<xml_diff>
--- a/presentation/LedgerLens_AI_Builder_Cup_Submission.pptx
+++ b/presentation/LedgerLens_AI_Builder_Cup_Submission.pptx
@@ -12109,7 +12109,7 @@
                 </a:solidFill>
                 <a:latin typeface="Arial"/>
               </a:rPr>
-              <a:t>GitHub public repository</a:t>
+              <a:t>GitHub repository</a:t>
             </a:r>
           </a:p>
         </p:txBody>
@@ -12122,8 +12122,8 @@
         </p:nvSpPr>
         <p:spPr>
           <a:xfrm>
-            <a:off x="457200" y="1783080"/>
-            <a:ext cx="3108960" cy="411480"/>
+            <a:off x="457200" y="1737360"/>
+            <a:ext cx="3200400" cy="457200"/>
           </a:xfrm>
           <a:prstGeom prst="rect">
             <a:avLst/>
@@ -12138,11 +12138,12 @@
           <a:p>
             <a:pPr algn="l"/>
             <a:r>
-              <a:rPr sz="1200" b="0" i="0">
+              <a:rPr sz="1150" b="0" i="0">
                 <a:solidFill>
                   <a:srgbClr val="2A7F8E"/>
                 </a:solidFill>
                 <a:latin typeface="Arial"/>
+                <a:hlinkClick r:id="rId5"/>
               </a:rPr>
               <a:t>github.com/changhyeonnam/ghack</a:t>
             </a:r>
@@ -12179,7 +12180,7 @@
                 </a:solidFill>
                 <a:latin typeface="Arial"/>
               </a:rPr>
-              <a:t>English README, architecture, run instructions, synthetic-data notice, presentation/</a:t>
+              <a:t>Start with the README: what LedgerLens does, the architecture, how to run it locally (no API key needed) and the benchmark. All demo data is synthetic.</a:t>
             </a:r>
           </a:p>
         </p:txBody>
@@ -12259,8 +12260,8 @@
         </p:nvSpPr>
         <p:spPr>
           <a:xfrm>
-            <a:off x="457200" y="2999232"/>
-            <a:ext cx="3108960" cy="411480"/>
+            <a:off x="457200" y="2953512"/>
+            <a:ext cx="3200400" cy="457200"/>
           </a:xfrm>
           <a:prstGeom prst="rect">
             <a:avLst/>
@@ -12275,13 +12276,14 @@
           <a:p>
             <a:pPr algn="l"/>
             <a:r>
-              <a:rPr sz="1200" b="0" i="0">
+              <a:rPr sz="1150" b="0" i="0">
                 <a:solidFill>
                   <a:srgbClr val="2A7F8E"/>
                 </a:solidFill>
                 <a:latin typeface="Arial"/>
-              </a:rPr>
-              <a:t>TBD</a:t>
+                <a:hlinkClick r:id="rId6"/>
+              </a:rPr>
+              <a:t>youtube.com/watch?v=MBwsG0QQAUM</a:t>
             </a:r>
           </a:p>
         </p:txBody>
@@ -12316,7 +12318,7 @@
                 </a:solidFill>
                 <a:latin typeface="Arial"/>
               </a:rPr>
-              <a:t>Problem, how it works, one case end to end (click-to-source, Challenger, decision, letter), benchmark</a:t>
+              <a:t>A three-minute walkthrough: the problem, how it works, one loan file from upload to signed decision, and the benchmark. English narration and subtitles.</a:t>
             </a:r>
           </a:p>
         </p:txBody>
@@ -12383,7 +12385,7 @@
                 </a:solidFill>
                 <a:latin typeface="Arial"/>
               </a:rPr>
-              <a:t>Final product</a:t>
+              <a:t>Live app</a:t>
             </a:r>
           </a:p>
         </p:txBody>
@@ -12396,8 +12398,8 @@
         </p:nvSpPr>
         <p:spPr>
           <a:xfrm>
-            <a:off x="457200" y="4215384"/>
-            <a:ext cx="3108960" cy="411480"/>
+            <a:off x="457200" y="4169663"/>
+            <a:ext cx="3200400" cy="457200"/>
           </a:xfrm>
           <a:prstGeom prst="rect">
             <a:avLst/>
@@ -12412,13 +12414,27 @@
           <a:p>
             <a:pPr algn="l"/>
             <a:r>
-              <a:rPr sz="1200" b="0" i="0">
+              <a:rPr sz="1150" b="0" i="0">
                 <a:solidFill>
                   <a:srgbClr val="2A7F8E"/>
                 </a:solidFill>
                 <a:latin typeface="Arial"/>
-              </a:rPr>
-              <a:t>ledgerlens-api-629502893425.asia-southeast1.run.app</a:t>
+                <a:hlinkClick r:id="rId7"/>
+              </a:rPr>
+              <a:t>ledgerlens-api-629502893425</a:t>
+            </a:r>
+          </a:p>
+          <a:p>
+            <a:pPr algn="l"/>
+            <a:r>
+              <a:rPr sz="1150" b="0" i="0">
+                <a:solidFill>
+                  <a:srgbClr val="2A7F8E"/>
+                </a:solidFill>
+                <a:latin typeface="Arial"/>
+                <a:hlinkClick r:id="rId7"/>
+              </a:rPr>
+              <a:t>.asia-southeast1.run.app</a:t>
             </a:r>
           </a:p>
         </p:txBody>
@@ -12453,7 +12469,7 @@
                 </a:solidFill>
                 <a:latin typeface="Arial"/>
               </a:rPr>
-              <a:t>Cloud Run, live Gemini within a fixed AI budget (on-screen notice when reached). Each browser gets its own copy of the three demo cases, which replay the recorded live run in seconds; visitors' cases are shared read-only. No login</a:t>
+              <a:t>No login. Click Load demo cases, open Reyes Auto Repair and press Run all remaining, then click any number in the memo. New uploads run live Gemini within a fixed budget.</a:t>
             </a:r>
           </a:p>
         </p:txBody>
@@ -12488,7 +12504,7 @@
                 </a:solidFill>
                 <a:latin typeface="Arial"/>
               </a:rPr>
-              <a:t>Links are inserted at submission on 18 October 2026.</a:t>
+              <a:t>All three links are public, and the app stays online through judging.</a:t>
             </a:r>
           </a:p>
         </p:txBody>
@@ -13465,7 +13481,7 @@
                 </a:solidFill>
                 <a:latin typeface="Arial"/>
               </a:rPr>
-              <a:t>Banks are ready to lend on cash flow. But manual review costs too much, and numbers from a basic AI prompt cannot be traced to a page.</a:t>
+              <a:t>Only 8.8% of Vietnam's SMEs have a bank loan. Cash-flow lending stalls: manual review costs too much, and basic AI cannot trace its numbers.</a:t>
             </a:r>
           </a:p>
         </p:txBody>

</xml_diff>